<commit_message>
Adiciona o bloco 34 (MARATÁ - LEVANTA A POEIRA - POLKA DO FRITZ) e o loop de vaneira 86 BPM no ROTA.
Os loops e clicks descem para 35-45, em ordem por tipo e BPM; novo
scripts/cores_blocos.py para recolorir as regions; repertórios VS e
COMPLETO refeitos.

Co-Authored-By: Claude Opus 5.5 <noreply@anthropic.com>
</commit_message>
<xml_diff>
--- a/REPERTÓRIO/Repertório Rota do Chopp - COMPLETO.pptx
+++ b/REPERTÓRIO/Repertório Rota do Chopp - COMPLETO.pptx
@@ -5,7 +5,7 @@
     <p:sldMasterId id="2147483804" r:id="rId1"/>
   </p:sldMasterIdLst>
   <p:handoutMasterIdLst>
-    <p:handoutMasterId r:id="rId108"/>
+    <p:handoutMasterId r:id="rId99"/>
   </p:handoutMasterIdLst>
   <p:sldIdLst>
     <p:sldId id="392" r:id="rId2"/>
@@ -105,15 +105,6 @@
     <p:sldId id="477" r:id="rId96"/>
     <p:sldId id="481" r:id="rId97"/>
     <p:sldId id="482" r:id="rId98"/>
-    <p:sldId id="483" r:id="rId99"/>
-    <p:sldId id="484" r:id="rId100"/>
-    <p:sldId id="485" r:id="rId101"/>
-    <p:sldId id="486" r:id="rId102"/>
-    <p:sldId id="487" r:id="rId103"/>
-    <p:sldId id="488" r:id="rId104"/>
-    <p:sldId id="489" r:id="rId105"/>
-    <p:sldId id="490" r:id="rId106"/>
-    <p:sldId id="491" r:id="rId107"/>
   </p:sldIdLst>
   <p:sldSz cx="12192000" cy="6858000"/>
   <p:notesSz cx="6858000" cy="9144000"/>
@@ -572,7 +563,7 @@
           <a:p>
             <a:fld id="{9F69E24D-9DBE-4DAB-A481-718B3C423892}" type="datetimeFigureOut">
               <a:rPr lang="pt-BR" smtClean="0"/>
-              <a:t>10/10/2026</a:t>
+              <a:t>14/10/2026</a:t>
             </a:fld>
             <a:endParaRPr lang="pt-BR"/>
           </a:p>
@@ -789,7 +780,7 @@
             <a:fld id="{BB0B304C-6D9A-40FB-A8B9-28880A8BB8D2}" type="datetimeFigureOut">
               <a:rPr lang="pt-BR" smtClean="0"/>
               <a:pPr/>
-              <a:t>10/10/2026</a:t>
+              <a:t>14/10/2026</a:t>
             </a:fld>
             <a:endParaRPr lang="pt-BR"/>
           </a:p>
@@ -1078,7 +1069,7 @@
             <a:fld id="{BB0B304C-6D9A-40FB-A8B9-28880A8BB8D2}" type="datetimeFigureOut">
               <a:rPr lang="pt-BR" smtClean="0"/>
               <a:pPr/>
-              <a:t>10/10/2026</a:t>
+              <a:t>14/10/2026</a:t>
             </a:fld>
             <a:endParaRPr lang="pt-BR"/>
           </a:p>
@@ -1272,7 +1263,7 @@
             <a:fld id="{BB0B304C-6D9A-40FB-A8B9-28880A8BB8D2}" type="datetimeFigureOut">
               <a:rPr lang="pt-BR" smtClean="0"/>
               <a:pPr/>
-              <a:t>10/10/2026</a:t>
+              <a:t>14/10/2026</a:t>
             </a:fld>
             <a:endParaRPr lang="pt-BR"/>
           </a:p>
@@ -1535,7 +1526,7 @@
             <a:fld id="{BB0B304C-6D9A-40FB-A8B9-28880A8BB8D2}" type="datetimeFigureOut">
               <a:rPr lang="pt-BR" smtClean="0"/>
               <a:pPr/>
-              <a:t>10/10/2026</a:t>
+              <a:t>14/10/2026</a:t>
             </a:fld>
             <a:endParaRPr lang="pt-BR"/>
           </a:p>
@@ -1961,7 +1952,7 @@
             <a:fld id="{BB0B304C-6D9A-40FB-A8B9-28880A8BB8D2}" type="datetimeFigureOut">
               <a:rPr lang="pt-BR" smtClean="0"/>
               <a:pPr/>
-              <a:t>10/10/2026</a:t>
+              <a:t>14/10/2026</a:t>
             </a:fld>
             <a:endParaRPr lang="pt-BR"/>
           </a:p>
@@ -2509,7 +2500,7 @@
             <a:fld id="{BB0B304C-6D9A-40FB-A8B9-28880A8BB8D2}" type="datetimeFigureOut">
               <a:rPr lang="pt-BR" smtClean="0"/>
               <a:pPr/>
-              <a:t>10/10/2026</a:t>
+              <a:t>14/10/2026</a:t>
             </a:fld>
             <a:endParaRPr lang="pt-BR"/>
           </a:p>
@@ -3351,7 +3342,7 @@
             <a:fld id="{BB0B304C-6D9A-40FB-A8B9-28880A8BB8D2}" type="datetimeFigureOut">
               <a:rPr lang="pt-BR" smtClean="0"/>
               <a:pPr/>
-              <a:t>10/10/2026</a:t>
+              <a:t>14/10/2026</a:t>
             </a:fld>
             <a:endParaRPr lang="pt-BR"/>
           </a:p>
@@ -3523,7 +3514,7 @@
             <a:fld id="{BB0B304C-6D9A-40FB-A8B9-28880A8BB8D2}" type="datetimeFigureOut">
               <a:rPr lang="pt-BR" smtClean="0"/>
               <a:pPr/>
-              <a:t>10/10/2026</a:t>
+              <a:t>14/10/2026</a:t>
             </a:fld>
             <a:endParaRPr lang="pt-BR"/>
           </a:p>
@@ -3709,7 +3700,7 @@
             <a:fld id="{BB0B304C-6D9A-40FB-A8B9-28880A8BB8D2}" type="datetimeFigureOut">
               <a:rPr lang="pt-BR" smtClean="0"/>
               <a:pPr/>
-              <a:t>10/10/2026</a:t>
+              <a:t>14/10/2026</a:t>
             </a:fld>
             <a:endParaRPr lang="pt-BR"/>
           </a:p>
@@ -3881,7 +3872,7 @@
             <a:fld id="{BB0B304C-6D9A-40FB-A8B9-28880A8BB8D2}" type="datetimeFigureOut">
               <a:rPr lang="pt-BR" smtClean="0"/>
               <a:pPr/>
-              <a:t>10/10/2026</a:t>
+              <a:t>14/10/2026</a:t>
             </a:fld>
             <a:endParaRPr lang="pt-BR"/>
           </a:p>
@@ -4131,7 +4122,7 @@
             <a:fld id="{BB0B304C-6D9A-40FB-A8B9-28880A8BB8D2}" type="datetimeFigureOut">
               <a:rPr lang="pt-BR" smtClean="0"/>
               <a:pPr/>
-              <a:t>10/10/2026</a:t>
+              <a:t>14/10/2026</a:t>
             </a:fld>
             <a:endParaRPr lang="pt-BR"/>
           </a:p>
@@ -4370,7 +4361,7 @@
             <a:fld id="{BB0B304C-6D9A-40FB-A8B9-28880A8BB8D2}" type="datetimeFigureOut">
               <a:rPr lang="pt-BR" smtClean="0"/>
               <a:pPr/>
-              <a:t>10/10/2026</a:t>
+              <a:t>14/10/2026</a:t>
             </a:fld>
             <a:endParaRPr lang="pt-BR"/>
           </a:p>
@@ -4745,7 +4736,7 @@
             <a:fld id="{BB0B304C-6D9A-40FB-A8B9-28880A8BB8D2}" type="datetimeFigureOut">
               <a:rPr lang="pt-BR" smtClean="0"/>
               <a:pPr/>
-              <a:t>10/10/2026</a:t>
+              <a:t>14/10/2026</a:t>
             </a:fld>
             <a:endParaRPr lang="pt-BR"/>
           </a:p>
@@ -4865,7 +4856,7 @@
             <a:fld id="{BB0B304C-6D9A-40FB-A8B9-28880A8BB8D2}" type="datetimeFigureOut">
               <a:rPr lang="pt-BR" smtClean="0"/>
               <a:pPr/>
-              <a:t>10/10/2026</a:t>
+              <a:t>14/10/2026</a:t>
             </a:fld>
             <a:endParaRPr lang="pt-BR"/>
           </a:p>
@@ -4962,7 +4953,7 @@
             <a:fld id="{BB0B304C-6D9A-40FB-A8B9-28880A8BB8D2}" type="datetimeFigureOut">
               <a:rPr lang="pt-BR" smtClean="0"/>
               <a:pPr/>
-              <a:t>10/10/2026</a:t>
+              <a:t>14/10/2026</a:t>
             </a:fld>
             <a:endParaRPr lang="pt-BR"/>
           </a:p>
@@ -5215,7 +5206,7 @@
             <a:fld id="{BB0B304C-6D9A-40FB-A8B9-28880A8BB8D2}" type="datetimeFigureOut">
               <a:rPr lang="pt-BR" smtClean="0"/>
               <a:pPr/>
-              <a:t>10/10/2026</a:t>
+              <a:t>14/10/2026</a:t>
             </a:fld>
             <a:endParaRPr lang="pt-BR"/>
           </a:p>
@@ -5504,7 +5495,7 @@
             <a:fld id="{BB0B304C-6D9A-40FB-A8B9-28880A8BB8D2}" type="datetimeFigureOut">
               <a:rPr lang="pt-BR" smtClean="0"/>
               <a:pPr/>
-              <a:t>10/10/2026</a:t>
+              <a:t>14/10/2026</a:t>
             </a:fld>
             <a:endParaRPr lang="pt-BR"/>
           </a:p>
@@ -5719,7 +5710,7 @@
             <a:fld id="{BB0B304C-6D9A-40FB-A8B9-28880A8BB8D2}" type="datetimeFigureOut">
               <a:rPr lang="pt-BR" smtClean="0"/>
               <a:pPr/>
-              <a:t>10/10/2026</a:t>
+              <a:t>14/10/2026</a:t>
             </a:fld>
             <a:endParaRPr lang="pt-BR"/>
           </a:p>
@@ -6564,699 +6555,6 @@
 </p:sld>
 </file>
 
-<file path=ppt/slides/slide100.xml><?xml version="1.0" encoding="utf-8"?>
-<p:sld xmlns:a="http://schemas.openxmlformats.org/drawingml/2006/main" xmlns:r="http://schemas.openxmlformats.org/officeDocument/2006/relationships" xmlns:p="http://schemas.openxmlformats.org/presentationml/2006/main">
-  <p:cSld>
-    <p:spTree>
-      <p:nvGrpSpPr>
-        <p:cNvPr id="1" name=""/>
-        <p:cNvGrpSpPr/>
-        <p:nvPr/>
-      </p:nvGrpSpPr>
-      <p:grpSpPr>
-        <a:xfrm>
-          <a:off x="0" y="0"/>
-          <a:ext cx="0" cy="0"/>
-          <a:chOff x="0" y="0"/>
-          <a:chExt cx="0" cy="0"/>
-        </a:xfrm>
-      </p:grpSpPr>
-      <p:sp>
-        <p:nvSpPr>
-          <p:cNvPr id="3" name="Espaço Reservado para Conteúdo 2">
-            <a:extLst>
-              <a:ext uri="{FF2B5EF4-FFF2-40B4-BE49-F238E27FC236}">
-                <a16:creationId xmlns:a16="http://schemas.microsoft.com/office/drawing/2014/main" id="{7C70BAA2-54A1-BAA9-5EF9-9F93F22AE700}"/>
-              </a:ext>
-            </a:extLst>
-          </p:cNvPr>
-          <p:cNvSpPr>
-            <a:spLocks noGrp="1"/>
-          </p:cNvSpPr>
-          <p:nvPr>
-            <p:ph idx="1"/>
-          </p:nvPr>
-        </p:nvSpPr>
-        <p:spPr>
-          <a:xfrm>
-            <a:off x="10509" y="-3937"/>
-            <a:ext cx="12181491" cy="6861937"/>
-          </a:xfrm>
-        </p:spPr>
-        <p:txBody>
-          <a:bodyPr>
-            <a:noAutofit/>
-          </a:bodyPr>
-          <a:lstStyle/>
-          <a:p>
-            <a:pPr algn="ctr">
-              <a:lnSpc>
-                <a:spcPct val="100000"/>
-              </a:lnSpc>
-              <a:buNone/>
-            </a:pPr>
-            <a:r>
-              <a:rPr lang="en-US" sz="8800" dirty="0">
-                <a:solidFill>
-                  <a:srgbClr val="FF0000"/>
-                </a:solidFill>
-                <a:cs typeface="Arial" panose="020B0604020202020204" pitchFamily="34" charset="0"/>
-              </a:rPr>
-              <a:t>VS BLOCO 37</a:t>
-            </a:r>
-          </a:p>
-          <a:p>
-            <a:pPr marL="36000" indent="-252000" algn="ctr">
-              <a:lnSpc>
-                <a:spcPct val="100000"/>
-              </a:lnSpc>
-              <a:spcBef>
-                <a:spcPts val="0"/>
-              </a:spcBef>
-              <a:buNone/>
-            </a:pPr>
-            <a:r>
-              <a:rPr lang="pt-BR" sz="7200" dirty="0"/>
-              <a:t>Loop de Vaneira </a:t>
-            </a:r>
-            <a:r>
-              <a:rPr lang="pt-BR" sz="7200" dirty="0">
-                <a:solidFill>
-                  <a:srgbClr val="FF0000"/>
-                </a:solidFill>
-              </a:rPr>
-              <a:t>97 BPM</a:t>
-            </a:r>
-          </a:p>
-        </p:txBody>
-      </p:sp>
-    </p:spTree>
-    <p:extLst>
-      <p:ext uri="{BB962C8B-B14F-4D97-AF65-F5344CB8AC3E}">
-        <p14:creationId xmlns:p14="http://schemas.microsoft.com/office/powerpoint/2010/main" val="1878343145"/>
-      </p:ext>
-    </p:extLst>
-  </p:cSld>
-  <p:clrMapOvr>
-    <a:masterClrMapping/>
-  </p:clrMapOvr>
-</p:sld>
-</file>
-
-<file path=ppt/slides/slide101.xml><?xml version="1.0" encoding="utf-8"?>
-<p:sld xmlns:a="http://schemas.openxmlformats.org/drawingml/2006/main" xmlns:r="http://schemas.openxmlformats.org/officeDocument/2006/relationships" xmlns:p="http://schemas.openxmlformats.org/presentationml/2006/main">
-  <p:cSld>
-    <p:spTree>
-      <p:nvGrpSpPr>
-        <p:cNvPr id="1" name=""/>
-        <p:cNvGrpSpPr/>
-        <p:nvPr/>
-      </p:nvGrpSpPr>
-      <p:grpSpPr>
-        <a:xfrm>
-          <a:off x="0" y="0"/>
-          <a:ext cx="0" cy="0"/>
-          <a:chOff x="0" y="0"/>
-          <a:chExt cx="0" cy="0"/>
-        </a:xfrm>
-      </p:grpSpPr>
-      <p:sp>
-        <p:nvSpPr>
-          <p:cNvPr id="3" name="Espaço Reservado para Conteúdo 2">
-            <a:extLst>
-              <a:ext uri="{FF2B5EF4-FFF2-40B4-BE49-F238E27FC236}">
-                <a16:creationId xmlns:a16="http://schemas.microsoft.com/office/drawing/2014/main" id="{7C70BAA2-54A1-BAA9-5EF9-9F93F22AE700}"/>
-              </a:ext>
-            </a:extLst>
-          </p:cNvPr>
-          <p:cNvSpPr>
-            <a:spLocks noGrp="1"/>
-          </p:cNvSpPr>
-          <p:nvPr>
-            <p:ph idx="1"/>
-          </p:nvPr>
-        </p:nvSpPr>
-        <p:spPr>
-          <a:xfrm>
-            <a:off x="10509" y="-3937"/>
-            <a:ext cx="12181491" cy="6861937"/>
-          </a:xfrm>
-        </p:spPr>
-        <p:txBody>
-          <a:bodyPr>
-            <a:noAutofit/>
-          </a:bodyPr>
-          <a:lstStyle/>
-          <a:p>
-            <a:pPr algn="ctr">
-              <a:lnSpc>
-                <a:spcPct val="100000"/>
-              </a:lnSpc>
-              <a:buNone/>
-            </a:pPr>
-            <a:r>
-              <a:rPr lang="en-US" sz="8800" dirty="0">
-                <a:solidFill>
-                  <a:srgbClr val="FF0000"/>
-                </a:solidFill>
-                <a:cs typeface="Arial" panose="020B0604020202020204" pitchFamily="34" charset="0"/>
-              </a:rPr>
-              <a:t>VS BLOCO 38</a:t>
-            </a:r>
-          </a:p>
-          <a:p>
-            <a:pPr marL="36000" indent="-252000" algn="ctr">
-              <a:lnSpc>
-                <a:spcPct val="100000"/>
-              </a:lnSpc>
-              <a:spcBef>
-                <a:spcPts val="0"/>
-              </a:spcBef>
-              <a:buNone/>
-            </a:pPr>
-            <a:r>
-              <a:rPr lang="pt-BR" sz="7200" dirty="0"/>
-              <a:t>Loop de Marcha </a:t>
-            </a:r>
-            <a:r>
-              <a:rPr lang="pt-BR" sz="7200" dirty="0">
-                <a:solidFill>
-                  <a:srgbClr val="FF0000"/>
-                </a:solidFill>
-              </a:rPr>
-              <a:t>135 BPM</a:t>
-            </a:r>
-          </a:p>
-        </p:txBody>
-      </p:sp>
-    </p:spTree>
-    <p:extLst>
-      <p:ext uri="{BB962C8B-B14F-4D97-AF65-F5344CB8AC3E}">
-        <p14:creationId xmlns:p14="http://schemas.microsoft.com/office/powerpoint/2010/main" val="141995160"/>
-      </p:ext>
-    </p:extLst>
-  </p:cSld>
-  <p:clrMapOvr>
-    <a:masterClrMapping/>
-  </p:clrMapOvr>
-</p:sld>
-</file>
-
-<file path=ppt/slides/slide102.xml><?xml version="1.0" encoding="utf-8"?>
-<p:sld xmlns:a="http://schemas.openxmlformats.org/drawingml/2006/main" xmlns:r="http://schemas.openxmlformats.org/officeDocument/2006/relationships" xmlns:p="http://schemas.openxmlformats.org/presentationml/2006/main">
-  <p:cSld>
-    <p:spTree>
-      <p:nvGrpSpPr>
-        <p:cNvPr id="1" name=""/>
-        <p:cNvGrpSpPr/>
-        <p:nvPr/>
-      </p:nvGrpSpPr>
-      <p:grpSpPr>
-        <a:xfrm>
-          <a:off x="0" y="0"/>
-          <a:ext cx="0" cy="0"/>
-          <a:chOff x="0" y="0"/>
-          <a:chExt cx="0" cy="0"/>
-        </a:xfrm>
-      </p:grpSpPr>
-      <p:sp>
-        <p:nvSpPr>
-          <p:cNvPr id="3" name="Espaço Reservado para Conteúdo 2">
-            <a:extLst>
-              <a:ext uri="{FF2B5EF4-FFF2-40B4-BE49-F238E27FC236}">
-                <a16:creationId xmlns:a16="http://schemas.microsoft.com/office/drawing/2014/main" id="{7C70BAA2-54A1-BAA9-5EF9-9F93F22AE700}"/>
-              </a:ext>
-            </a:extLst>
-          </p:cNvPr>
-          <p:cNvSpPr>
-            <a:spLocks noGrp="1"/>
-          </p:cNvSpPr>
-          <p:nvPr>
-            <p:ph idx="1"/>
-          </p:nvPr>
-        </p:nvSpPr>
-        <p:spPr>
-          <a:xfrm>
-            <a:off x="10509" y="-3937"/>
-            <a:ext cx="12181491" cy="6861937"/>
-          </a:xfrm>
-        </p:spPr>
-        <p:txBody>
-          <a:bodyPr>
-            <a:noAutofit/>
-          </a:bodyPr>
-          <a:lstStyle/>
-          <a:p>
-            <a:pPr algn="ctr">
-              <a:lnSpc>
-                <a:spcPct val="100000"/>
-              </a:lnSpc>
-              <a:buNone/>
-            </a:pPr>
-            <a:r>
-              <a:rPr lang="en-US" sz="8800" dirty="0">
-                <a:solidFill>
-                  <a:srgbClr val="FF0000"/>
-                </a:solidFill>
-                <a:cs typeface="Arial" panose="020B0604020202020204" pitchFamily="34" charset="0"/>
-              </a:rPr>
-              <a:t>VS BLOCO 39</a:t>
-            </a:r>
-          </a:p>
-          <a:p>
-            <a:pPr marL="36000" indent="-252000" algn="ctr">
-              <a:lnSpc>
-                <a:spcPct val="100000"/>
-              </a:lnSpc>
-              <a:spcBef>
-                <a:spcPts val="0"/>
-              </a:spcBef>
-              <a:buNone/>
-            </a:pPr>
-            <a:r>
-              <a:rPr lang="pt-BR" sz="7200" dirty="0"/>
-              <a:t>Loop de Marcha </a:t>
-            </a:r>
-            <a:r>
-              <a:rPr lang="pt-BR" sz="7200" dirty="0">
-                <a:solidFill>
-                  <a:srgbClr val="FF0000"/>
-                </a:solidFill>
-              </a:rPr>
-              <a:t>138 BPM</a:t>
-            </a:r>
-          </a:p>
-        </p:txBody>
-      </p:sp>
-    </p:spTree>
-    <p:extLst>
-      <p:ext uri="{BB962C8B-B14F-4D97-AF65-F5344CB8AC3E}">
-        <p14:creationId xmlns:p14="http://schemas.microsoft.com/office/powerpoint/2010/main" val="3483726967"/>
-      </p:ext>
-    </p:extLst>
-  </p:cSld>
-  <p:clrMapOvr>
-    <a:masterClrMapping/>
-  </p:clrMapOvr>
-</p:sld>
-</file>
-
-<file path=ppt/slides/slide103.xml><?xml version="1.0" encoding="utf-8"?>
-<p:sld xmlns:a="http://schemas.openxmlformats.org/drawingml/2006/main" xmlns:r="http://schemas.openxmlformats.org/officeDocument/2006/relationships" xmlns:p="http://schemas.openxmlformats.org/presentationml/2006/main">
-  <p:cSld>
-    <p:spTree>
-      <p:nvGrpSpPr>
-        <p:cNvPr id="1" name=""/>
-        <p:cNvGrpSpPr/>
-        <p:nvPr/>
-      </p:nvGrpSpPr>
-      <p:grpSpPr>
-        <a:xfrm>
-          <a:off x="0" y="0"/>
-          <a:ext cx="0" cy="0"/>
-          <a:chOff x="0" y="0"/>
-          <a:chExt cx="0" cy="0"/>
-        </a:xfrm>
-      </p:grpSpPr>
-      <p:sp>
-        <p:nvSpPr>
-          <p:cNvPr id="3" name="Espaço Reservado para Conteúdo 2">
-            <a:extLst>
-              <a:ext uri="{FF2B5EF4-FFF2-40B4-BE49-F238E27FC236}">
-                <a16:creationId xmlns:a16="http://schemas.microsoft.com/office/drawing/2014/main" id="{7C70BAA2-54A1-BAA9-5EF9-9F93F22AE700}"/>
-              </a:ext>
-            </a:extLst>
-          </p:cNvPr>
-          <p:cNvSpPr>
-            <a:spLocks noGrp="1"/>
-          </p:cNvSpPr>
-          <p:nvPr>
-            <p:ph idx="1"/>
-          </p:nvPr>
-        </p:nvSpPr>
-        <p:spPr>
-          <a:xfrm>
-            <a:off x="10509" y="-3937"/>
-            <a:ext cx="12181491" cy="6861937"/>
-          </a:xfrm>
-        </p:spPr>
-        <p:txBody>
-          <a:bodyPr>
-            <a:noAutofit/>
-          </a:bodyPr>
-          <a:lstStyle/>
-          <a:p>
-            <a:pPr algn="ctr">
-              <a:lnSpc>
-                <a:spcPct val="100000"/>
-              </a:lnSpc>
-              <a:buNone/>
-            </a:pPr>
-            <a:r>
-              <a:rPr lang="en-US" sz="8800" dirty="0">
-                <a:solidFill>
-                  <a:srgbClr val="FF0000"/>
-                </a:solidFill>
-                <a:cs typeface="Arial" panose="020B0604020202020204" pitchFamily="34" charset="0"/>
-              </a:rPr>
-              <a:t>VS BLOCO 40</a:t>
-            </a:r>
-          </a:p>
-          <a:p>
-            <a:pPr marL="36000" indent="-252000" algn="ctr">
-              <a:lnSpc>
-                <a:spcPct val="100000"/>
-              </a:lnSpc>
-              <a:spcBef>
-                <a:spcPts val="0"/>
-              </a:spcBef>
-              <a:buNone/>
-            </a:pPr>
-            <a:r>
-              <a:rPr lang="pt-BR" sz="7200" dirty="0"/>
-              <a:t>Loop de Marcha </a:t>
-            </a:r>
-            <a:r>
-              <a:rPr lang="pt-BR" sz="7200" dirty="0">
-                <a:solidFill>
-                  <a:srgbClr val="FF0000"/>
-                </a:solidFill>
-              </a:rPr>
-              <a:t>140 BPM</a:t>
-            </a:r>
-          </a:p>
-        </p:txBody>
-      </p:sp>
-    </p:spTree>
-    <p:extLst>
-      <p:ext uri="{BB962C8B-B14F-4D97-AF65-F5344CB8AC3E}">
-        <p14:creationId xmlns:p14="http://schemas.microsoft.com/office/powerpoint/2010/main" val="951932075"/>
-      </p:ext>
-    </p:extLst>
-  </p:cSld>
-  <p:clrMapOvr>
-    <a:masterClrMapping/>
-  </p:clrMapOvr>
-</p:sld>
-</file>
-
-<file path=ppt/slides/slide104.xml><?xml version="1.0" encoding="utf-8"?>
-<p:sld xmlns:a="http://schemas.openxmlformats.org/drawingml/2006/main" xmlns:r="http://schemas.openxmlformats.org/officeDocument/2006/relationships" xmlns:p="http://schemas.openxmlformats.org/presentationml/2006/main">
-  <p:cSld>
-    <p:spTree>
-      <p:nvGrpSpPr>
-        <p:cNvPr id="1" name=""/>
-        <p:cNvGrpSpPr/>
-        <p:nvPr/>
-      </p:nvGrpSpPr>
-      <p:grpSpPr>
-        <a:xfrm>
-          <a:off x="0" y="0"/>
-          <a:ext cx="0" cy="0"/>
-          <a:chOff x="0" y="0"/>
-          <a:chExt cx="0" cy="0"/>
-        </a:xfrm>
-      </p:grpSpPr>
-      <p:sp>
-        <p:nvSpPr>
-          <p:cNvPr id="3" name="Espaço Reservado para Conteúdo 2">
-            <a:extLst>
-              <a:ext uri="{FF2B5EF4-FFF2-40B4-BE49-F238E27FC236}">
-                <a16:creationId xmlns:a16="http://schemas.microsoft.com/office/drawing/2014/main" id="{7C70BAA2-54A1-BAA9-5EF9-9F93F22AE700}"/>
-              </a:ext>
-            </a:extLst>
-          </p:cNvPr>
-          <p:cNvSpPr>
-            <a:spLocks noGrp="1"/>
-          </p:cNvSpPr>
-          <p:nvPr>
-            <p:ph idx="1"/>
-          </p:nvPr>
-        </p:nvSpPr>
-        <p:spPr>
-          <a:xfrm>
-            <a:off x="10509" y="-3937"/>
-            <a:ext cx="12181491" cy="6861937"/>
-          </a:xfrm>
-        </p:spPr>
-        <p:txBody>
-          <a:bodyPr>
-            <a:noAutofit/>
-          </a:bodyPr>
-          <a:lstStyle/>
-          <a:p>
-            <a:pPr algn="ctr">
-              <a:lnSpc>
-                <a:spcPct val="100000"/>
-              </a:lnSpc>
-              <a:buNone/>
-            </a:pPr>
-            <a:r>
-              <a:rPr lang="en-US" sz="8800" dirty="0">
-                <a:solidFill>
-                  <a:srgbClr val="FF0000"/>
-                </a:solidFill>
-                <a:cs typeface="Arial" panose="020B0604020202020204" pitchFamily="34" charset="0"/>
-              </a:rPr>
-              <a:t>VS BLOCO 41</a:t>
-            </a:r>
-          </a:p>
-          <a:p>
-            <a:pPr marL="36000" indent="-252000" algn="ctr">
-              <a:lnSpc>
-                <a:spcPct val="100000"/>
-              </a:lnSpc>
-              <a:spcBef>
-                <a:spcPts val="0"/>
-              </a:spcBef>
-              <a:buNone/>
-            </a:pPr>
-            <a:r>
-              <a:rPr lang="pt-BR" sz="7200" dirty="0"/>
-              <a:t>Click de Marcha </a:t>
-            </a:r>
-            <a:r>
-              <a:rPr lang="pt-BR" sz="7200" dirty="0">
-                <a:solidFill>
-                  <a:srgbClr val="FF0000"/>
-                </a:solidFill>
-              </a:rPr>
-              <a:t>135 BPM</a:t>
-            </a:r>
-          </a:p>
-        </p:txBody>
-      </p:sp>
-    </p:spTree>
-    <p:extLst>
-      <p:ext uri="{BB962C8B-B14F-4D97-AF65-F5344CB8AC3E}">
-        <p14:creationId xmlns:p14="http://schemas.microsoft.com/office/powerpoint/2010/main" val="4221678744"/>
-      </p:ext>
-    </p:extLst>
-  </p:cSld>
-  <p:clrMapOvr>
-    <a:masterClrMapping/>
-  </p:clrMapOvr>
-</p:sld>
-</file>
-
-<file path=ppt/slides/slide105.xml><?xml version="1.0" encoding="utf-8"?>
-<p:sld xmlns:a="http://schemas.openxmlformats.org/drawingml/2006/main" xmlns:r="http://schemas.openxmlformats.org/officeDocument/2006/relationships" xmlns:p="http://schemas.openxmlformats.org/presentationml/2006/main">
-  <p:cSld>
-    <p:spTree>
-      <p:nvGrpSpPr>
-        <p:cNvPr id="1" name=""/>
-        <p:cNvGrpSpPr/>
-        <p:nvPr/>
-      </p:nvGrpSpPr>
-      <p:grpSpPr>
-        <a:xfrm>
-          <a:off x="0" y="0"/>
-          <a:ext cx="0" cy="0"/>
-          <a:chOff x="0" y="0"/>
-          <a:chExt cx="0" cy="0"/>
-        </a:xfrm>
-      </p:grpSpPr>
-      <p:sp>
-        <p:nvSpPr>
-          <p:cNvPr id="3" name="Espaço Reservado para Conteúdo 2">
-            <a:extLst>
-              <a:ext uri="{FF2B5EF4-FFF2-40B4-BE49-F238E27FC236}">
-                <a16:creationId xmlns:a16="http://schemas.microsoft.com/office/drawing/2014/main" id="{7C70BAA2-54A1-BAA9-5EF9-9F93F22AE700}"/>
-              </a:ext>
-            </a:extLst>
-          </p:cNvPr>
-          <p:cNvSpPr>
-            <a:spLocks noGrp="1"/>
-          </p:cNvSpPr>
-          <p:nvPr>
-            <p:ph idx="1"/>
-          </p:nvPr>
-        </p:nvSpPr>
-        <p:spPr>
-          <a:xfrm>
-            <a:off x="10509" y="-3937"/>
-            <a:ext cx="12181491" cy="6861937"/>
-          </a:xfrm>
-        </p:spPr>
-        <p:txBody>
-          <a:bodyPr>
-            <a:noAutofit/>
-          </a:bodyPr>
-          <a:lstStyle/>
-          <a:p>
-            <a:pPr algn="ctr">
-              <a:lnSpc>
-                <a:spcPct val="100000"/>
-              </a:lnSpc>
-              <a:buNone/>
-            </a:pPr>
-            <a:r>
-              <a:rPr lang="en-US" sz="8800" dirty="0">
-                <a:solidFill>
-                  <a:srgbClr val="FF0000"/>
-                </a:solidFill>
-                <a:cs typeface="Arial" panose="020B0604020202020204" pitchFamily="34" charset="0"/>
-              </a:rPr>
-              <a:t>VS BLOCO 42</a:t>
-            </a:r>
-          </a:p>
-          <a:p>
-            <a:pPr marL="36000" indent="-252000" algn="ctr">
-              <a:lnSpc>
-                <a:spcPct val="100000"/>
-              </a:lnSpc>
-              <a:spcBef>
-                <a:spcPts val="0"/>
-              </a:spcBef>
-              <a:buNone/>
-            </a:pPr>
-            <a:r>
-              <a:rPr lang="pt-BR" sz="7200" dirty="0"/>
-              <a:t>Click de Marcha </a:t>
-            </a:r>
-            <a:r>
-              <a:rPr lang="pt-BR" sz="7200" dirty="0">
-                <a:solidFill>
-                  <a:srgbClr val="FF0000"/>
-                </a:solidFill>
-              </a:rPr>
-              <a:t>138 BPM</a:t>
-            </a:r>
-          </a:p>
-        </p:txBody>
-      </p:sp>
-    </p:spTree>
-    <p:extLst>
-      <p:ext uri="{BB962C8B-B14F-4D97-AF65-F5344CB8AC3E}">
-        <p14:creationId xmlns:p14="http://schemas.microsoft.com/office/powerpoint/2010/main" val="3123579458"/>
-      </p:ext>
-    </p:extLst>
-  </p:cSld>
-  <p:clrMapOvr>
-    <a:masterClrMapping/>
-  </p:clrMapOvr>
-</p:sld>
-</file>
-
-<file path=ppt/slides/slide106.xml><?xml version="1.0" encoding="utf-8"?>
-<p:sld xmlns:a="http://schemas.openxmlformats.org/drawingml/2006/main" xmlns:r="http://schemas.openxmlformats.org/officeDocument/2006/relationships" xmlns:p="http://schemas.openxmlformats.org/presentationml/2006/main">
-  <p:cSld>
-    <p:spTree>
-      <p:nvGrpSpPr>
-        <p:cNvPr id="1" name=""/>
-        <p:cNvGrpSpPr/>
-        <p:nvPr/>
-      </p:nvGrpSpPr>
-      <p:grpSpPr>
-        <a:xfrm>
-          <a:off x="0" y="0"/>
-          <a:ext cx="0" cy="0"/>
-          <a:chOff x="0" y="0"/>
-          <a:chExt cx="0" cy="0"/>
-        </a:xfrm>
-      </p:grpSpPr>
-      <p:sp>
-        <p:nvSpPr>
-          <p:cNvPr id="3" name="Espaço Reservado para Conteúdo 2">
-            <a:extLst>
-              <a:ext uri="{FF2B5EF4-FFF2-40B4-BE49-F238E27FC236}">
-                <a16:creationId xmlns:a16="http://schemas.microsoft.com/office/drawing/2014/main" id="{7C70BAA2-54A1-BAA9-5EF9-9F93F22AE700}"/>
-              </a:ext>
-            </a:extLst>
-          </p:cNvPr>
-          <p:cNvSpPr>
-            <a:spLocks noGrp="1"/>
-          </p:cNvSpPr>
-          <p:nvPr>
-            <p:ph idx="1"/>
-          </p:nvPr>
-        </p:nvSpPr>
-        <p:spPr>
-          <a:xfrm>
-            <a:off x="10509" y="-3937"/>
-            <a:ext cx="12181491" cy="6861937"/>
-          </a:xfrm>
-        </p:spPr>
-        <p:txBody>
-          <a:bodyPr>
-            <a:noAutofit/>
-          </a:bodyPr>
-          <a:lstStyle/>
-          <a:p>
-            <a:pPr algn="ctr">
-              <a:lnSpc>
-                <a:spcPct val="100000"/>
-              </a:lnSpc>
-              <a:buNone/>
-            </a:pPr>
-            <a:r>
-              <a:rPr lang="en-US" sz="8800" dirty="0">
-                <a:solidFill>
-                  <a:srgbClr val="FF0000"/>
-                </a:solidFill>
-                <a:cs typeface="Arial" panose="020B0604020202020204" pitchFamily="34" charset="0"/>
-              </a:rPr>
-              <a:t>VS BLOCO 43</a:t>
-            </a:r>
-          </a:p>
-          <a:p>
-            <a:pPr marL="36000" indent="-252000" algn="ctr">
-              <a:lnSpc>
-                <a:spcPct val="100000"/>
-              </a:lnSpc>
-              <a:spcBef>
-                <a:spcPts val="0"/>
-              </a:spcBef>
-              <a:buNone/>
-            </a:pPr>
-            <a:r>
-              <a:rPr lang="pt-BR" sz="7200" dirty="0"/>
-              <a:t>Click de Marcha </a:t>
-            </a:r>
-            <a:r>
-              <a:rPr lang="pt-BR" sz="7200" dirty="0">
-                <a:solidFill>
-                  <a:srgbClr val="FF0000"/>
-                </a:solidFill>
-              </a:rPr>
-              <a:t>140 BPM</a:t>
-            </a:r>
-          </a:p>
-        </p:txBody>
-      </p:sp>
-    </p:spTree>
-    <p:extLst>
-      <p:ext uri="{BB962C8B-B14F-4D97-AF65-F5344CB8AC3E}">
-        <p14:creationId xmlns:p14="http://schemas.microsoft.com/office/powerpoint/2010/main" val="2730158660"/>
-      </p:ext>
-    </p:extLst>
-  </p:cSld>
-  <p:clrMapOvr>
-    <a:masterClrMapping/>
-  </p:clrMapOvr>
-</p:sld>
-</file>
-
 <file path=ppt/slides/slide11.xml><?xml version="1.0" encoding="utf-8"?>
 <p:sld xmlns:a="http://schemas.openxmlformats.org/drawingml/2006/main" xmlns:r="http://schemas.openxmlformats.org/officeDocument/2006/relationships" xmlns:p="http://schemas.openxmlformats.org/presentationml/2006/main">
   <p:cSld>
@@ -15550,7 +14848,7 @@
     </p:spTree>
     <p:extLst>
       <p:ext uri="{BB962C8B-B14F-4D97-AF65-F5344CB8AC3E}">
-        <p14:creationId xmlns:p14="http://schemas.microsoft.com/office/powerpoint/2010/main" val="1171173955"/>
+        <p14:creationId xmlns:p14="http://schemas.microsoft.com/office/powerpoint/2010/main" val="1762806921"/>
       </p:ext>
     </p:extLst>
   </p:cSld>
@@ -15714,7 +15012,7 @@
     </p:spTree>
     <p:extLst>
       <p:ext uri="{BB962C8B-B14F-4D97-AF65-F5344CB8AC3E}">
-        <p14:creationId xmlns:p14="http://schemas.microsoft.com/office/powerpoint/2010/main" val="1450154134"/>
+        <p14:creationId xmlns:p14="http://schemas.microsoft.com/office/powerpoint/2010/main" val="1999328298"/>
       </p:ext>
     </p:extLst>
   </p:cSld>
@@ -15956,7 +15254,7 @@
     </p:spTree>
     <p:extLst>
       <p:ext uri="{BB962C8B-B14F-4D97-AF65-F5344CB8AC3E}">
-        <p14:creationId xmlns:p14="http://schemas.microsoft.com/office/powerpoint/2010/main" val="1633259188"/>
+        <p14:creationId xmlns:p14="http://schemas.microsoft.com/office/powerpoint/2010/main" val="2054186895"/>
       </p:ext>
     </p:extLst>
   </p:cSld>
@@ -16121,7 +15419,7 @@
     </p:spTree>
     <p:extLst>
       <p:ext uri="{BB962C8B-B14F-4D97-AF65-F5344CB8AC3E}">
-        <p14:creationId xmlns:p14="http://schemas.microsoft.com/office/powerpoint/2010/main" val="2799376381"/>
+        <p14:creationId xmlns:p14="http://schemas.microsoft.com/office/powerpoint/2010/main" val="610305201"/>
       </p:ext>
     </p:extLst>
   </p:cSld>
@@ -16299,7 +15597,7 @@
     </p:spTree>
     <p:extLst>
       <p:ext uri="{BB962C8B-B14F-4D97-AF65-F5344CB8AC3E}">
-        <p14:creationId xmlns:p14="http://schemas.microsoft.com/office/powerpoint/2010/main" val="4061061639"/>
+        <p14:creationId xmlns:p14="http://schemas.microsoft.com/office/powerpoint/2010/main" val="3270442868"/>
       </p:ext>
     </p:extLst>
   </p:cSld>
@@ -16425,7 +15723,7 @@
     </p:spTree>
     <p:extLst>
       <p:ext uri="{BB962C8B-B14F-4D97-AF65-F5344CB8AC3E}">
-        <p14:creationId xmlns:p14="http://schemas.microsoft.com/office/powerpoint/2010/main" val="4148550901"/>
+        <p14:creationId xmlns:p14="http://schemas.microsoft.com/office/powerpoint/2010/main" val="1720707557"/>
       </p:ext>
     </p:extLst>
   </p:cSld>
@@ -16713,7 +16011,7 @@
     </p:spTree>
     <p:extLst>
       <p:ext uri="{BB962C8B-B14F-4D97-AF65-F5344CB8AC3E}">
-        <p14:creationId xmlns:p14="http://schemas.microsoft.com/office/powerpoint/2010/main" val="324425334"/>
+        <p14:creationId xmlns:p14="http://schemas.microsoft.com/office/powerpoint/2010/main" val="2796686526"/>
       </p:ext>
     </p:extLst>
   </p:cSld>
@@ -16839,7 +16137,7 @@
     </p:spTree>
     <p:extLst>
       <p:ext uri="{BB962C8B-B14F-4D97-AF65-F5344CB8AC3E}">
-        <p14:creationId xmlns:p14="http://schemas.microsoft.com/office/powerpoint/2010/main" val="1973646698"/>
+        <p14:creationId xmlns:p14="http://schemas.microsoft.com/office/powerpoint/2010/main" val="69810962"/>
       </p:ext>
     </p:extLst>
   </p:cSld>
@@ -17043,7 +16341,7 @@
     </p:spTree>
     <p:extLst>
       <p:ext uri="{BB962C8B-B14F-4D97-AF65-F5344CB8AC3E}">
-        <p14:creationId xmlns:p14="http://schemas.microsoft.com/office/powerpoint/2010/main" val="1644800925"/>
+        <p14:creationId xmlns:p14="http://schemas.microsoft.com/office/powerpoint/2010/main" val="2963673977"/>
       </p:ext>
     </p:extLst>
   </p:cSld>
@@ -17184,7 +16482,7 @@
     </p:spTree>
     <p:extLst>
       <p:ext uri="{BB962C8B-B14F-4D97-AF65-F5344CB8AC3E}">
-        <p14:creationId xmlns:p14="http://schemas.microsoft.com/office/powerpoint/2010/main" val="3765200905"/>
+        <p14:creationId xmlns:p14="http://schemas.microsoft.com/office/powerpoint/2010/main" val="1018213711"/>
       </p:ext>
     </p:extLst>
   </p:cSld>
@@ -17370,7 +16668,7 @@
     </p:spTree>
     <p:extLst>
       <p:ext uri="{BB962C8B-B14F-4D97-AF65-F5344CB8AC3E}">
-        <p14:creationId xmlns:p14="http://schemas.microsoft.com/office/powerpoint/2010/main" val="2380486740"/>
+        <p14:creationId xmlns:p14="http://schemas.microsoft.com/office/powerpoint/2010/main" val="1127717112"/>
       </p:ext>
     </p:extLst>
   </p:cSld>
@@ -17524,7 +16822,7 @@
     </p:spTree>
     <p:extLst>
       <p:ext uri="{BB962C8B-B14F-4D97-AF65-F5344CB8AC3E}">
-        <p14:creationId xmlns:p14="http://schemas.microsoft.com/office/powerpoint/2010/main" val="724938429"/>
+        <p14:creationId xmlns:p14="http://schemas.microsoft.com/office/powerpoint/2010/main" val="41749953"/>
       </p:ext>
     </p:extLst>
   </p:cSld>
@@ -17665,7 +16963,7 @@
     </p:spTree>
     <p:extLst>
       <p:ext uri="{BB962C8B-B14F-4D97-AF65-F5344CB8AC3E}">
-        <p14:creationId xmlns:p14="http://schemas.microsoft.com/office/powerpoint/2010/main" val="4051169299"/>
+        <p14:creationId xmlns:p14="http://schemas.microsoft.com/office/powerpoint/2010/main" val="3513069163"/>
       </p:ext>
     </p:extLst>
   </p:cSld>
@@ -17830,7 +17128,7 @@
     </p:spTree>
     <p:extLst>
       <p:ext uri="{BB962C8B-B14F-4D97-AF65-F5344CB8AC3E}">
-        <p14:creationId xmlns:p14="http://schemas.microsoft.com/office/powerpoint/2010/main" val="1829382932"/>
+        <p14:creationId xmlns:p14="http://schemas.microsoft.com/office/powerpoint/2010/main" val="1959315695"/>
       </p:ext>
     </p:extLst>
   </p:cSld>
@@ -17971,7 +17269,7 @@
     </p:spTree>
     <p:extLst>
       <p:ext uri="{BB962C8B-B14F-4D97-AF65-F5344CB8AC3E}">
-        <p14:creationId xmlns:p14="http://schemas.microsoft.com/office/powerpoint/2010/main" val="2125308312"/>
+        <p14:creationId xmlns:p14="http://schemas.microsoft.com/office/powerpoint/2010/main" val="822754617"/>
       </p:ext>
     </p:extLst>
   </p:cSld>
@@ -18097,7 +17395,7 @@
     </p:spTree>
     <p:extLst>
       <p:ext uri="{BB962C8B-B14F-4D97-AF65-F5344CB8AC3E}">
-        <p14:creationId xmlns:p14="http://schemas.microsoft.com/office/powerpoint/2010/main" val="3028490521"/>
+        <p14:creationId xmlns:p14="http://schemas.microsoft.com/office/powerpoint/2010/main" val="2835660319"/>
       </p:ext>
     </p:extLst>
   </p:cSld>
@@ -18460,7 +17758,7 @@
     </p:spTree>
     <p:extLst>
       <p:ext uri="{BB962C8B-B14F-4D97-AF65-F5344CB8AC3E}">
-        <p14:creationId xmlns:p14="http://schemas.microsoft.com/office/powerpoint/2010/main" val="662498229"/>
+        <p14:creationId xmlns:p14="http://schemas.microsoft.com/office/powerpoint/2010/main" val="961943045"/>
       </p:ext>
     </p:extLst>
   </p:cSld>
@@ -18626,7 +17924,7 @@
     </p:spTree>
     <p:extLst>
       <p:ext uri="{BB962C8B-B14F-4D97-AF65-F5344CB8AC3E}">
-        <p14:creationId xmlns:p14="http://schemas.microsoft.com/office/powerpoint/2010/main" val="3711217857"/>
+        <p14:creationId xmlns:p14="http://schemas.microsoft.com/office/powerpoint/2010/main" val="2408532865"/>
       </p:ext>
     </p:extLst>
   </p:cSld>
@@ -18767,7 +18065,7 @@
     </p:spTree>
     <p:extLst>
       <p:ext uri="{BB962C8B-B14F-4D97-AF65-F5344CB8AC3E}">
-        <p14:creationId xmlns:p14="http://schemas.microsoft.com/office/powerpoint/2010/main" val="90947965"/>
+        <p14:creationId xmlns:p14="http://schemas.microsoft.com/office/powerpoint/2010/main" val="3254818698"/>
       </p:ext>
     </p:extLst>
   </p:cSld>
@@ -18905,7 +18203,7 @@
     </p:spTree>
     <p:extLst>
       <p:ext uri="{BB962C8B-B14F-4D97-AF65-F5344CB8AC3E}">
-        <p14:creationId xmlns:p14="http://schemas.microsoft.com/office/powerpoint/2010/main" val="2120334372"/>
+        <p14:creationId xmlns:p14="http://schemas.microsoft.com/office/powerpoint/2010/main" val="743261955"/>
       </p:ext>
     </p:extLst>
   </p:cSld>
@@ -19046,7 +18344,7 @@
     </p:spTree>
     <p:extLst>
       <p:ext uri="{BB962C8B-B14F-4D97-AF65-F5344CB8AC3E}">
-        <p14:creationId xmlns:p14="http://schemas.microsoft.com/office/powerpoint/2010/main" val="1712291044"/>
+        <p14:creationId xmlns:p14="http://schemas.microsoft.com/office/powerpoint/2010/main" val="1770831916"/>
       </p:ext>
     </p:extLst>
   </p:cSld>
@@ -19187,7 +18485,7 @@
     </p:spTree>
     <p:extLst>
       <p:ext uri="{BB962C8B-B14F-4D97-AF65-F5344CB8AC3E}">
-        <p14:creationId xmlns:p14="http://schemas.microsoft.com/office/powerpoint/2010/main" val="393127027"/>
+        <p14:creationId xmlns:p14="http://schemas.microsoft.com/office/powerpoint/2010/main" val="1353014419"/>
       </p:ext>
     </p:extLst>
   </p:cSld>
@@ -19336,7 +18634,7 @@
     </p:spTree>
     <p:extLst>
       <p:ext uri="{BB962C8B-B14F-4D97-AF65-F5344CB8AC3E}">
-        <p14:creationId xmlns:p14="http://schemas.microsoft.com/office/powerpoint/2010/main" val="4079232276"/>
+        <p14:creationId xmlns:p14="http://schemas.microsoft.com/office/powerpoint/2010/main" val="1012781211"/>
       </p:ext>
     </p:extLst>
   </p:cSld>
@@ -19495,7 +18793,7 @@
     </p:spTree>
     <p:extLst>
       <p:ext uri="{BB962C8B-B14F-4D97-AF65-F5344CB8AC3E}">
-        <p14:creationId xmlns:p14="http://schemas.microsoft.com/office/powerpoint/2010/main" val="2605010743"/>
+        <p14:creationId xmlns:p14="http://schemas.microsoft.com/office/powerpoint/2010/main" val="2604190072"/>
       </p:ext>
     </p:extLst>
   </p:cSld>
@@ -19624,7 +18922,7 @@
     </p:spTree>
     <p:extLst>
       <p:ext uri="{BB962C8B-B14F-4D97-AF65-F5344CB8AC3E}">
-        <p14:creationId xmlns:p14="http://schemas.microsoft.com/office/powerpoint/2010/main" val="2870424101"/>
+        <p14:creationId xmlns:p14="http://schemas.microsoft.com/office/powerpoint/2010/main" val="67435840"/>
       </p:ext>
     </p:extLst>
   </p:cSld>
@@ -19753,7 +19051,7 @@
     </p:spTree>
     <p:extLst>
       <p:ext uri="{BB962C8B-B14F-4D97-AF65-F5344CB8AC3E}">
-        <p14:creationId xmlns:p14="http://schemas.microsoft.com/office/powerpoint/2010/main" val="473946518"/>
+        <p14:creationId xmlns:p14="http://schemas.microsoft.com/office/powerpoint/2010/main" val="675027269"/>
       </p:ext>
     </p:extLst>
   </p:cSld>
@@ -20061,7 +19359,7 @@
     </p:spTree>
     <p:extLst>
       <p:ext uri="{BB962C8B-B14F-4D97-AF65-F5344CB8AC3E}">
-        <p14:creationId xmlns:p14="http://schemas.microsoft.com/office/powerpoint/2010/main" val="326662624"/>
+        <p14:creationId xmlns:p14="http://schemas.microsoft.com/office/powerpoint/2010/main" val="1716007443"/>
       </p:ext>
     </p:extLst>
   </p:cSld>
@@ -20175,7 +19473,7 @@
     </p:spTree>
     <p:extLst>
       <p:ext uri="{BB962C8B-B14F-4D97-AF65-F5344CB8AC3E}">
-        <p14:creationId xmlns:p14="http://schemas.microsoft.com/office/powerpoint/2010/main" val="122030716"/>
+        <p14:creationId xmlns:p14="http://schemas.microsoft.com/office/powerpoint/2010/main" val="2464227776"/>
       </p:ext>
     </p:extLst>
   </p:cSld>
@@ -20334,7 +19632,7 @@
     </p:spTree>
     <p:extLst>
       <p:ext uri="{BB962C8B-B14F-4D97-AF65-F5344CB8AC3E}">
-        <p14:creationId xmlns:p14="http://schemas.microsoft.com/office/powerpoint/2010/main" val="2217557769"/>
+        <p14:creationId xmlns:p14="http://schemas.microsoft.com/office/powerpoint/2010/main" val="770637854"/>
       </p:ext>
     </p:extLst>
   </p:cSld>
@@ -20463,7 +19761,7 @@
     </p:spTree>
     <p:extLst>
       <p:ext uri="{BB962C8B-B14F-4D97-AF65-F5344CB8AC3E}">
-        <p14:creationId xmlns:p14="http://schemas.microsoft.com/office/powerpoint/2010/main" val="3805823356"/>
+        <p14:creationId xmlns:p14="http://schemas.microsoft.com/office/powerpoint/2010/main" val="1224212356"/>
       </p:ext>
     </p:extLst>
   </p:cSld>
@@ -20592,7 +19890,7 @@
     </p:spTree>
     <p:extLst>
       <p:ext uri="{BB962C8B-B14F-4D97-AF65-F5344CB8AC3E}">
-        <p14:creationId xmlns:p14="http://schemas.microsoft.com/office/powerpoint/2010/main" val="2369605914"/>
+        <p14:creationId xmlns:p14="http://schemas.microsoft.com/office/powerpoint/2010/main" val="4231919291"/>
       </p:ext>
     </p:extLst>
   </p:cSld>
@@ -20721,7 +20019,7 @@
     </p:spTree>
     <p:extLst>
       <p:ext uri="{BB962C8B-B14F-4D97-AF65-F5344CB8AC3E}">
-        <p14:creationId xmlns:p14="http://schemas.microsoft.com/office/powerpoint/2010/main" val="2829116736"/>
+        <p14:creationId xmlns:p14="http://schemas.microsoft.com/office/powerpoint/2010/main" val="2582779485"/>
       </p:ext>
     </p:extLst>
   </p:cSld>
@@ -20812,7 +20110,7 @@
                   <a:srgbClr val="FF0000"/>
                 </a:solidFill>
               </a:rPr>
-              <a:t>??</a:t>
+              <a:t>Fa</a:t>
             </a:r>
           </a:p>
         </p:txBody>
@@ -20820,7 +20118,7 @@
     </p:spTree>
     <p:extLst>
       <p:ext uri="{BB962C8B-B14F-4D97-AF65-F5344CB8AC3E}">
-        <p14:creationId xmlns:p14="http://schemas.microsoft.com/office/powerpoint/2010/main" val="3276011111"/>
+        <p14:creationId xmlns:p14="http://schemas.microsoft.com/office/powerpoint/2010/main" val="2933088883"/>
       </p:ext>
     </p:extLst>
   </p:cSld>
@@ -20903,7 +20201,7 @@
             </a:pPr>
             <a:r>
               <a:rPr lang="pt-BR" sz="7200" dirty="0"/>
-              <a:t>Loop de Vaneira </a:t>
+              <a:t>Maratá </a:t>
             </a:r>
             <a:r>
               <a:rPr lang="pt-BR" sz="7200" dirty="0">
@@ -20911,7 +20209,37 @@
                   <a:srgbClr val="FF0000"/>
                 </a:solidFill>
               </a:rPr>
-              <a:t>82 BPM</a:t>
+              <a:t>??</a:t>
+            </a:r>
+            <a:br>
+              <a:rPr lang="pt-BR" sz="7200" dirty="0"/>
+            </a:br>
+            <a:r>
+              <a:rPr lang="pt-BR" sz="7200" dirty="0"/>
+              <a:t>Levanta a Poeira </a:t>
+            </a:r>
+            <a:r>
+              <a:rPr lang="pt-BR" sz="7200" dirty="0">
+                <a:solidFill>
+                  <a:srgbClr val="FF0000"/>
+                </a:solidFill>
+              </a:rPr>
+              <a:t>Sib</a:t>
+            </a:r>
+            <a:br>
+              <a:rPr lang="pt-BR" sz="7200" dirty="0"/>
+            </a:br>
+            <a:r>
+              <a:rPr lang="pt-BR" sz="7200" dirty="0"/>
+              <a:t>Polka do Fritz </a:t>
+            </a:r>
+            <a:r>
+              <a:rPr lang="pt-BR" sz="7200" dirty="0">
+                <a:solidFill>
+                  <a:srgbClr val="FF0000"/>
+                </a:solidFill>
+              </a:rPr>
+              <a:t>??</a:t>
             </a:r>
           </a:p>
         </p:txBody>
@@ -20919,205 +20247,7 @@
     </p:spTree>
     <p:extLst>
       <p:ext uri="{BB962C8B-B14F-4D97-AF65-F5344CB8AC3E}">
-        <p14:creationId xmlns:p14="http://schemas.microsoft.com/office/powerpoint/2010/main" val="2466609216"/>
-      </p:ext>
-    </p:extLst>
-  </p:cSld>
-  <p:clrMapOvr>
-    <a:masterClrMapping/>
-  </p:clrMapOvr>
-</p:sld>
-</file>
-
-<file path=ppt/slides/slide98.xml><?xml version="1.0" encoding="utf-8"?>
-<p:sld xmlns:a="http://schemas.openxmlformats.org/drawingml/2006/main" xmlns:r="http://schemas.openxmlformats.org/officeDocument/2006/relationships" xmlns:p="http://schemas.openxmlformats.org/presentationml/2006/main">
-  <p:cSld>
-    <p:spTree>
-      <p:nvGrpSpPr>
-        <p:cNvPr id="1" name=""/>
-        <p:cNvGrpSpPr/>
-        <p:nvPr/>
-      </p:nvGrpSpPr>
-      <p:grpSpPr>
-        <a:xfrm>
-          <a:off x="0" y="0"/>
-          <a:ext cx="0" cy="0"/>
-          <a:chOff x="0" y="0"/>
-          <a:chExt cx="0" cy="0"/>
-        </a:xfrm>
-      </p:grpSpPr>
-      <p:sp>
-        <p:nvSpPr>
-          <p:cNvPr id="3" name="Espaço Reservado para Conteúdo 2">
-            <a:extLst>
-              <a:ext uri="{FF2B5EF4-FFF2-40B4-BE49-F238E27FC236}">
-                <a16:creationId xmlns:a16="http://schemas.microsoft.com/office/drawing/2014/main" id="{7C70BAA2-54A1-BAA9-5EF9-9F93F22AE700}"/>
-              </a:ext>
-            </a:extLst>
-          </p:cNvPr>
-          <p:cNvSpPr>
-            <a:spLocks noGrp="1"/>
-          </p:cNvSpPr>
-          <p:nvPr>
-            <p:ph idx="1"/>
-          </p:nvPr>
-        </p:nvSpPr>
-        <p:spPr>
-          <a:xfrm>
-            <a:off x="10509" y="-3937"/>
-            <a:ext cx="12181491" cy="6861937"/>
-          </a:xfrm>
-        </p:spPr>
-        <p:txBody>
-          <a:bodyPr>
-            <a:noAutofit/>
-          </a:bodyPr>
-          <a:lstStyle/>
-          <a:p>
-            <a:pPr algn="ctr">
-              <a:lnSpc>
-                <a:spcPct val="100000"/>
-              </a:lnSpc>
-              <a:buNone/>
-            </a:pPr>
-            <a:r>
-              <a:rPr lang="en-US" sz="8800" dirty="0">
-                <a:solidFill>
-                  <a:srgbClr val="FF0000"/>
-                </a:solidFill>
-                <a:cs typeface="Arial" panose="020B0604020202020204" pitchFamily="34" charset="0"/>
-              </a:rPr>
-              <a:t>VS BLOCO 35</a:t>
-            </a:r>
-          </a:p>
-          <a:p>
-            <a:pPr marL="36000" indent="-252000" algn="ctr">
-              <a:lnSpc>
-                <a:spcPct val="100000"/>
-              </a:lnSpc>
-              <a:spcBef>
-                <a:spcPts val="0"/>
-              </a:spcBef>
-              <a:buNone/>
-            </a:pPr>
-            <a:r>
-              <a:rPr lang="pt-BR" sz="7200" dirty="0"/>
-              <a:t>Loop de Vaneira </a:t>
-            </a:r>
-            <a:r>
-              <a:rPr lang="pt-BR" sz="7200" dirty="0">
-                <a:solidFill>
-                  <a:srgbClr val="FF0000"/>
-                </a:solidFill>
-              </a:rPr>
-              <a:t>90 BPM</a:t>
-            </a:r>
-          </a:p>
-        </p:txBody>
-      </p:sp>
-    </p:spTree>
-    <p:extLst>
-      <p:ext uri="{BB962C8B-B14F-4D97-AF65-F5344CB8AC3E}">
-        <p14:creationId xmlns:p14="http://schemas.microsoft.com/office/powerpoint/2010/main" val="312988008"/>
-      </p:ext>
-    </p:extLst>
-  </p:cSld>
-  <p:clrMapOvr>
-    <a:masterClrMapping/>
-  </p:clrMapOvr>
-</p:sld>
-</file>
-
-<file path=ppt/slides/slide99.xml><?xml version="1.0" encoding="utf-8"?>
-<p:sld xmlns:a="http://schemas.openxmlformats.org/drawingml/2006/main" xmlns:r="http://schemas.openxmlformats.org/officeDocument/2006/relationships" xmlns:p="http://schemas.openxmlformats.org/presentationml/2006/main">
-  <p:cSld>
-    <p:spTree>
-      <p:nvGrpSpPr>
-        <p:cNvPr id="1" name=""/>
-        <p:cNvGrpSpPr/>
-        <p:nvPr/>
-      </p:nvGrpSpPr>
-      <p:grpSpPr>
-        <a:xfrm>
-          <a:off x="0" y="0"/>
-          <a:ext cx="0" cy="0"/>
-          <a:chOff x="0" y="0"/>
-          <a:chExt cx="0" cy="0"/>
-        </a:xfrm>
-      </p:grpSpPr>
-      <p:sp>
-        <p:nvSpPr>
-          <p:cNvPr id="3" name="Espaço Reservado para Conteúdo 2">
-            <a:extLst>
-              <a:ext uri="{FF2B5EF4-FFF2-40B4-BE49-F238E27FC236}">
-                <a16:creationId xmlns:a16="http://schemas.microsoft.com/office/drawing/2014/main" id="{7C70BAA2-54A1-BAA9-5EF9-9F93F22AE700}"/>
-              </a:ext>
-            </a:extLst>
-          </p:cNvPr>
-          <p:cNvSpPr>
-            <a:spLocks noGrp="1"/>
-          </p:cNvSpPr>
-          <p:nvPr>
-            <p:ph idx="1"/>
-          </p:nvPr>
-        </p:nvSpPr>
-        <p:spPr>
-          <a:xfrm>
-            <a:off x="10509" y="-3937"/>
-            <a:ext cx="12181491" cy="6861937"/>
-          </a:xfrm>
-        </p:spPr>
-        <p:txBody>
-          <a:bodyPr>
-            <a:noAutofit/>
-          </a:bodyPr>
-          <a:lstStyle/>
-          <a:p>
-            <a:pPr algn="ctr">
-              <a:lnSpc>
-                <a:spcPct val="100000"/>
-              </a:lnSpc>
-              <a:buNone/>
-            </a:pPr>
-            <a:r>
-              <a:rPr lang="en-US" sz="8800" dirty="0">
-                <a:solidFill>
-                  <a:srgbClr val="FF0000"/>
-                </a:solidFill>
-                <a:cs typeface="Arial" panose="020B0604020202020204" pitchFamily="34" charset="0"/>
-              </a:rPr>
-              <a:t>VS BLOCO 36</a:t>
-            </a:r>
-          </a:p>
-          <a:p>
-            <a:pPr marL="36000" indent="-252000" algn="ctr">
-              <a:lnSpc>
-                <a:spcPct val="100000"/>
-              </a:lnSpc>
-              <a:spcBef>
-                <a:spcPts val="0"/>
-              </a:spcBef>
-              <a:buNone/>
-            </a:pPr>
-            <a:r>
-              <a:rPr lang="pt-BR" sz="7200" dirty="0"/>
-              <a:t>Loop de Vaneira </a:t>
-            </a:r>
-            <a:r>
-              <a:rPr lang="pt-BR" sz="7200" dirty="0">
-                <a:solidFill>
-                  <a:srgbClr val="FF0000"/>
-                </a:solidFill>
-              </a:rPr>
-              <a:t>94 BPM</a:t>
-            </a:r>
-          </a:p>
-        </p:txBody>
-      </p:sp>
-    </p:spTree>
-    <p:extLst>
-      <p:ext uri="{BB962C8B-B14F-4D97-AF65-F5344CB8AC3E}">
-        <p14:creationId xmlns:p14="http://schemas.microsoft.com/office/powerpoint/2010/main" val="2798160634"/>
+        <p14:creationId xmlns:p14="http://schemas.microsoft.com/office/powerpoint/2010/main" val="610891450"/>
       </p:ext>
     </p:extLst>
   </p:cSld>

</xml_diff>

<commit_message>
Adiciona o bloco 35 (NA HORA DE AMAR - PÁGINA DE AMIGOS - DORMI NA PRAÇA) ao ROTA, vindo do LAB.
Entra depois do último bloco de música; os loops e clicks descem para 36-46.
BASS, BATERIA, GUIA NA HORA DE AMAR e GUIA VOZ mutadas como no LAB.
Repertórios VS e COMPLETO refeitos, com tom ?? nas três músicas.

Co-Authored-By: Claude Opus 5.5 <noreply@anthropic.com>
</commit_message>
<xml_diff>
--- a/REPERTÓRIO/Repertório Rota do Chopp - COMPLETO.pptx
+++ b/REPERTÓRIO/Repertório Rota do Chopp - COMPLETO.pptx
@@ -5,7 +5,7 @@
     <p:sldMasterId id="2147483804" r:id="rId1"/>
   </p:sldMasterIdLst>
   <p:handoutMasterIdLst>
-    <p:handoutMasterId r:id="rId99"/>
+    <p:handoutMasterId r:id="rId100"/>
   </p:handoutMasterIdLst>
   <p:sldIdLst>
     <p:sldId id="392" r:id="rId2"/>
@@ -105,6 +105,7 @@
     <p:sldId id="477" r:id="rId96"/>
     <p:sldId id="481" r:id="rId97"/>
     <p:sldId id="482" r:id="rId98"/>
+    <p:sldId id="483" r:id="rId99"/>
   </p:sldIdLst>
   <p:sldSz cx="12192000" cy="6858000"/>
   <p:notesSz cx="6858000" cy="9144000"/>
@@ -563,7 +564,7 @@
           <a:p>
             <a:fld id="{9F69E24D-9DBE-4DAB-A481-718B3C423892}" type="datetimeFigureOut">
               <a:rPr lang="pt-BR" smtClean="0"/>
-              <a:t>14/10/2026</a:t>
+              <a:t>17/10/2026</a:t>
             </a:fld>
             <a:endParaRPr lang="pt-BR"/>
           </a:p>
@@ -780,7 +781,7 @@
             <a:fld id="{BB0B304C-6D9A-40FB-A8B9-28880A8BB8D2}" type="datetimeFigureOut">
               <a:rPr lang="pt-BR" smtClean="0"/>
               <a:pPr/>
-              <a:t>14/10/2026</a:t>
+              <a:t>17/10/2026</a:t>
             </a:fld>
             <a:endParaRPr lang="pt-BR"/>
           </a:p>
@@ -1069,7 +1070,7 @@
             <a:fld id="{BB0B304C-6D9A-40FB-A8B9-28880A8BB8D2}" type="datetimeFigureOut">
               <a:rPr lang="pt-BR" smtClean="0"/>
               <a:pPr/>
-              <a:t>14/10/2026</a:t>
+              <a:t>17/10/2026</a:t>
             </a:fld>
             <a:endParaRPr lang="pt-BR"/>
           </a:p>
@@ -1263,7 +1264,7 @@
             <a:fld id="{BB0B304C-6D9A-40FB-A8B9-28880A8BB8D2}" type="datetimeFigureOut">
               <a:rPr lang="pt-BR" smtClean="0"/>
               <a:pPr/>
-              <a:t>14/10/2026</a:t>
+              <a:t>17/10/2026</a:t>
             </a:fld>
             <a:endParaRPr lang="pt-BR"/>
           </a:p>
@@ -1526,7 +1527,7 @@
             <a:fld id="{BB0B304C-6D9A-40FB-A8B9-28880A8BB8D2}" type="datetimeFigureOut">
               <a:rPr lang="pt-BR" smtClean="0"/>
               <a:pPr/>
-              <a:t>14/10/2026</a:t>
+              <a:t>17/10/2026</a:t>
             </a:fld>
             <a:endParaRPr lang="pt-BR"/>
           </a:p>
@@ -1952,7 +1953,7 @@
             <a:fld id="{BB0B304C-6D9A-40FB-A8B9-28880A8BB8D2}" type="datetimeFigureOut">
               <a:rPr lang="pt-BR" smtClean="0"/>
               <a:pPr/>
-              <a:t>14/10/2026</a:t>
+              <a:t>17/10/2026</a:t>
             </a:fld>
             <a:endParaRPr lang="pt-BR"/>
           </a:p>
@@ -2500,7 +2501,7 @@
             <a:fld id="{BB0B304C-6D9A-40FB-A8B9-28880A8BB8D2}" type="datetimeFigureOut">
               <a:rPr lang="pt-BR" smtClean="0"/>
               <a:pPr/>
-              <a:t>14/10/2026</a:t>
+              <a:t>17/10/2026</a:t>
             </a:fld>
             <a:endParaRPr lang="pt-BR"/>
           </a:p>
@@ -3342,7 +3343,7 @@
             <a:fld id="{BB0B304C-6D9A-40FB-A8B9-28880A8BB8D2}" type="datetimeFigureOut">
               <a:rPr lang="pt-BR" smtClean="0"/>
               <a:pPr/>
-              <a:t>14/10/2026</a:t>
+              <a:t>17/10/2026</a:t>
             </a:fld>
             <a:endParaRPr lang="pt-BR"/>
           </a:p>
@@ -3514,7 +3515,7 @@
             <a:fld id="{BB0B304C-6D9A-40FB-A8B9-28880A8BB8D2}" type="datetimeFigureOut">
               <a:rPr lang="pt-BR" smtClean="0"/>
               <a:pPr/>
-              <a:t>14/10/2026</a:t>
+              <a:t>17/10/2026</a:t>
             </a:fld>
             <a:endParaRPr lang="pt-BR"/>
           </a:p>
@@ -3700,7 +3701,7 @@
             <a:fld id="{BB0B304C-6D9A-40FB-A8B9-28880A8BB8D2}" type="datetimeFigureOut">
               <a:rPr lang="pt-BR" smtClean="0"/>
               <a:pPr/>
-              <a:t>14/10/2026</a:t>
+              <a:t>17/10/2026</a:t>
             </a:fld>
             <a:endParaRPr lang="pt-BR"/>
           </a:p>
@@ -3872,7 +3873,7 @@
             <a:fld id="{BB0B304C-6D9A-40FB-A8B9-28880A8BB8D2}" type="datetimeFigureOut">
               <a:rPr lang="pt-BR" smtClean="0"/>
               <a:pPr/>
-              <a:t>14/10/2026</a:t>
+              <a:t>17/10/2026</a:t>
             </a:fld>
             <a:endParaRPr lang="pt-BR"/>
           </a:p>
@@ -4122,7 +4123,7 @@
             <a:fld id="{BB0B304C-6D9A-40FB-A8B9-28880A8BB8D2}" type="datetimeFigureOut">
               <a:rPr lang="pt-BR" smtClean="0"/>
               <a:pPr/>
-              <a:t>14/10/2026</a:t>
+              <a:t>17/10/2026</a:t>
             </a:fld>
             <a:endParaRPr lang="pt-BR"/>
           </a:p>
@@ -4361,7 +4362,7 @@
             <a:fld id="{BB0B304C-6D9A-40FB-A8B9-28880A8BB8D2}" type="datetimeFigureOut">
               <a:rPr lang="pt-BR" smtClean="0"/>
               <a:pPr/>
-              <a:t>14/10/2026</a:t>
+              <a:t>17/10/2026</a:t>
             </a:fld>
             <a:endParaRPr lang="pt-BR"/>
           </a:p>
@@ -4736,7 +4737,7 @@
             <a:fld id="{BB0B304C-6D9A-40FB-A8B9-28880A8BB8D2}" type="datetimeFigureOut">
               <a:rPr lang="pt-BR" smtClean="0"/>
               <a:pPr/>
-              <a:t>14/10/2026</a:t>
+              <a:t>17/10/2026</a:t>
             </a:fld>
             <a:endParaRPr lang="pt-BR"/>
           </a:p>
@@ -4856,7 +4857,7 @@
             <a:fld id="{BB0B304C-6D9A-40FB-A8B9-28880A8BB8D2}" type="datetimeFigureOut">
               <a:rPr lang="pt-BR" smtClean="0"/>
               <a:pPr/>
-              <a:t>14/10/2026</a:t>
+              <a:t>17/10/2026</a:t>
             </a:fld>
             <a:endParaRPr lang="pt-BR"/>
           </a:p>
@@ -4953,7 +4954,7 @@
             <a:fld id="{BB0B304C-6D9A-40FB-A8B9-28880A8BB8D2}" type="datetimeFigureOut">
               <a:rPr lang="pt-BR" smtClean="0"/>
               <a:pPr/>
-              <a:t>14/10/2026</a:t>
+              <a:t>17/10/2026</a:t>
             </a:fld>
             <a:endParaRPr lang="pt-BR"/>
           </a:p>
@@ -5206,7 +5207,7 @@
             <a:fld id="{BB0B304C-6D9A-40FB-A8B9-28880A8BB8D2}" type="datetimeFigureOut">
               <a:rPr lang="pt-BR" smtClean="0"/>
               <a:pPr/>
-              <a:t>14/10/2026</a:t>
+              <a:t>17/10/2026</a:t>
             </a:fld>
             <a:endParaRPr lang="pt-BR"/>
           </a:p>
@@ -5495,7 +5496,7 @@
             <a:fld id="{BB0B304C-6D9A-40FB-A8B9-28880A8BB8D2}" type="datetimeFigureOut">
               <a:rPr lang="pt-BR" smtClean="0"/>
               <a:pPr/>
-              <a:t>14/10/2026</a:t>
+              <a:t>17/10/2026</a:t>
             </a:fld>
             <a:endParaRPr lang="pt-BR"/>
           </a:p>
@@ -5710,7 +5711,7 @@
             <a:fld id="{BB0B304C-6D9A-40FB-A8B9-28880A8BB8D2}" type="datetimeFigureOut">
               <a:rPr lang="pt-BR" smtClean="0"/>
               <a:pPr/>
-              <a:t>14/10/2026</a:t>
+              <a:t>17/10/2026</a:t>
             </a:fld>
             <a:endParaRPr lang="pt-BR"/>
           </a:p>
@@ -14848,7 +14849,7 @@
     </p:spTree>
     <p:extLst>
       <p:ext uri="{BB962C8B-B14F-4D97-AF65-F5344CB8AC3E}">
-        <p14:creationId xmlns:p14="http://schemas.microsoft.com/office/powerpoint/2010/main" val="1762806921"/>
+        <p14:creationId xmlns:p14="http://schemas.microsoft.com/office/powerpoint/2010/main" val="3757311472"/>
       </p:ext>
     </p:extLst>
   </p:cSld>
@@ -15012,7 +15013,7 @@
     </p:spTree>
     <p:extLst>
       <p:ext uri="{BB962C8B-B14F-4D97-AF65-F5344CB8AC3E}">
-        <p14:creationId xmlns:p14="http://schemas.microsoft.com/office/powerpoint/2010/main" val="1999328298"/>
+        <p14:creationId xmlns:p14="http://schemas.microsoft.com/office/powerpoint/2010/main" val="4129570783"/>
       </p:ext>
     </p:extLst>
   </p:cSld>
@@ -15254,7 +15255,7 @@
     </p:spTree>
     <p:extLst>
       <p:ext uri="{BB962C8B-B14F-4D97-AF65-F5344CB8AC3E}">
-        <p14:creationId xmlns:p14="http://schemas.microsoft.com/office/powerpoint/2010/main" val="2054186895"/>
+        <p14:creationId xmlns:p14="http://schemas.microsoft.com/office/powerpoint/2010/main" val="3985484919"/>
       </p:ext>
     </p:extLst>
   </p:cSld>
@@ -15419,7 +15420,7 @@
     </p:spTree>
     <p:extLst>
       <p:ext uri="{BB962C8B-B14F-4D97-AF65-F5344CB8AC3E}">
-        <p14:creationId xmlns:p14="http://schemas.microsoft.com/office/powerpoint/2010/main" val="610305201"/>
+        <p14:creationId xmlns:p14="http://schemas.microsoft.com/office/powerpoint/2010/main" val="4043846689"/>
       </p:ext>
     </p:extLst>
   </p:cSld>
@@ -15597,7 +15598,7 @@
     </p:spTree>
     <p:extLst>
       <p:ext uri="{BB962C8B-B14F-4D97-AF65-F5344CB8AC3E}">
-        <p14:creationId xmlns:p14="http://schemas.microsoft.com/office/powerpoint/2010/main" val="3270442868"/>
+        <p14:creationId xmlns:p14="http://schemas.microsoft.com/office/powerpoint/2010/main" val="725496263"/>
       </p:ext>
     </p:extLst>
   </p:cSld>
@@ -15723,7 +15724,7 @@
     </p:spTree>
     <p:extLst>
       <p:ext uri="{BB962C8B-B14F-4D97-AF65-F5344CB8AC3E}">
-        <p14:creationId xmlns:p14="http://schemas.microsoft.com/office/powerpoint/2010/main" val="1720707557"/>
+        <p14:creationId xmlns:p14="http://schemas.microsoft.com/office/powerpoint/2010/main" val="617374800"/>
       </p:ext>
     </p:extLst>
   </p:cSld>
@@ -16011,7 +16012,7 @@
     </p:spTree>
     <p:extLst>
       <p:ext uri="{BB962C8B-B14F-4D97-AF65-F5344CB8AC3E}">
-        <p14:creationId xmlns:p14="http://schemas.microsoft.com/office/powerpoint/2010/main" val="2796686526"/>
+        <p14:creationId xmlns:p14="http://schemas.microsoft.com/office/powerpoint/2010/main" val="837478984"/>
       </p:ext>
     </p:extLst>
   </p:cSld>
@@ -16137,7 +16138,7 @@
     </p:spTree>
     <p:extLst>
       <p:ext uri="{BB962C8B-B14F-4D97-AF65-F5344CB8AC3E}">
-        <p14:creationId xmlns:p14="http://schemas.microsoft.com/office/powerpoint/2010/main" val="69810962"/>
+        <p14:creationId xmlns:p14="http://schemas.microsoft.com/office/powerpoint/2010/main" val="425110700"/>
       </p:ext>
     </p:extLst>
   </p:cSld>
@@ -16341,7 +16342,7 @@
     </p:spTree>
     <p:extLst>
       <p:ext uri="{BB962C8B-B14F-4D97-AF65-F5344CB8AC3E}">
-        <p14:creationId xmlns:p14="http://schemas.microsoft.com/office/powerpoint/2010/main" val="2963673977"/>
+        <p14:creationId xmlns:p14="http://schemas.microsoft.com/office/powerpoint/2010/main" val="383440447"/>
       </p:ext>
     </p:extLst>
   </p:cSld>
@@ -16482,7 +16483,7 @@
     </p:spTree>
     <p:extLst>
       <p:ext uri="{BB962C8B-B14F-4D97-AF65-F5344CB8AC3E}">
-        <p14:creationId xmlns:p14="http://schemas.microsoft.com/office/powerpoint/2010/main" val="1018213711"/>
+        <p14:creationId xmlns:p14="http://schemas.microsoft.com/office/powerpoint/2010/main" val="3556834615"/>
       </p:ext>
     </p:extLst>
   </p:cSld>
@@ -16668,7 +16669,7 @@
     </p:spTree>
     <p:extLst>
       <p:ext uri="{BB962C8B-B14F-4D97-AF65-F5344CB8AC3E}">
-        <p14:creationId xmlns:p14="http://schemas.microsoft.com/office/powerpoint/2010/main" val="1127717112"/>
+        <p14:creationId xmlns:p14="http://schemas.microsoft.com/office/powerpoint/2010/main" val="2480040779"/>
       </p:ext>
     </p:extLst>
   </p:cSld>
@@ -16822,7 +16823,7 @@
     </p:spTree>
     <p:extLst>
       <p:ext uri="{BB962C8B-B14F-4D97-AF65-F5344CB8AC3E}">
-        <p14:creationId xmlns:p14="http://schemas.microsoft.com/office/powerpoint/2010/main" val="41749953"/>
+        <p14:creationId xmlns:p14="http://schemas.microsoft.com/office/powerpoint/2010/main" val="1332279248"/>
       </p:ext>
     </p:extLst>
   </p:cSld>
@@ -16963,7 +16964,7 @@
     </p:spTree>
     <p:extLst>
       <p:ext uri="{BB962C8B-B14F-4D97-AF65-F5344CB8AC3E}">
-        <p14:creationId xmlns:p14="http://schemas.microsoft.com/office/powerpoint/2010/main" val="3513069163"/>
+        <p14:creationId xmlns:p14="http://schemas.microsoft.com/office/powerpoint/2010/main" val="361009882"/>
       </p:ext>
     </p:extLst>
   </p:cSld>
@@ -17128,7 +17129,7 @@
     </p:spTree>
     <p:extLst>
       <p:ext uri="{BB962C8B-B14F-4D97-AF65-F5344CB8AC3E}">
-        <p14:creationId xmlns:p14="http://schemas.microsoft.com/office/powerpoint/2010/main" val="1959315695"/>
+        <p14:creationId xmlns:p14="http://schemas.microsoft.com/office/powerpoint/2010/main" val="381076217"/>
       </p:ext>
     </p:extLst>
   </p:cSld>
@@ -17269,7 +17270,7 @@
     </p:spTree>
     <p:extLst>
       <p:ext uri="{BB962C8B-B14F-4D97-AF65-F5344CB8AC3E}">
-        <p14:creationId xmlns:p14="http://schemas.microsoft.com/office/powerpoint/2010/main" val="822754617"/>
+        <p14:creationId xmlns:p14="http://schemas.microsoft.com/office/powerpoint/2010/main" val="2867383609"/>
       </p:ext>
     </p:extLst>
   </p:cSld>
@@ -17395,7 +17396,7 @@
     </p:spTree>
     <p:extLst>
       <p:ext uri="{BB962C8B-B14F-4D97-AF65-F5344CB8AC3E}">
-        <p14:creationId xmlns:p14="http://schemas.microsoft.com/office/powerpoint/2010/main" val="2835660319"/>
+        <p14:creationId xmlns:p14="http://schemas.microsoft.com/office/powerpoint/2010/main" val="3717431089"/>
       </p:ext>
     </p:extLst>
   </p:cSld>
@@ -17758,7 +17759,7 @@
     </p:spTree>
     <p:extLst>
       <p:ext uri="{BB962C8B-B14F-4D97-AF65-F5344CB8AC3E}">
-        <p14:creationId xmlns:p14="http://schemas.microsoft.com/office/powerpoint/2010/main" val="961943045"/>
+        <p14:creationId xmlns:p14="http://schemas.microsoft.com/office/powerpoint/2010/main" val="3987736872"/>
       </p:ext>
     </p:extLst>
   </p:cSld>
@@ -17924,7 +17925,7 @@
     </p:spTree>
     <p:extLst>
       <p:ext uri="{BB962C8B-B14F-4D97-AF65-F5344CB8AC3E}">
-        <p14:creationId xmlns:p14="http://schemas.microsoft.com/office/powerpoint/2010/main" val="2408532865"/>
+        <p14:creationId xmlns:p14="http://schemas.microsoft.com/office/powerpoint/2010/main" val="2201469516"/>
       </p:ext>
     </p:extLst>
   </p:cSld>
@@ -18065,7 +18066,7 @@
     </p:spTree>
     <p:extLst>
       <p:ext uri="{BB962C8B-B14F-4D97-AF65-F5344CB8AC3E}">
-        <p14:creationId xmlns:p14="http://schemas.microsoft.com/office/powerpoint/2010/main" val="3254818698"/>
+        <p14:creationId xmlns:p14="http://schemas.microsoft.com/office/powerpoint/2010/main" val="1113714772"/>
       </p:ext>
     </p:extLst>
   </p:cSld>
@@ -18203,7 +18204,7 @@
     </p:spTree>
     <p:extLst>
       <p:ext uri="{BB962C8B-B14F-4D97-AF65-F5344CB8AC3E}">
-        <p14:creationId xmlns:p14="http://schemas.microsoft.com/office/powerpoint/2010/main" val="743261955"/>
+        <p14:creationId xmlns:p14="http://schemas.microsoft.com/office/powerpoint/2010/main" val="615428593"/>
       </p:ext>
     </p:extLst>
   </p:cSld>
@@ -18344,7 +18345,7 @@
     </p:spTree>
     <p:extLst>
       <p:ext uri="{BB962C8B-B14F-4D97-AF65-F5344CB8AC3E}">
-        <p14:creationId xmlns:p14="http://schemas.microsoft.com/office/powerpoint/2010/main" val="1770831916"/>
+        <p14:creationId xmlns:p14="http://schemas.microsoft.com/office/powerpoint/2010/main" val="848930938"/>
       </p:ext>
     </p:extLst>
   </p:cSld>
@@ -18485,7 +18486,7 @@
     </p:spTree>
     <p:extLst>
       <p:ext uri="{BB962C8B-B14F-4D97-AF65-F5344CB8AC3E}">
-        <p14:creationId xmlns:p14="http://schemas.microsoft.com/office/powerpoint/2010/main" val="1353014419"/>
+        <p14:creationId xmlns:p14="http://schemas.microsoft.com/office/powerpoint/2010/main" val="1232025425"/>
       </p:ext>
     </p:extLst>
   </p:cSld>
@@ -18634,7 +18635,7 @@
     </p:spTree>
     <p:extLst>
       <p:ext uri="{BB962C8B-B14F-4D97-AF65-F5344CB8AC3E}">
-        <p14:creationId xmlns:p14="http://schemas.microsoft.com/office/powerpoint/2010/main" val="1012781211"/>
+        <p14:creationId xmlns:p14="http://schemas.microsoft.com/office/powerpoint/2010/main" val="3479716492"/>
       </p:ext>
     </p:extLst>
   </p:cSld>
@@ -18793,7 +18794,7 @@
     </p:spTree>
     <p:extLst>
       <p:ext uri="{BB962C8B-B14F-4D97-AF65-F5344CB8AC3E}">
-        <p14:creationId xmlns:p14="http://schemas.microsoft.com/office/powerpoint/2010/main" val="2604190072"/>
+        <p14:creationId xmlns:p14="http://schemas.microsoft.com/office/powerpoint/2010/main" val="2483999642"/>
       </p:ext>
     </p:extLst>
   </p:cSld>
@@ -18922,7 +18923,7 @@
     </p:spTree>
     <p:extLst>
       <p:ext uri="{BB962C8B-B14F-4D97-AF65-F5344CB8AC3E}">
-        <p14:creationId xmlns:p14="http://schemas.microsoft.com/office/powerpoint/2010/main" val="67435840"/>
+        <p14:creationId xmlns:p14="http://schemas.microsoft.com/office/powerpoint/2010/main" val="2546721598"/>
       </p:ext>
     </p:extLst>
   </p:cSld>
@@ -19051,7 +19052,7 @@
     </p:spTree>
     <p:extLst>
       <p:ext uri="{BB962C8B-B14F-4D97-AF65-F5344CB8AC3E}">
-        <p14:creationId xmlns:p14="http://schemas.microsoft.com/office/powerpoint/2010/main" val="675027269"/>
+        <p14:creationId xmlns:p14="http://schemas.microsoft.com/office/powerpoint/2010/main" val="1926229927"/>
       </p:ext>
     </p:extLst>
   </p:cSld>
@@ -19359,7 +19360,7 @@
     </p:spTree>
     <p:extLst>
       <p:ext uri="{BB962C8B-B14F-4D97-AF65-F5344CB8AC3E}">
-        <p14:creationId xmlns:p14="http://schemas.microsoft.com/office/powerpoint/2010/main" val="1716007443"/>
+        <p14:creationId xmlns:p14="http://schemas.microsoft.com/office/powerpoint/2010/main" val="3701785412"/>
       </p:ext>
     </p:extLst>
   </p:cSld>
@@ -19473,7 +19474,7 @@
     </p:spTree>
     <p:extLst>
       <p:ext uri="{BB962C8B-B14F-4D97-AF65-F5344CB8AC3E}">
-        <p14:creationId xmlns:p14="http://schemas.microsoft.com/office/powerpoint/2010/main" val="2464227776"/>
+        <p14:creationId xmlns:p14="http://schemas.microsoft.com/office/powerpoint/2010/main" val="3958843814"/>
       </p:ext>
     </p:extLst>
   </p:cSld>
@@ -19632,7 +19633,7 @@
     </p:spTree>
     <p:extLst>
       <p:ext uri="{BB962C8B-B14F-4D97-AF65-F5344CB8AC3E}">
-        <p14:creationId xmlns:p14="http://schemas.microsoft.com/office/powerpoint/2010/main" val="770637854"/>
+        <p14:creationId xmlns:p14="http://schemas.microsoft.com/office/powerpoint/2010/main" val="4108880505"/>
       </p:ext>
     </p:extLst>
   </p:cSld>
@@ -19761,7 +19762,7 @@
     </p:spTree>
     <p:extLst>
       <p:ext uri="{BB962C8B-B14F-4D97-AF65-F5344CB8AC3E}">
-        <p14:creationId xmlns:p14="http://schemas.microsoft.com/office/powerpoint/2010/main" val="1224212356"/>
+        <p14:creationId xmlns:p14="http://schemas.microsoft.com/office/powerpoint/2010/main" val="2132989991"/>
       </p:ext>
     </p:extLst>
   </p:cSld>
@@ -19890,7 +19891,7 @@
     </p:spTree>
     <p:extLst>
       <p:ext uri="{BB962C8B-B14F-4D97-AF65-F5344CB8AC3E}">
-        <p14:creationId xmlns:p14="http://schemas.microsoft.com/office/powerpoint/2010/main" val="4231919291"/>
+        <p14:creationId xmlns:p14="http://schemas.microsoft.com/office/powerpoint/2010/main" val="3130659454"/>
       </p:ext>
     </p:extLst>
   </p:cSld>
@@ -20019,7 +20020,7 @@
     </p:spTree>
     <p:extLst>
       <p:ext uri="{BB962C8B-B14F-4D97-AF65-F5344CB8AC3E}">
-        <p14:creationId xmlns:p14="http://schemas.microsoft.com/office/powerpoint/2010/main" val="2582779485"/>
+        <p14:creationId xmlns:p14="http://schemas.microsoft.com/office/powerpoint/2010/main" val="1915499331"/>
       </p:ext>
     </p:extLst>
   </p:cSld>
@@ -20118,7 +20119,7 @@
     </p:spTree>
     <p:extLst>
       <p:ext uri="{BB962C8B-B14F-4D97-AF65-F5344CB8AC3E}">
-        <p14:creationId xmlns:p14="http://schemas.microsoft.com/office/powerpoint/2010/main" val="2933088883"/>
+        <p14:creationId xmlns:p14="http://schemas.microsoft.com/office/powerpoint/2010/main" val="615709339"/>
       </p:ext>
     </p:extLst>
   </p:cSld>
@@ -20247,7 +20248,136 @@
     </p:spTree>
     <p:extLst>
       <p:ext uri="{BB962C8B-B14F-4D97-AF65-F5344CB8AC3E}">
-        <p14:creationId xmlns:p14="http://schemas.microsoft.com/office/powerpoint/2010/main" val="610891450"/>
+        <p14:creationId xmlns:p14="http://schemas.microsoft.com/office/powerpoint/2010/main" val="658313605"/>
+      </p:ext>
+    </p:extLst>
+  </p:cSld>
+  <p:clrMapOvr>
+    <a:masterClrMapping/>
+  </p:clrMapOvr>
+</p:sld>
+</file>
+
+<file path=ppt/slides/slide98.xml><?xml version="1.0" encoding="utf-8"?>
+<p:sld xmlns:a="http://schemas.openxmlformats.org/drawingml/2006/main" xmlns:r="http://schemas.openxmlformats.org/officeDocument/2006/relationships" xmlns:p="http://schemas.openxmlformats.org/presentationml/2006/main">
+  <p:cSld>
+    <p:spTree>
+      <p:nvGrpSpPr>
+        <p:cNvPr id="1" name=""/>
+        <p:cNvGrpSpPr/>
+        <p:nvPr/>
+      </p:nvGrpSpPr>
+      <p:grpSpPr>
+        <a:xfrm>
+          <a:off x="0" y="0"/>
+          <a:ext cx="0" cy="0"/>
+          <a:chOff x="0" y="0"/>
+          <a:chExt cx="0" cy="0"/>
+        </a:xfrm>
+      </p:grpSpPr>
+      <p:sp>
+        <p:nvSpPr>
+          <p:cNvPr id="3" name="Espaço Reservado para Conteúdo 2">
+            <a:extLst>
+              <a:ext uri="{FF2B5EF4-FFF2-40B4-BE49-F238E27FC236}">
+                <a16:creationId xmlns:a16="http://schemas.microsoft.com/office/drawing/2014/main" id="{7C70BAA2-54A1-BAA9-5EF9-9F93F22AE700}"/>
+              </a:ext>
+            </a:extLst>
+          </p:cNvPr>
+          <p:cNvSpPr>
+            <a:spLocks noGrp="1"/>
+          </p:cNvSpPr>
+          <p:nvPr>
+            <p:ph idx="1"/>
+          </p:nvPr>
+        </p:nvSpPr>
+        <p:spPr>
+          <a:xfrm>
+            <a:off x="10509" y="-3937"/>
+            <a:ext cx="12181491" cy="6861937"/>
+          </a:xfrm>
+        </p:spPr>
+        <p:txBody>
+          <a:bodyPr>
+            <a:noAutofit/>
+          </a:bodyPr>
+          <a:lstStyle/>
+          <a:p>
+            <a:pPr algn="ctr">
+              <a:lnSpc>
+                <a:spcPct val="100000"/>
+              </a:lnSpc>
+              <a:buNone/>
+            </a:pPr>
+            <a:r>
+              <a:rPr lang="en-US" sz="8800" dirty="0">
+                <a:solidFill>
+                  <a:srgbClr val="FF0000"/>
+                </a:solidFill>
+                <a:cs typeface="Arial" panose="020B0604020202020204" pitchFamily="34" charset="0"/>
+              </a:rPr>
+              <a:t>VS BLOCO 35</a:t>
+            </a:r>
+          </a:p>
+          <a:p>
+            <a:pPr marL="36000" indent="-252000" algn="ctr">
+              <a:lnSpc>
+                <a:spcPct val="100000"/>
+              </a:lnSpc>
+              <a:spcBef>
+                <a:spcPts val="0"/>
+              </a:spcBef>
+              <a:buNone/>
+            </a:pPr>
+            <a:r>
+              <a:rPr lang="pt-BR" sz="7200" dirty="0"/>
+              <a:t>Na Hora de Amar </a:t>
+            </a:r>
+            <a:r>
+              <a:rPr lang="pt-BR" sz="7200" dirty="0">
+                <a:solidFill>
+                  <a:srgbClr val="FF0000"/>
+                </a:solidFill>
+              </a:rPr>
+              <a:t>??</a:t>
+            </a:r>
+            <a:br>
+              <a:rPr lang="pt-BR" sz="7200" dirty="0"/>
+            </a:br>
+            <a:r>
+              <a:rPr lang="pt-BR" sz="7200" dirty="0"/>
+              <a:t>Página de Amigos </a:t>
+            </a:r>
+            <a:r>
+              <a:rPr lang="pt-BR" sz="7200" dirty="0">
+                <a:solidFill>
+                  <a:srgbClr val="FF0000"/>
+                </a:solidFill>
+              </a:rPr>
+              <a:t>??</a:t>
+            </a:r>
+            <a:br>
+              <a:rPr lang="pt-BR" sz="7200" dirty="0"/>
+            </a:br>
+            <a:r>
+              <a:rPr lang="pt-BR" sz="7200" dirty="0"/>
+              <a:t>Dormi na Praça </a:t>
+            </a:r>
+            <a:r>
+              <a:rPr lang="pt-BR" sz="7200" dirty="0">
+                <a:solidFill>
+                  <a:srgbClr val="FF0000"/>
+                </a:solidFill>
+              </a:rPr>
+              <a:t>??</a:t>
+            </a:r>
+          </a:p>
+        </p:txBody>
+      </p:sp>
+    </p:spTree>
+    <p:extLst>
+      <p:ext uri="{BB962C8B-B14F-4D97-AF65-F5344CB8AC3E}">
+        <p14:creationId xmlns:p14="http://schemas.microsoft.com/office/powerpoint/2010/main" val="2526099791"/>
       </p:ext>
     </p:extLst>
   </p:cSld>

</xml_diff>

<commit_message>
Acrescenta TEMPORAL DE AMOR e EVIDÊNCIAS ao bloco 35 do ROTA.
Region, tracks, pasta, cartaz e slide (tom ??); repertórios VS e COMPLETO refeitos.

Co-Authored-By: Claude Opus 5.5 <noreply@anthropic.com>
</commit_message>
<xml_diff>
--- a/REPERTÓRIO/Repertório Rota do Chopp - COMPLETO.pptx
+++ b/REPERTÓRIO/Repertório Rota do Chopp - COMPLETO.pptx
@@ -14849,7 +14849,7 @@
     </p:spTree>
     <p:extLst>
       <p:ext uri="{BB962C8B-B14F-4D97-AF65-F5344CB8AC3E}">
-        <p14:creationId xmlns:p14="http://schemas.microsoft.com/office/powerpoint/2010/main" val="3757311472"/>
+        <p14:creationId xmlns:p14="http://schemas.microsoft.com/office/powerpoint/2010/main" val="2089142067"/>
       </p:ext>
     </p:extLst>
   </p:cSld>
@@ -15013,7 +15013,7 @@
     </p:spTree>
     <p:extLst>
       <p:ext uri="{BB962C8B-B14F-4D97-AF65-F5344CB8AC3E}">
-        <p14:creationId xmlns:p14="http://schemas.microsoft.com/office/powerpoint/2010/main" val="4129570783"/>
+        <p14:creationId xmlns:p14="http://schemas.microsoft.com/office/powerpoint/2010/main" val="4030428204"/>
       </p:ext>
     </p:extLst>
   </p:cSld>
@@ -15255,7 +15255,7 @@
     </p:spTree>
     <p:extLst>
       <p:ext uri="{BB962C8B-B14F-4D97-AF65-F5344CB8AC3E}">
-        <p14:creationId xmlns:p14="http://schemas.microsoft.com/office/powerpoint/2010/main" val="3985484919"/>
+        <p14:creationId xmlns:p14="http://schemas.microsoft.com/office/powerpoint/2010/main" val="563476019"/>
       </p:ext>
     </p:extLst>
   </p:cSld>
@@ -15420,7 +15420,7 @@
     </p:spTree>
     <p:extLst>
       <p:ext uri="{BB962C8B-B14F-4D97-AF65-F5344CB8AC3E}">
-        <p14:creationId xmlns:p14="http://schemas.microsoft.com/office/powerpoint/2010/main" val="4043846689"/>
+        <p14:creationId xmlns:p14="http://schemas.microsoft.com/office/powerpoint/2010/main" val="1431852520"/>
       </p:ext>
     </p:extLst>
   </p:cSld>
@@ -15598,7 +15598,7 @@
     </p:spTree>
     <p:extLst>
       <p:ext uri="{BB962C8B-B14F-4D97-AF65-F5344CB8AC3E}">
-        <p14:creationId xmlns:p14="http://schemas.microsoft.com/office/powerpoint/2010/main" val="725496263"/>
+        <p14:creationId xmlns:p14="http://schemas.microsoft.com/office/powerpoint/2010/main" val="361046949"/>
       </p:ext>
     </p:extLst>
   </p:cSld>
@@ -15724,7 +15724,7 @@
     </p:spTree>
     <p:extLst>
       <p:ext uri="{BB962C8B-B14F-4D97-AF65-F5344CB8AC3E}">
-        <p14:creationId xmlns:p14="http://schemas.microsoft.com/office/powerpoint/2010/main" val="617374800"/>
+        <p14:creationId xmlns:p14="http://schemas.microsoft.com/office/powerpoint/2010/main" val="2322386915"/>
       </p:ext>
     </p:extLst>
   </p:cSld>
@@ -16012,7 +16012,7 @@
     </p:spTree>
     <p:extLst>
       <p:ext uri="{BB962C8B-B14F-4D97-AF65-F5344CB8AC3E}">
-        <p14:creationId xmlns:p14="http://schemas.microsoft.com/office/powerpoint/2010/main" val="837478984"/>
+        <p14:creationId xmlns:p14="http://schemas.microsoft.com/office/powerpoint/2010/main" val="2491854916"/>
       </p:ext>
     </p:extLst>
   </p:cSld>
@@ -16138,7 +16138,7 @@
     </p:spTree>
     <p:extLst>
       <p:ext uri="{BB962C8B-B14F-4D97-AF65-F5344CB8AC3E}">
-        <p14:creationId xmlns:p14="http://schemas.microsoft.com/office/powerpoint/2010/main" val="425110700"/>
+        <p14:creationId xmlns:p14="http://schemas.microsoft.com/office/powerpoint/2010/main" val="2269393178"/>
       </p:ext>
     </p:extLst>
   </p:cSld>
@@ -16342,7 +16342,7 @@
     </p:spTree>
     <p:extLst>
       <p:ext uri="{BB962C8B-B14F-4D97-AF65-F5344CB8AC3E}">
-        <p14:creationId xmlns:p14="http://schemas.microsoft.com/office/powerpoint/2010/main" val="383440447"/>
+        <p14:creationId xmlns:p14="http://schemas.microsoft.com/office/powerpoint/2010/main" val="1708532493"/>
       </p:ext>
     </p:extLst>
   </p:cSld>
@@ -16483,7 +16483,7 @@
     </p:spTree>
     <p:extLst>
       <p:ext uri="{BB962C8B-B14F-4D97-AF65-F5344CB8AC3E}">
-        <p14:creationId xmlns:p14="http://schemas.microsoft.com/office/powerpoint/2010/main" val="3556834615"/>
+        <p14:creationId xmlns:p14="http://schemas.microsoft.com/office/powerpoint/2010/main" val="389728738"/>
       </p:ext>
     </p:extLst>
   </p:cSld>
@@ -16669,7 +16669,7 @@
     </p:spTree>
     <p:extLst>
       <p:ext uri="{BB962C8B-B14F-4D97-AF65-F5344CB8AC3E}">
-        <p14:creationId xmlns:p14="http://schemas.microsoft.com/office/powerpoint/2010/main" val="2480040779"/>
+        <p14:creationId xmlns:p14="http://schemas.microsoft.com/office/powerpoint/2010/main" val="3021598653"/>
       </p:ext>
     </p:extLst>
   </p:cSld>
@@ -16823,7 +16823,7 @@
     </p:spTree>
     <p:extLst>
       <p:ext uri="{BB962C8B-B14F-4D97-AF65-F5344CB8AC3E}">
-        <p14:creationId xmlns:p14="http://schemas.microsoft.com/office/powerpoint/2010/main" val="1332279248"/>
+        <p14:creationId xmlns:p14="http://schemas.microsoft.com/office/powerpoint/2010/main" val="3510183714"/>
       </p:ext>
     </p:extLst>
   </p:cSld>
@@ -16964,7 +16964,7 @@
     </p:spTree>
     <p:extLst>
       <p:ext uri="{BB962C8B-B14F-4D97-AF65-F5344CB8AC3E}">
-        <p14:creationId xmlns:p14="http://schemas.microsoft.com/office/powerpoint/2010/main" val="361009882"/>
+        <p14:creationId xmlns:p14="http://schemas.microsoft.com/office/powerpoint/2010/main" val="3631102532"/>
       </p:ext>
     </p:extLst>
   </p:cSld>
@@ -17129,7 +17129,7 @@
     </p:spTree>
     <p:extLst>
       <p:ext uri="{BB962C8B-B14F-4D97-AF65-F5344CB8AC3E}">
-        <p14:creationId xmlns:p14="http://schemas.microsoft.com/office/powerpoint/2010/main" val="381076217"/>
+        <p14:creationId xmlns:p14="http://schemas.microsoft.com/office/powerpoint/2010/main" val="234799058"/>
       </p:ext>
     </p:extLst>
   </p:cSld>
@@ -17270,7 +17270,7 @@
     </p:spTree>
     <p:extLst>
       <p:ext uri="{BB962C8B-B14F-4D97-AF65-F5344CB8AC3E}">
-        <p14:creationId xmlns:p14="http://schemas.microsoft.com/office/powerpoint/2010/main" val="2867383609"/>
+        <p14:creationId xmlns:p14="http://schemas.microsoft.com/office/powerpoint/2010/main" val="2085413432"/>
       </p:ext>
     </p:extLst>
   </p:cSld>
@@ -17396,7 +17396,7 @@
     </p:spTree>
     <p:extLst>
       <p:ext uri="{BB962C8B-B14F-4D97-AF65-F5344CB8AC3E}">
-        <p14:creationId xmlns:p14="http://schemas.microsoft.com/office/powerpoint/2010/main" val="3717431089"/>
+        <p14:creationId xmlns:p14="http://schemas.microsoft.com/office/powerpoint/2010/main" val="1299608314"/>
       </p:ext>
     </p:extLst>
   </p:cSld>
@@ -17759,7 +17759,7 @@
     </p:spTree>
     <p:extLst>
       <p:ext uri="{BB962C8B-B14F-4D97-AF65-F5344CB8AC3E}">
-        <p14:creationId xmlns:p14="http://schemas.microsoft.com/office/powerpoint/2010/main" val="3987736872"/>
+        <p14:creationId xmlns:p14="http://schemas.microsoft.com/office/powerpoint/2010/main" val="4248360019"/>
       </p:ext>
     </p:extLst>
   </p:cSld>
@@ -17925,7 +17925,7 @@
     </p:spTree>
     <p:extLst>
       <p:ext uri="{BB962C8B-B14F-4D97-AF65-F5344CB8AC3E}">
-        <p14:creationId xmlns:p14="http://schemas.microsoft.com/office/powerpoint/2010/main" val="2201469516"/>
+        <p14:creationId xmlns:p14="http://schemas.microsoft.com/office/powerpoint/2010/main" val="1960366677"/>
       </p:ext>
     </p:extLst>
   </p:cSld>
@@ -18066,7 +18066,7 @@
     </p:spTree>
     <p:extLst>
       <p:ext uri="{BB962C8B-B14F-4D97-AF65-F5344CB8AC3E}">
-        <p14:creationId xmlns:p14="http://schemas.microsoft.com/office/powerpoint/2010/main" val="1113714772"/>
+        <p14:creationId xmlns:p14="http://schemas.microsoft.com/office/powerpoint/2010/main" val="2912743868"/>
       </p:ext>
     </p:extLst>
   </p:cSld>
@@ -18204,7 +18204,7 @@
     </p:spTree>
     <p:extLst>
       <p:ext uri="{BB962C8B-B14F-4D97-AF65-F5344CB8AC3E}">
-        <p14:creationId xmlns:p14="http://schemas.microsoft.com/office/powerpoint/2010/main" val="615428593"/>
+        <p14:creationId xmlns:p14="http://schemas.microsoft.com/office/powerpoint/2010/main" val="1228789558"/>
       </p:ext>
     </p:extLst>
   </p:cSld>
@@ -18345,7 +18345,7 @@
     </p:spTree>
     <p:extLst>
       <p:ext uri="{BB962C8B-B14F-4D97-AF65-F5344CB8AC3E}">
-        <p14:creationId xmlns:p14="http://schemas.microsoft.com/office/powerpoint/2010/main" val="848930938"/>
+        <p14:creationId xmlns:p14="http://schemas.microsoft.com/office/powerpoint/2010/main" val="4290407121"/>
       </p:ext>
     </p:extLst>
   </p:cSld>
@@ -18486,7 +18486,7 @@
     </p:spTree>
     <p:extLst>
       <p:ext uri="{BB962C8B-B14F-4D97-AF65-F5344CB8AC3E}">
-        <p14:creationId xmlns:p14="http://schemas.microsoft.com/office/powerpoint/2010/main" val="1232025425"/>
+        <p14:creationId xmlns:p14="http://schemas.microsoft.com/office/powerpoint/2010/main" val="2964182992"/>
       </p:ext>
     </p:extLst>
   </p:cSld>
@@ -18635,7 +18635,7 @@
     </p:spTree>
     <p:extLst>
       <p:ext uri="{BB962C8B-B14F-4D97-AF65-F5344CB8AC3E}">
-        <p14:creationId xmlns:p14="http://schemas.microsoft.com/office/powerpoint/2010/main" val="3479716492"/>
+        <p14:creationId xmlns:p14="http://schemas.microsoft.com/office/powerpoint/2010/main" val="1713249733"/>
       </p:ext>
     </p:extLst>
   </p:cSld>
@@ -18794,7 +18794,7 @@
     </p:spTree>
     <p:extLst>
       <p:ext uri="{BB962C8B-B14F-4D97-AF65-F5344CB8AC3E}">
-        <p14:creationId xmlns:p14="http://schemas.microsoft.com/office/powerpoint/2010/main" val="2483999642"/>
+        <p14:creationId xmlns:p14="http://schemas.microsoft.com/office/powerpoint/2010/main" val="4187109604"/>
       </p:ext>
     </p:extLst>
   </p:cSld>
@@ -18923,7 +18923,7 @@
     </p:spTree>
     <p:extLst>
       <p:ext uri="{BB962C8B-B14F-4D97-AF65-F5344CB8AC3E}">
-        <p14:creationId xmlns:p14="http://schemas.microsoft.com/office/powerpoint/2010/main" val="2546721598"/>
+        <p14:creationId xmlns:p14="http://schemas.microsoft.com/office/powerpoint/2010/main" val="3127466589"/>
       </p:ext>
     </p:extLst>
   </p:cSld>
@@ -19052,7 +19052,7 @@
     </p:spTree>
     <p:extLst>
       <p:ext uri="{BB962C8B-B14F-4D97-AF65-F5344CB8AC3E}">
-        <p14:creationId xmlns:p14="http://schemas.microsoft.com/office/powerpoint/2010/main" val="1926229927"/>
+        <p14:creationId xmlns:p14="http://schemas.microsoft.com/office/powerpoint/2010/main" val="2376823465"/>
       </p:ext>
     </p:extLst>
   </p:cSld>
@@ -19360,7 +19360,7 @@
     </p:spTree>
     <p:extLst>
       <p:ext uri="{BB962C8B-B14F-4D97-AF65-F5344CB8AC3E}">
-        <p14:creationId xmlns:p14="http://schemas.microsoft.com/office/powerpoint/2010/main" val="3701785412"/>
+        <p14:creationId xmlns:p14="http://schemas.microsoft.com/office/powerpoint/2010/main" val="1875749952"/>
       </p:ext>
     </p:extLst>
   </p:cSld>
@@ -19474,7 +19474,7 @@
     </p:spTree>
     <p:extLst>
       <p:ext uri="{BB962C8B-B14F-4D97-AF65-F5344CB8AC3E}">
-        <p14:creationId xmlns:p14="http://schemas.microsoft.com/office/powerpoint/2010/main" val="3958843814"/>
+        <p14:creationId xmlns:p14="http://schemas.microsoft.com/office/powerpoint/2010/main" val="3588785989"/>
       </p:ext>
     </p:extLst>
   </p:cSld>
@@ -19633,7 +19633,7 @@
     </p:spTree>
     <p:extLst>
       <p:ext uri="{BB962C8B-B14F-4D97-AF65-F5344CB8AC3E}">
-        <p14:creationId xmlns:p14="http://schemas.microsoft.com/office/powerpoint/2010/main" val="4108880505"/>
+        <p14:creationId xmlns:p14="http://schemas.microsoft.com/office/powerpoint/2010/main" val="3672496690"/>
       </p:ext>
     </p:extLst>
   </p:cSld>
@@ -19762,7 +19762,7 @@
     </p:spTree>
     <p:extLst>
       <p:ext uri="{BB962C8B-B14F-4D97-AF65-F5344CB8AC3E}">
-        <p14:creationId xmlns:p14="http://schemas.microsoft.com/office/powerpoint/2010/main" val="2132989991"/>
+        <p14:creationId xmlns:p14="http://schemas.microsoft.com/office/powerpoint/2010/main" val="3086042836"/>
       </p:ext>
     </p:extLst>
   </p:cSld>
@@ -19891,7 +19891,7 @@
     </p:spTree>
     <p:extLst>
       <p:ext uri="{BB962C8B-B14F-4D97-AF65-F5344CB8AC3E}">
-        <p14:creationId xmlns:p14="http://schemas.microsoft.com/office/powerpoint/2010/main" val="3130659454"/>
+        <p14:creationId xmlns:p14="http://schemas.microsoft.com/office/powerpoint/2010/main" val="2158055679"/>
       </p:ext>
     </p:extLst>
   </p:cSld>
@@ -20020,7 +20020,7 @@
     </p:spTree>
     <p:extLst>
       <p:ext uri="{BB962C8B-B14F-4D97-AF65-F5344CB8AC3E}">
-        <p14:creationId xmlns:p14="http://schemas.microsoft.com/office/powerpoint/2010/main" val="1915499331"/>
+        <p14:creationId xmlns:p14="http://schemas.microsoft.com/office/powerpoint/2010/main" val="4194378947"/>
       </p:ext>
     </p:extLst>
   </p:cSld>
@@ -20119,7 +20119,7 @@
     </p:spTree>
     <p:extLst>
       <p:ext uri="{BB962C8B-B14F-4D97-AF65-F5344CB8AC3E}">
-        <p14:creationId xmlns:p14="http://schemas.microsoft.com/office/powerpoint/2010/main" val="615709339"/>
+        <p14:creationId xmlns:p14="http://schemas.microsoft.com/office/powerpoint/2010/main" val="1444003938"/>
       </p:ext>
     </p:extLst>
   </p:cSld>
@@ -20248,7 +20248,7 @@
     </p:spTree>
     <p:extLst>
       <p:ext uri="{BB962C8B-B14F-4D97-AF65-F5344CB8AC3E}">
-        <p14:creationId xmlns:p14="http://schemas.microsoft.com/office/powerpoint/2010/main" val="658313605"/>
+        <p14:creationId xmlns:p14="http://schemas.microsoft.com/office/powerpoint/2010/main" val="3833491578"/>
       </p:ext>
     </p:extLst>
   </p:cSld>
@@ -20371,13 +20371,43 @@
               </a:rPr>
               <a:t>??</a:t>
             </a:r>
+            <a:br>
+              <a:rPr lang="pt-BR" sz="7200" dirty="0"/>
+            </a:br>
+            <a:r>
+              <a:rPr lang="pt-BR" sz="7200" dirty="0"/>
+              <a:t>Temporal de Amor </a:t>
+            </a:r>
+            <a:r>
+              <a:rPr lang="pt-BR" sz="7200" dirty="0">
+                <a:solidFill>
+                  <a:srgbClr val="FF0000"/>
+                </a:solidFill>
+              </a:rPr>
+              <a:t>??</a:t>
+            </a:r>
+            <a:br>
+              <a:rPr lang="pt-BR" sz="7200" dirty="0"/>
+            </a:br>
+            <a:r>
+              <a:rPr lang="pt-BR" sz="7200" dirty="0"/>
+              <a:t>Evidências </a:t>
+            </a:r>
+            <a:r>
+              <a:rPr lang="pt-BR" sz="7200" dirty="0">
+                <a:solidFill>
+                  <a:srgbClr val="FF0000"/>
+                </a:solidFill>
+              </a:rPr>
+              <a:t>??</a:t>
+            </a:r>
           </a:p>
         </p:txBody>
       </p:sp>
     </p:spTree>
     <p:extLst>
       <p:ext uri="{BB962C8B-B14F-4D97-AF65-F5344CB8AC3E}">
-        <p14:creationId xmlns:p14="http://schemas.microsoft.com/office/powerpoint/2010/main" val="2526099791"/>
+        <p14:creationId xmlns:p14="http://schemas.microsoft.com/office/powerpoint/2010/main" val="114692999"/>
       </p:ext>
     </p:extLst>
   </p:cSld>

</xml_diff>

<commit_message>
Põe no COMPLETO a capa AO VIVO no padrão dos VS e a capa dos VS antes dos blocos VS.
A capa (REPERTÓRIO/Capa AO VIVO.jpg, "capa" no completo do projeto.json)
ocupa o slide 1 no lugar da do AO VIVO, que não muda. O
montar_repertorio_completo.py agora traz os slides VS inteiros, com a capa.

Co-Authored-By: Claude Opus 5.5 <noreply@anthropic.com>
</commit_message>
<xml_diff>
--- a/REPERTÓRIO/Repertório Rota do Chopp - COMPLETO.pptx
+++ b/REPERTÓRIO/Repertório Rota do Chopp - COMPLETO.pptx
@@ -5,10 +5,10 @@
     <p:sldMasterId id="2147483804" r:id="rId1"/>
   </p:sldMasterIdLst>
   <p:handoutMasterIdLst>
-    <p:handoutMasterId r:id="rId100"/>
+    <p:handoutMasterId r:id="rId101"/>
   </p:handoutMasterIdLst>
   <p:sldIdLst>
-    <p:sldId id="392" r:id="rId2"/>
+    <p:sldId id="484" r:id="rId2"/>
     <p:sldId id="416" r:id="rId3"/>
     <p:sldId id="381" r:id="rId4"/>
     <p:sldId id="382" r:id="rId5"/>
@@ -71,41 +71,42 @@
     <p:sldId id="442" r:id="rId62"/>
     <p:sldId id="443" r:id="rId63"/>
     <p:sldId id="444" r:id="rId64"/>
-    <p:sldId id="462" r:id="rId65"/>
-    <p:sldId id="445" r:id="rId66"/>
-    <p:sldId id="463" r:id="rId67"/>
-    <p:sldId id="446" r:id="rId68"/>
-    <p:sldId id="464" r:id="rId69"/>
-    <p:sldId id="447" r:id="rId70"/>
-    <p:sldId id="448" r:id="rId71"/>
-    <p:sldId id="449" r:id="rId72"/>
-    <p:sldId id="465" r:id="rId73"/>
-    <p:sldId id="450" r:id="rId74"/>
-    <p:sldId id="451" r:id="rId75"/>
-    <p:sldId id="452" r:id="rId76"/>
-    <p:sldId id="468" r:id="rId77"/>
-    <p:sldId id="453" r:id="rId78"/>
-    <p:sldId id="455" r:id="rId79"/>
-    <p:sldId id="456" r:id="rId80"/>
-    <p:sldId id="466" r:id="rId81"/>
-    <p:sldId id="467" r:id="rId82"/>
-    <p:sldId id="457" r:id="rId83"/>
-    <p:sldId id="458" r:id="rId84"/>
-    <p:sldId id="459" r:id="rId85"/>
-    <p:sldId id="460" r:id="rId86"/>
-    <p:sldId id="461" r:id="rId87"/>
-    <p:sldId id="469" r:id="rId88"/>
-    <p:sldId id="470" r:id="rId89"/>
-    <p:sldId id="471" r:id="rId90"/>
-    <p:sldId id="472" r:id="rId91"/>
-    <p:sldId id="473" r:id="rId92"/>
-    <p:sldId id="474" r:id="rId93"/>
-    <p:sldId id="475" r:id="rId94"/>
-    <p:sldId id="476" r:id="rId95"/>
-    <p:sldId id="477" r:id="rId96"/>
-    <p:sldId id="481" r:id="rId97"/>
-    <p:sldId id="482" r:id="rId98"/>
-    <p:sldId id="483" r:id="rId99"/>
+    <p:sldId id="480" r:id="rId65"/>
+    <p:sldId id="462" r:id="rId66"/>
+    <p:sldId id="445" r:id="rId67"/>
+    <p:sldId id="463" r:id="rId68"/>
+    <p:sldId id="446" r:id="rId69"/>
+    <p:sldId id="464" r:id="rId70"/>
+    <p:sldId id="447" r:id="rId71"/>
+    <p:sldId id="448" r:id="rId72"/>
+    <p:sldId id="449" r:id="rId73"/>
+    <p:sldId id="465" r:id="rId74"/>
+    <p:sldId id="450" r:id="rId75"/>
+    <p:sldId id="451" r:id="rId76"/>
+    <p:sldId id="452" r:id="rId77"/>
+    <p:sldId id="468" r:id="rId78"/>
+    <p:sldId id="453" r:id="rId79"/>
+    <p:sldId id="455" r:id="rId80"/>
+    <p:sldId id="456" r:id="rId81"/>
+    <p:sldId id="466" r:id="rId82"/>
+    <p:sldId id="467" r:id="rId83"/>
+    <p:sldId id="457" r:id="rId84"/>
+    <p:sldId id="458" r:id="rId85"/>
+    <p:sldId id="459" r:id="rId86"/>
+    <p:sldId id="460" r:id="rId87"/>
+    <p:sldId id="461" r:id="rId88"/>
+    <p:sldId id="469" r:id="rId89"/>
+    <p:sldId id="470" r:id="rId90"/>
+    <p:sldId id="471" r:id="rId91"/>
+    <p:sldId id="472" r:id="rId92"/>
+    <p:sldId id="473" r:id="rId93"/>
+    <p:sldId id="474" r:id="rId94"/>
+    <p:sldId id="475" r:id="rId95"/>
+    <p:sldId id="476" r:id="rId96"/>
+    <p:sldId id="477" r:id="rId97"/>
+    <p:sldId id="481" r:id="rId98"/>
+    <p:sldId id="482" r:id="rId99"/>
+    <p:sldId id="483" r:id="rId100"/>
   </p:sldIdLst>
   <p:sldSz cx="12192000" cy="6858000"/>
   <p:notesSz cx="6858000" cy="9144000"/>
@@ -6179,37 +6180,9 @@
 <file path=ppt/slides/slide1.xml><?xml version="1.0" encoding="utf-8"?>
 <p:sld xmlns:a="http://schemas.openxmlformats.org/drawingml/2006/main" xmlns:r="http://schemas.openxmlformats.org/officeDocument/2006/relationships" xmlns:p="http://schemas.openxmlformats.org/presentationml/2006/main">
   <p:cSld>
-    <p:bg>
-      <p:bgPr>
-        <a:blipFill rotWithShape="1">
-          <a:blip r:embed="rId2">
-            <a:duotone>
-              <a:schemeClr val="bg2">
-                <a:shade val="18000"/>
-                <a:satMod val="160000"/>
-                <a:lumMod val="28000"/>
-              </a:schemeClr>
-              <a:schemeClr val="bg2">
-                <a:tint val="95000"/>
-                <a:satMod val="160000"/>
-                <a:lumMod val="116000"/>
-              </a:schemeClr>
-            </a:duotone>
-          </a:blip>
-          <a:stretch/>
-        </a:blipFill>
-        <a:effectLst/>
-      </p:bgPr>
-    </p:bg>
     <p:spTree>
       <p:nvGrpSpPr>
-        <p:cNvPr id="1" name="">
-          <a:extLst>
-            <a:ext uri="{FF2B5EF4-FFF2-40B4-BE49-F238E27FC236}">
-              <a16:creationId xmlns:a16="http://schemas.microsoft.com/office/drawing/2014/main" id="{EBD8B078-B005-E808-C1F2-7D52408ED104}"/>
-            </a:ext>
-          </a:extLst>
-        </p:cNvPr>
+        <p:cNvPr id="1" name=""/>
         <p:cNvGrpSpPr/>
         <p:nvPr/>
       </p:nvGrpSpPr>
@@ -6221,104 +6194,22 @@
           <a:chExt cx="0" cy="0"/>
         </a:xfrm>
       </p:grpSpPr>
-      <p:sp>
-        <p:nvSpPr>
-          <p:cNvPr id="10" name="Rectangle 8">
+      <p:pic>
+        <p:nvPicPr>
+          <p:cNvPr id="3" name="Imagem 2">
             <a:extLst>
               <a:ext uri="{FF2B5EF4-FFF2-40B4-BE49-F238E27FC236}">
-                <a16:creationId xmlns:a16="http://schemas.microsoft.com/office/drawing/2014/main" id="{BF99D510-C769-4A3F-B1BF-0A2F3822AED2}"/>
-              </a:ext>
-              <a:ext uri="{C183D7F6-B498-43B3-948B-1728B52AA6E4}">
-                <adec:decorative xmlns:adec="http://schemas.microsoft.com/office/drawing/2017/decorative" val="1"/>
-              </a:ext>
-            </a:extLst>
-          </p:cNvPr>
-          <p:cNvSpPr>
-            <a:spLocks noGrp="1" noRot="1" noChangeAspect="1" noMove="1" noResize="1" noEditPoints="1" noAdjustHandles="1" noChangeArrowheads="1" noChangeShapeType="1" noTextEdit="1"/>
-          </p:cNvSpPr>
-          <p:nvPr>
-            <p:extLst>
-              <p:ext uri="{386F3935-93C4-4BCD-93E2-E3B085C9AB24}">
-                <p16:designElem xmlns:p16="http://schemas.microsoft.com/office/powerpoint/2015/main" val="1"/>
-              </p:ext>
-            </p:extLst>
-          </p:nvPr>
-        </p:nvSpPr>
-        <p:spPr>
-          <a:xfrm>
-            <a:off x="752474" y="733425"/>
-            <a:ext cx="10693662" cy="5391150"/>
-          </a:xfrm>
-          <a:prstGeom prst="rect">
-            <a:avLst/>
-          </a:prstGeom>
-          <a:solidFill>
-            <a:srgbClr val="FFFFFF"/>
-          </a:solidFill>
-          <a:ln w="190500" cap="sq">
-            <a:solidFill>
-              <a:srgbClr val="FFFFFF"/>
-            </a:solidFill>
-            <a:miter lim="800000"/>
-          </a:ln>
-          <a:effectLst>
-            <a:outerShdw blurRad="54991" dist="17780" dir="5400000" algn="ctr" rotWithShape="0">
-              <a:schemeClr val="bg1">
-                <a:alpha val="40000"/>
-              </a:schemeClr>
-            </a:outerShdw>
-          </a:effectLst>
-          <a:scene3d>
-            <a:camera prst="orthographicFront"/>
-            <a:lightRig rig="twoPt" dir="t">
-              <a:rot lat="0" lon="0" rev="7200000"/>
-            </a:lightRig>
-          </a:scene3d>
-          <a:sp3d>
-            <a:bevelT w="25400" h="19050"/>
-          </a:sp3d>
-        </p:spPr>
-        <p:style>
-          <a:lnRef idx="2">
-            <a:schemeClr val="accent1">
-              <a:shade val="50000"/>
-            </a:schemeClr>
-          </a:lnRef>
-          <a:fillRef idx="1">
-            <a:schemeClr val="accent1"/>
-          </a:fillRef>
-          <a:effectRef idx="0">
-            <a:schemeClr val="accent1"/>
-          </a:effectRef>
-          <a:fontRef idx="minor">
-            <a:schemeClr val="lt1"/>
-          </a:fontRef>
-        </p:style>
-        <p:txBody>
-          <a:bodyPr rtlCol="0" anchor="ctr"/>
-          <a:lstStyle/>
-          <a:p>
-            <a:pPr algn="ctr"/>
-            <a:endParaRPr lang="en-US"/>
-          </a:p>
-        </p:txBody>
-      </p:sp>
-      <p:pic>
-        <p:nvPicPr>
-          <p:cNvPr id="4" name="Imagem 3" descr="Logotipo&#10;&#10;Descrição gerada automaticamente">
-            <a:extLst>
-              <a:ext uri="{FF2B5EF4-FFF2-40B4-BE49-F238E27FC236}">
-                <a16:creationId xmlns:a16="http://schemas.microsoft.com/office/drawing/2014/main" id="{7F9E0B70-3AAE-571C-AFEA-4C3555AB4614}"/>
+                <a16:creationId xmlns:a16="http://schemas.microsoft.com/office/drawing/2014/main" id="{F429F386-107B-1B77-F7FD-6B74855304D9}"/>
               </a:ext>
             </a:extLst>
           </p:cNvPr>
           <p:cNvPicPr>
-            <a:picLocks noChangeAspect="1"/>
+            <a:picLocks/>
           </p:cNvPicPr>
           <p:nvPr/>
         </p:nvPicPr>
         <p:blipFill>
-          <a:blip r:embed="rId3">
+          <a:blip r:embed="rId2">
             <a:extLst>
               <a:ext uri="{28A0092B-C50C-407E-A947-70E740481C1C}">
                 <a14:useLocalDpi xmlns:a14="http://schemas.microsoft.com/office/drawing/2010/main" val="0"/>
@@ -6331,81 +6222,18 @@
         </p:blipFill>
         <p:spPr>
           <a:xfrm>
-            <a:off x="3789762" y="1114868"/>
-            <a:ext cx="4628265" cy="4628265"/>
+            <a:off x="0" y="0"/>
+            <a:ext cx="12192000" cy="6858000"/>
           </a:xfrm>
           <a:prstGeom prst="rect">
             <a:avLst/>
           </a:prstGeom>
         </p:spPr>
       </p:pic>
-      <p:sp>
-        <p:nvSpPr>
-          <p:cNvPr id="12" name="Rectangle 10">
-            <a:extLst>
-              <a:ext uri="{FF2B5EF4-FFF2-40B4-BE49-F238E27FC236}">
-                <a16:creationId xmlns:a16="http://schemas.microsoft.com/office/drawing/2014/main" id="{62DD38F0-3136-4D36-9445-AAF26688FF04}"/>
-              </a:ext>
-              <a:ext uri="{C183D7F6-B498-43B3-948B-1728B52AA6E4}">
-                <adec:decorative xmlns:adec="http://schemas.microsoft.com/office/drawing/2017/decorative" val="1"/>
-              </a:ext>
-            </a:extLst>
-          </p:cNvPr>
-          <p:cNvSpPr>
-            <a:spLocks noGrp="1" noRot="1" noChangeAspect="1" noMove="1" noResize="1" noEditPoints="1" noAdjustHandles="1" noChangeArrowheads="1" noChangeShapeType="1" noTextEdit="1"/>
-          </p:cNvSpPr>
-          <p:nvPr>
-            <p:extLst>
-              <p:ext uri="{386F3935-93C4-4BCD-93E2-E3B085C9AB24}">
-                <p16:designElem xmlns:p16="http://schemas.microsoft.com/office/powerpoint/2015/main" val="1"/>
-              </p:ext>
-            </p:extLst>
-          </p:nvPr>
-        </p:nvSpPr>
-        <p:spPr>
-          <a:xfrm>
-            <a:off x="812496" y="799817"/>
-            <a:ext cx="10575170" cy="5258367"/>
-          </a:xfrm>
-          <a:prstGeom prst="rect">
-            <a:avLst/>
-          </a:prstGeom>
-          <a:noFill/>
-          <a:ln w="12700">
-            <a:solidFill>
-              <a:schemeClr val="bg2"/>
-            </a:solidFill>
-          </a:ln>
-        </p:spPr>
-        <p:style>
-          <a:lnRef idx="2">
-            <a:schemeClr val="accent1">
-              <a:shade val="50000"/>
-            </a:schemeClr>
-          </a:lnRef>
-          <a:fillRef idx="1">
-            <a:schemeClr val="accent1"/>
-          </a:fillRef>
-          <a:effectRef idx="0">
-            <a:schemeClr val="accent1"/>
-          </a:effectRef>
-          <a:fontRef idx="minor">
-            <a:schemeClr val="lt1"/>
-          </a:fontRef>
-        </p:style>
-        <p:txBody>
-          <a:bodyPr rtlCol="0" anchor="ctr"/>
-          <a:lstStyle/>
-          <a:p>
-            <a:pPr algn="ctr"/>
-            <a:endParaRPr lang="en-US"/>
-          </a:p>
-        </p:txBody>
-      </p:sp>
     </p:spTree>
     <p:extLst>
       <p:ext uri="{BB962C8B-B14F-4D97-AF65-F5344CB8AC3E}">
-        <p14:creationId xmlns:p14="http://schemas.microsoft.com/office/powerpoint/2010/main" val="1330358702"/>
+        <p14:creationId xmlns:p14="http://schemas.microsoft.com/office/powerpoint/2010/main" val="1857954803"/>
       </p:ext>
     </p:extLst>
   </p:cSld>
@@ -14660,6 +14488,72 @@
   <p:cSld>
     <p:spTree>
       <p:nvGrpSpPr>
+        <p:cNvPr id="1" name=""/>
+        <p:cNvGrpSpPr/>
+        <p:nvPr/>
+      </p:nvGrpSpPr>
+      <p:grpSpPr>
+        <a:xfrm>
+          <a:off x="0" y="0"/>
+          <a:ext cx="0" cy="0"/>
+          <a:chOff x="0" y="0"/>
+          <a:chExt cx="0" cy="0"/>
+        </a:xfrm>
+      </p:grpSpPr>
+      <p:pic>
+        <p:nvPicPr>
+          <p:cNvPr id="3" name="Capa VS">
+            <a:extLst>
+              <a:ext uri="{FF2B5EF4-FFF2-40B4-BE49-F238E27FC236}">
+                <a16:creationId xmlns:a16="http://schemas.microsoft.com/office/drawing/2014/main" id="{57E9E2DE-BD3C-CBFB-A830-6AC70E98ED60}"/>
+              </a:ext>
+            </a:extLst>
+          </p:cNvPr>
+          <p:cNvPicPr>
+            <a:picLocks/>
+          </p:cNvPicPr>
+          <p:nvPr/>
+        </p:nvPicPr>
+        <p:blipFill>
+          <a:blip r:embed="rId2">
+            <a:extLst>
+              <a:ext uri="{28A0092B-C50C-407E-A947-70E740481C1C}">
+                <a14:useLocalDpi xmlns:a14="http://schemas.microsoft.com/office/drawing/2010/main" val="0"/>
+              </a:ext>
+            </a:extLst>
+          </a:blip>
+          <a:stretch>
+            <a:fillRect/>
+          </a:stretch>
+        </p:blipFill>
+        <p:spPr>
+          <a:xfrm>
+            <a:off x="0" y="0"/>
+            <a:ext cx="12192000" cy="6858000"/>
+          </a:xfrm>
+          <a:prstGeom prst="rect">
+            <a:avLst/>
+          </a:prstGeom>
+        </p:spPr>
+      </p:pic>
+    </p:spTree>
+    <p:extLst>
+      <p:ext uri="{BB962C8B-B14F-4D97-AF65-F5344CB8AC3E}">
+        <p14:creationId xmlns:p14="http://schemas.microsoft.com/office/powerpoint/2010/main" val="1701172766"/>
+      </p:ext>
+    </p:extLst>
+  </p:cSld>
+  <p:clrMapOvr>
+    <a:masterClrMapping/>
+  </p:clrMapOvr>
+</p:sld>
+</file>
+
+<file path=ppt/slides/slide65.xml><?xml version="1.0" encoding="utf-8"?>
+<p:sld xmlns:a="http://schemas.openxmlformats.org/drawingml/2006/main" xmlns:r="http://schemas.openxmlformats.org/officeDocument/2006/relationships" xmlns:p="http://schemas.openxmlformats.org/presentationml/2006/main">
+  <p:cSld>
+    <p:spTree>
+      <p:nvGrpSpPr>
         <p:cNvPr id="1" name="">
           <a:extLst>
             <a:ext uri="{FF2B5EF4-FFF2-40B4-BE49-F238E27FC236}">
@@ -14849,7 +14743,7 @@
     </p:spTree>
     <p:extLst>
       <p:ext uri="{BB962C8B-B14F-4D97-AF65-F5344CB8AC3E}">
-        <p14:creationId xmlns:p14="http://schemas.microsoft.com/office/powerpoint/2010/main" val="2089142067"/>
+        <p14:creationId xmlns:p14="http://schemas.microsoft.com/office/powerpoint/2010/main" val="3909828367"/>
       </p:ext>
     </p:extLst>
   </p:cSld>
@@ -14859,7 +14753,7 @@
 </p:sld>
 </file>
 
-<file path=ppt/slides/slide65.xml><?xml version="1.0" encoding="utf-8"?>
+<file path=ppt/slides/slide66.xml><?xml version="1.0" encoding="utf-8"?>
 <p:sld xmlns:a="http://schemas.openxmlformats.org/drawingml/2006/main" xmlns:r="http://schemas.openxmlformats.org/officeDocument/2006/relationships" xmlns:p="http://schemas.openxmlformats.org/presentationml/2006/main">
   <p:cSld>
     <p:spTree>
@@ -15013,7 +14907,7 @@
     </p:spTree>
     <p:extLst>
       <p:ext uri="{BB962C8B-B14F-4D97-AF65-F5344CB8AC3E}">
-        <p14:creationId xmlns:p14="http://schemas.microsoft.com/office/powerpoint/2010/main" val="4030428204"/>
+        <p14:creationId xmlns:p14="http://schemas.microsoft.com/office/powerpoint/2010/main" val="78001677"/>
       </p:ext>
     </p:extLst>
   </p:cSld>
@@ -15023,7 +14917,7 @@
 </p:sld>
 </file>
 
-<file path=ppt/slides/slide66.xml><?xml version="1.0" encoding="utf-8"?>
+<file path=ppt/slides/slide67.xml><?xml version="1.0" encoding="utf-8"?>
 <p:sld xmlns:a="http://schemas.openxmlformats.org/drawingml/2006/main" xmlns:r="http://schemas.openxmlformats.org/officeDocument/2006/relationships" xmlns:p="http://schemas.openxmlformats.org/presentationml/2006/main">
   <p:cSld>
     <p:spTree>
@@ -15255,7 +15149,7 @@
     </p:spTree>
     <p:extLst>
       <p:ext uri="{BB962C8B-B14F-4D97-AF65-F5344CB8AC3E}">
-        <p14:creationId xmlns:p14="http://schemas.microsoft.com/office/powerpoint/2010/main" val="563476019"/>
+        <p14:creationId xmlns:p14="http://schemas.microsoft.com/office/powerpoint/2010/main" val="833599022"/>
       </p:ext>
     </p:extLst>
   </p:cSld>
@@ -15265,7 +15159,7 @@
 </p:sld>
 </file>
 
-<file path=ppt/slides/slide67.xml><?xml version="1.0" encoding="utf-8"?>
+<file path=ppt/slides/slide68.xml><?xml version="1.0" encoding="utf-8"?>
 <p:sld xmlns:a="http://schemas.openxmlformats.org/drawingml/2006/main" xmlns:r="http://schemas.openxmlformats.org/officeDocument/2006/relationships" xmlns:p="http://schemas.openxmlformats.org/presentationml/2006/main">
   <p:cSld>
     <p:spTree>
@@ -15420,7 +15314,7 @@
     </p:spTree>
     <p:extLst>
       <p:ext uri="{BB962C8B-B14F-4D97-AF65-F5344CB8AC3E}">
-        <p14:creationId xmlns:p14="http://schemas.microsoft.com/office/powerpoint/2010/main" val="1431852520"/>
+        <p14:creationId xmlns:p14="http://schemas.microsoft.com/office/powerpoint/2010/main" val="2434061000"/>
       </p:ext>
     </p:extLst>
   </p:cSld>
@@ -15430,7 +15324,7 @@
 </p:sld>
 </file>
 
-<file path=ppt/slides/slide68.xml><?xml version="1.0" encoding="utf-8"?>
+<file path=ppt/slides/slide69.xml><?xml version="1.0" encoding="utf-8"?>
 <p:sld xmlns:a="http://schemas.openxmlformats.org/drawingml/2006/main" xmlns:r="http://schemas.openxmlformats.org/officeDocument/2006/relationships" xmlns:p="http://schemas.openxmlformats.org/presentationml/2006/main">
   <p:cSld>
     <p:spTree>
@@ -15598,133 +15492,7 @@
     </p:spTree>
     <p:extLst>
       <p:ext uri="{BB962C8B-B14F-4D97-AF65-F5344CB8AC3E}">
-        <p14:creationId xmlns:p14="http://schemas.microsoft.com/office/powerpoint/2010/main" val="361046949"/>
-      </p:ext>
-    </p:extLst>
-  </p:cSld>
-  <p:clrMapOvr>
-    <a:masterClrMapping/>
-  </p:clrMapOvr>
-</p:sld>
-</file>
-
-<file path=ppt/slides/slide69.xml><?xml version="1.0" encoding="utf-8"?>
-<p:sld xmlns:a="http://schemas.openxmlformats.org/drawingml/2006/main" xmlns:r="http://schemas.openxmlformats.org/officeDocument/2006/relationships" xmlns:p="http://schemas.openxmlformats.org/presentationml/2006/main">
-  <p:cSld>
-    <p:spTree>
-      <p:nvGrpSpPr>
-        <p:cNvPr id="1" name="">
-          <a:extLst>
-            <a:ext uri="{FF2B5EF4-FFF2-40B4-BE49-F238E27FC236}">
-              <a16:creationId xmlns:a16="http://schemas.microsoft.com/office/drawing/2014/main" id="{4B1F9B04-E36D-CFC9-424B-663C997F3B62}"/>
-            </a:ext>
-          </a:extLst>
-        </p:cNvPr>
-        <p:cNvGrpSpPr/>
-        <p:nvPr/>
-      </p:nvGrpSpPr>
-      <p:grpSpPr>
-        <a:xfrm>
-          <a:off x="0" y="0"/>
-          <a:ext cx="0" cy="0"/>
-          <a:chOff x="0" y="0"/>
-          <a:chExt cx="0" cy="0"/>
-        </a:xfrm>
-      </p:grpSpPr>
-      <p:sp>
-        <p:nvSpPr>
-          <p:cNvPr id="3" name="Espaço Reservado para Conteúdo 2">
-            <a:extLst>
-              <a:ext uri="{FF2B5EF4-FFF2-40B4-BE49-F238E27FC236}">
-                <a16:creationId xmlns:a16="http://schemas.microsoft.com/office/drawing/2014/main" id="{D70FA326-5BDF-6400-83DF-E705E9993E0D}"/>
-              </a:ext>
-            </a:extLst>
-          </p:cNvPr>
-          <p:cNvSpPr>
-            <a:spLocks noGrp="1"/>
-          </p:cNvSpPr>
-          <p:nvPr>
-            <p:ph idx="1"/>
-          </p:nvPr>
-        </p:nvSpPr>
-        <p:spPr>
-          <a:xfrm>
-            <a:off x="10509" y="-3937"/>
-            <a:ext cx="12181491" cy="6861937"/>
-          </a:xfrm>
-        </p:spPr>
-        <p:txBody>
-          <a:bodyPr>
-            <a:noAutofit/>
-          </a:bodyPr>
-          <a:lstStyle/>
-          <a:p>
-            <a:pPr algn="ctr">
-              <a:lnSpc>
-                <a:spcPct val="100000"/>
-              </a:lnSpc>
-              <a:buNone/>
-            </a:pPr>
-            <a:r>
-              <a:rPr lang="en-US" sz="8800" dirty="0">
-                <a:solidFill>
-                  <a:srgbClr val="FF0000"/>
-                </a:solidFill>
-                <a:cs typeface="Arial" panose="020B0604020202020204" pitchFamily="34" charset="0"/>
-              </a:rPr>
-              <a:t>VS BLOCO 6</a:t>
-            </a:r>
-          </a:p>
-          <a:p>
-            <a:pPr marL="36000" indent="-252000" algn="ctr">
-              <a:lnSpc>
-                <a:spcPct val="100000"/>
-              </a:lnSpc>
-              <a:spcBef>
-                <a:spcPts val="0"/>
-              </a:spcBef>
-              <a:buNone/>
-            </a:pPr>
-            <a:r>
-              <a:rPr lang="pt-BR" sz="7200" dirty="0"/>
-              <a:t>Catchaqueira </a:t>
-            </a:r>
-            <a:r>
-              <a:rPr lang="pt-BR" sz="7200" dirty="0">
-                <a:solidFill>
-                  <a:srgbClr val="FF0000"/>
-                </a:solidFill>
-              </a:rPr>
-              <a:t>Sol</a:t>
-            </a:r>
-            <a:br>
-              <a:rPr lang="pt-BR" sz="7200" dirty="0"/>
-            </a:br>
-            <a:r>
-              <a:rPr lang="pt-BR" sz="7200" dirty="0"/>
-              <a:t>Luz Da Minha Vida </a:t>
-            </a:r>
-            <a:r>
-              <a:rPr lang="pt-BR" sz="7200" dirty="0">
-                <a:solidFill>
-                  <a:srgbClr val="FF0000"/>
-                </a:solidFill>
-              </a:rPr>
-              <a:t>Sol</a:t>
-            </a:r>
-            <a:endParaRPr lang="pt-BR" sz="8000" dirty="0">
-              <a:solidFill>
-                <a:srgbClr val="FF0000"/>
-              </a:solidFill>
-              <a:cs typeface="Arial" panose="020B0604020202020204" pitchFamily="34" charset="0"/>
-            </a:endParaRPr>
-          </a:p>
-        </p:txBody>
-      </p:sp>
-    </p:spTree>
-    <p:extLst>
-      <p:ext uri="{BB962C8B-B14F-4D97-AF65-F5344CB8AC3E}">
-        <p14:creationId xmlns:p14="http://schemas.microsoft.com/office/powerpoint/2010/main" val="2322386915"/>
+        <p14:creationId xmlns:p14="http://schemas.microsoft.com/office/powerpoint/2010/main" val="1742158037"/>
       </p:ext>
     </p:extLst>
   </p:cSld>
@@ -15889,6 +15657,132 @@
         <p:cNvPr id="1" name="">
           <a:extLst>
             <a:ext uri="{FF2B5EF4-FFF2-40B4-BE49-F238E27FC236}">
+              <a16:creationId xmlns:a16="http://schemas.microsoft.com/office/drawing/2014/main" id="{4B1F9B04-E36D-CFC9-424B-663C997F3B62}"/>
+            </a:ext>
+          </a:extLst>
+        </p:cNvPr>
+        <p:cNvGrpSpPr/>
+        <p:nvPr/>
+      </p:nvGrpSpPr>
+      <p:grpSpPr>
+        <a:xfrm>
+          <a:off x="0" y="0"/>
+          <a:ext cx="0" cy="0"/>
+          <a:chOff x="0" y="0"/>
+          <a:chExt cx="0" cy="0"/>
+        </a:xfrm>
+      </p:grpSpPr>
+      <p:sp>
+        <p:nvSpPr>
+          <p:cNvPr id="3" name="Espaço Reservado para Conteúdo 2">
+            <a:extLst>
+              <a:ext uri="{FF2B5EF4-FFF2-40B4-BE49-F238E27FC236}">
+                <a16:creationId xmlns:a16="http://schemas.microsoft.com/office/drawing/2014/main" id="{D70FA326-5BDF-6400-83DF-E705E9993E0D}"/>
+              </a:ext>
+            </a:extLst>
+          </p:cNvPr>
+          <p:cNvSpPr>
+            <a:spLocks noGrp="1"/>
+          </p:cNvSpPr>
+          <p:nvPr>
+            <p:ph idx="1"/>
+          </p:nvPr>
+        </p:nvSpPr>
+        <p:spPr>
+          <a:xfrm>
+            <a:off x="10509" y="-3937"/>
+            <a:ext cx="12181491" cy="6861937"/>
+          </a:xfrm>
+        </p:spPr>
+        <p:txBody>
+          <a:bodyPr>
+            <a:noAutofit/>
+          </a:bodyPr>
+          <a:lstStyle/>
+          <a:p>
+            <a:pPr algn="ctr">
+              <a:lnSpc>
+                <a:spcPct val="100000"/>
+              </a:lnSpc>
+              <a:buNone/>
+            </a:pPr>
+            <a:r>
+              <a:rPr lang="en-US" sz="8800" dirty="0">
+                <a:solidFill>
+                  <a:srgbClr val="FF0000"/>
+                </a:solidFill>
+                <a:cs typeface="Arial" panose="020B0604020202020204" pitchFamily="34" charset="0"/>
+              </a:rPr>
+              <a:t>VS BLOCO 6</a:t>
+            </a:r>
+          </a:p>
+          <a:p>
+            <a:pPr marL="36000" indent="-252000" algn="ctr">
+              <a:lnSpc>
+                <a:spcPct val="100000"/>
+              </a:lnSpc>
+              <a:spcBef>
+                <a:spcPts val="0"/>
+              </a:spcBef>
+              <a:buNone/>
+            </a:pPr>
+            <a:r>
+              <a:rPr lang="pt-BR" sz="7200" dirty="0"/>
+              <a:t>Catchaqueira </a:t>
+            </a:r>
+            <a:r>
+              <a:rPr lang="pt-BR" sz="7200" dirty="0">
+                <a:solidFill>
+                  <a:srgbClr val="FF0000"/>
+                </a:solidFill>
+              </a:rPr>
+              <a:t>Sol</a:t>
+            </a:r>
+            <a:br>
+              <a:rPr lang="pt-BR" sz="7200" dirty="0"/>
+            </a:br>
+            <a:r>
+              <a:rPr lang="pt-BR" sz="7200" dirty="0"/>
+              <a:t>Luz Da Minha Vida </a:t>
+            </a:r>
+            <a:r>
+              <a:rPr lang="pt-BR" sz="7200" dirty="0">
+                <a:solidFill>
+                  <a:srgbClr val="FF0000"/>
+                </a:solidFill>
+              </a:rPr>
+              <a:t>Sol</a:t>
+            </a:r>
+            <a:endParaRPr lang="pt-BR" sz="8000" dirty="0">
+              <a:solidFill>
+                <a:srgbClr val="FF0000"/>
+              </a:solidFill>
+              <a:cs typeface="Arial" panose="020B0604020202020204" pitchFamily="34" charset="0"/>
+            </a:endParaRPr>
+          </a:p>
+        </p:txBody>
+      </p:sp>
+    </p:spTree>
+    <p:extLst>
+      <p:ext uri="{BB962C8B-B14F-4D97-AF65-F5344CB8AC3E}">
+        <p14:creationId xmlns:p14="http://schemas.microsoft.com/office/powerpoint/2010/main" val="1477774677"/>
+      </p:ext>
+    </p:extLst>
+  </p:cSld>
+  <p:clrMapOvr>
+    <a:masterClrMapping/>
+  </p:clrMapOvr>
+</p:sld>
+</file>
+
+<file path=ppt/slides/slide71.xml><?xml version="1.0" encoding="utf-8"?>
+<p:sld xmlns:a="http://schemas.openxmlformats.org/drawingml/2006/main" xmlns:r="http://schemas.openxmlformats.org/officeDocument/2006/relationships" xmlns:p="http://schemas.openxmlformats.org/presentationml/2006/main">
+  <p:cSld>
+    <p:spTree>
+      <p:nvGrpSpPr>
+        <p:cNvPr id="1" name="">
+          <a:extLst>
+            <a:ext uri="{FF2B5EF4-FFF2-40B4-BE49-F238E27FC236}">
               <a16:creationId xmlns:a16="http://schemas.microsoft.com/office/drawing/2014/main" id="{F2D14050-DA13-E65F-ADC3-C6C4FE41D805}"/>
             </a:ext>
           </a:extLst>
@@ -16012,7 +15906,7 @@
     </p:spTree>
     <p:extLst>
       <p:ext uri="{BB962C8B-B14F-4D97-AF65-F5344CB8AC3E}">
-        <p14:creationId xmlns:p14="http://schemas.microsoft.com/office/powerpoint/2010/main" val="2491854916"/>
+        <p14:creationId xmlns:p14="http://schemas.microsoft.com/office/powerpoint/2010/main" val="3340755008"/>
       </p:ext>
     </p:extLst>
   </p:cSld>
@@ -16022,7 +15916,7 @@
 </p:sld>
 </file>
 
-<file path=ppt/slides/slide71.xml><?xml version="1.0" encoding="utf-8"?>
+<file path=ppt/slides/slide72.xml><?xml version="1.0" encoding="utf-8"?>
 <p:sld xmlns:a="http://schemas.openxmlformats.org/drawingml/2006/main" xmlns:r="http://schemas.openxmlformats.org/officeDocument/2006/relationships" xmlns:p="http://schemas.openxmlformats.org/presentationml/2006/main">
   <p:cSld>
     <p:spTree>
@@ -16138,7 +16032,7 @@
     </p:spTree>
     <p:extLst>
       <p:ext uri="{BB962C8B-B14F-4D97-AF65-F5344CB8AC3E}">
-        <p14:creationId xmlns:p14="http://schemas.microsoft.com/office/powerpoint/2010/main" val="2269393178"/>
+        <p14:creationId xmlns:p14="http://schemas.microsoft.com/office/powerpoint/2010/main" val="4078408356"/>
       </p:ext>
     </p:extLst>
   </p:cSld>
@@ -16148,7 +16042,7 @@
 </p:sld>
 </file>
 
-<file path=ppt/slides/slide72.xml><?xml version="1.0" encoding="utf-8"?>
+<file path=ppt/slides/slide73.xml><?xml version="1.0" encoding="utf-8"?>
 <p:sld xmlns:a="http://schemas.openxmlformats.org/drawingml/2006/main" xmlns:r="http://schemas.openxmlformats.org/officeDocument/2006/relationships" xmlns:p="http://schemas.openxmlformats.org/presentationml/2006/main">
   <p:cSld>
     <p:spTree>
@@ -16342,7 +16236,7 @@
     </p:spTree>
     <p:extLst>
       <p:ext uri="{BB962C8B-B14F-4D97-AF65-F5344CB8AC3E}">
-        <p14:creationId xmlns:p14="http://schemas.microsoft.com/office/powerpoint/2010/main" val="1708532493"/>
+        <p14:creationId xmlns:p14="http://schemas.microsoft.com/office/powerpoint/2010/main" val="1733778688"/>
       </p:ext>
     </p:extLst>
   </p:cSld>
@@ -16352,7 +16246,7 @@
 </p:sld>
 </file>
 
-<file path=ppt/slides/slide73.xml><?xml version="1.0" encoding="utf-8"?>
+<file path=ppt/slides/slide74.xml><?xml version="1.0" encoding="utf-8"?>
 <p:sld xmlns:a="http://schemas.openxmlformats.org/drawingml/2006/main" xmlns:r="http://schemas.openxmlformats.org/officeDocument/2006/relationships" xmlns:p="http://schemas.openxmlformats.org/presentationml/2006/main">
   <p:cSld>
     <p:spTree>
@@ -16483,7 +16377,7 @@
     </p:spTree>
     <p:extLst>
       <p:ext uri="{BB962C8B-B14F-4D97-AF65-F5344CB8AC3E}">
-        <p14:creationId xmlns:p14="http://schemas.microsoft.com/office/powerpoint/2010/main" val="389728738"/>
+        <p14:creationId xmlns:p14="http://schemas.microsoft.com/office/powerpoint/2010/main" val="115736051"/>
       </p:ext>
     </p:extLst>
   </p:cSld>
@@ -16493,7 +16387,7 @@
 </p:sld>
 </file>
 
-<file path=ppt/slides/slide74.xml><?xml version="1.0" encoding="utf-8"?>
+<file path=ppt/slides/slide75.xml><?xml version="1.0" encoding="utf-8"?>
 <p:sld xmlns:a="http://schemas.openxmlformats.org/drawingml/2006/main" xmlns:r="http://schemas.openxmlformats.org/officeDocument/2006/relationships" xmlns:p="http://schemas.openxmlformats.org/presentationml/2006/main">
   <p:cSld>
     <p:spTree>
@@ -16669,7 +16563,7 @@
     </p:spTree>
     <p:extLst>
       <p:ext uri="{BB962C8B-B14F-4D97-AF65-F5344CB8AC3E}">
-        <p14:creationId xmlns:p14="http://schemas.microsoft.com/office/powerpoint/2010/main" val="3021598653"/>
+        <p14:creationId xmlns:p14="http://schemas.microsoft.com/office/powerpoint/2010/main" val="3399997052"/>
       </p:ext>
     </p:extLst>
   </p:cSld>
@@ -16679,7 +16573,7 @@
 </p:sld>
 </file>
 
-<file path=ppt/slides/slide75.xml><?xml version="1.0" encoding="utf-8"?>
+<file path=ppt/slides/slide76.xml><?xml version="1.0" encoding="utf-8"?>
 <p:sld xmlns:a="http://schemas.openxmlformats.org/drawingml/2006/main" xmlns:r="http://schemas.openxmlformats.org/officeDocument/2006/relationships" xmlns:p="http://schemas.openxmlformats.org/presentationml/2006/main">
   <p:cSld>
     <p:spTree>
@@ -16823,7 +16717,7 @@
     </p:spTree>
     <p:extLst>
       <p:ext uri="{BB962C8B-B14F-4D97-AF65-F5344CB8AC3E}">
-        <p14:creationId xmlns:p14="http://schemas.microsoft.com/office/powerpoint/2010/main" val="3510183714"/>
+        <p14:creationId xmlns:p14="http://schemas.microsoft.com/office/powerpoint/2010/main" val="1493072947"/>
       </p:ext>
     </p:extLst>
   </p:cSld>
@@ -16833,7 +16727,7 @@
 </p:sld>
 </file>
 
-<file path=ppt/slides/slide76.xml><?xml version="1.0" encoding="utf-8"?>
+<file path=ppt/slides/slide77.xml><?xml version="1.0" encoding="utf-8"?>
 <p:sld xmlns:a="http://schemas.openxmlformats.org/drawingml/2006/main" xmlns:r="http://schemas.openxmlformats.org/officeDocument/2006/relationships" xmlns:p="http://schemas.openxmlformats.org/presentationml/2006/main">
   <p:cSld>
     <p:spTree>
@@ -16964,7 +16858,7 @@
     </p:spTree>
     <p:extLst>
       <p:ext uri="{BB962C8B-B14F-4D97-AF65-F5344CB8AC3E}">
-        <p14:creationId xmlns:p14="http://schemas.microsoft.com/office/powerpoint/2010/main" val="3631102532"/>
+        <p14:creationId xmlns:p14="http://schemas.microsoft.com/office/powerpoint/2010/main" val="2639022366"/>
       </p:ext>
     </p:extLst>
   </p:cSld>
@@ -16974,7 +16868,7 @@
 </p:sld>
 </file>
 
-<file path=ppt/slides/slide77.xml><?xml version="1.0" encoding="utf-8"?>
+<file path=ppt/slides/slide78.xml><?xml version="1.0" encoding="utf-8"?>
 <p:sld xmlns:a="http://schemas.openxmlformats.org/drawingml/2006/main" xmlns:r="http://schemas.openxmlformats.org/officeDocument/2006/relationships" xmlns:p="http://schemas.openxmlformats.org/presentationml/2006/main">
   <p:cSld>
     <p:spTree>
@@ -17129,7 +17023,7 @@
     </p:spTree>
     <p:extLst>
       <p:ext uri="{BB962C8B-B14F-4D97-AF65-F5344CB8AC3E}">
-        <p14:creationId xmlns:p14="http://schemas.microsoft.com/office/powerpoint/2010/main" val="234799058"/>
+        <p14:creationId xmlns:p14="http://schemas.microsoft.com/office/powerpoint/2010/main" val="1760658781"/>
       </p:ext>
     </p:extLst>
   </p:cSld>
@@ -17139,7 +17033,7 @@
 </p:sld>
 </file>
 
-<file path=ppt/slides/slide78.xml><?xml version="1.0" encoding="utf-8"?>
+<file path=ppt/slides/slide79.xml><?xml version="1.0" encoding="utf-8"?>
 <p:sld xmlns:a="http://schemas.openxmlformats.org/drawingml/2006/main" xmlns:r="http://schemas.openxmlformats.org/officeDocument/2006/relationships" xmlns:p="http://schemas.openxmlformats.org/presentationml/2006/main">
   <p:cSld>
     <p:spTree>
@@ -17270,133 +17164,7 @@
     </p:spTree>
     <p:extLst>
       <p:ext uri="{BB962C8B-B14F-4D97-AF65-F5344CB8AC3E}">
-        <p14:creationId xmlns:p14="http://schemas.microsoft.com/office/powerpoint/2010/main" val="2085413432"/>
-      </p:ext>
-    </p:extLst>
-  </p:cSld>
-  <p:clrMapOvr>
-    <a:masterClrMapping/>
-  </p:clrMapOvr>
-</p:sld>
-</file>
-
-<file path=ppt/slides/slide79.xml><?xml version="1.0" encoding="utf-8"?>
-<p:sld xmlns:a="http://schemas.openxmlformats.org/drawingml/2006/main" xmlns:r="http://schemas.openxmlformats.org/officeDocument/2006/relationships" xmlns:p="http://schemas.openxmlformats.org/presentationml/2006/main">
-  <p:cSld>
-    <p:spTree>
-      <p:nvGrpSpPr>
-        <p:cNvPr id="1" name="">
-          <a:extLst>
-            <a:ext uri="{FF2B5EF4-FFF2-40B4-BE49-F238E27FC236}">
-              <a16:creationId xmlns:a16="http://schemas.microsoft.com/office/drawing/2014/main" id="{B77F8FE7-F682-F272-86B7-05E04CD81CA5}"/>
-            </a:ext>
-          </a:extLst>
-        </p:cNvPr>
-        <p:cNvGrpSpPr/>
-        <p:nvPr/>
-      </p:nvGrpSpPr>
-      <p:grpSpPr>
-        <a:xfrm>
-          <a:off x="0" y="0"/>
-          <a:ext cx="0" cy="0"/>
-          <a:chOff x="0" y="0"/>
-          <a:chExt cx="0" cy="0"/>
-        </a:xfrm>
-      </p:grpSpPr>
-      <p:sp>
-        <p:nvSpPr>
-          <p:cNvPr id="3" name="Espaço Reservado para Conteúdo 2">
-            <a:extLst>
-              <a:ext uri="{FF2B5EF4-FFF2-40B4-BE49-F238E27FC236}">
-                <a16:creationId xmlns:a16="http://schemas.microsoft.com/office/drawing/2014/main" id="{2AC924BC-F62C-79CC-E31A-7623E1BCB835}"/>
-              </a:ext>
-            </a:extLst>
-          </p:cNvPr>
-          <p:cNvSpPr>
-            <a:spLocks noGrp="1"/>
-          </p:cNvSpPr>
-          <p:nvPr>
-            <p:ph idx="1"/>
-          </p:nvPr>
-        </p:nvSpPr>
-        <p:spPr>
-          <a:xfrm>
-            <a:off x="10509" y="-3937"/>
-            <a:ext cx="12181491" cy="6861937"/>
-          </a:xfrm>
-        </p:spPr>
-        <p:txBody>
-          <a:bodyPr>
-            <a:noAutofit/>
-          </a:bodyPr>
-          <a:lstStyle/>
-          <a:p>
-            <a:pPr algn="ctr">
-              <a:lnSpc>
-                <a:spcPct val="100000"/>
-              </a:lnSpc>
-              <a:buNone/>
-            </a:pPr>
-            <a:r>
-              <a:rPr lang="en-US" sz="8800" dirty="0">
-                <a:solidFill>
-                  <a:srgbClr val="FF0000"/>
-                </a:solidFill>
-                <a:cs typeface="Arial" panose="020B0604020202020204" pitchFamily="34" charset="0"/>
-              </a:rPr>
-              <a:t>VS BLOCO 16</a:t>
-            </a:r>
-          </a:p>
-          <a:p>
-            <a:pPr marL="36000" indent="-252000" algn="ctr">
-              <a:lnSpc>
-                <a:spcPct val="100000"/>
-              </a:lnSpc>
-              <a:spcBef>
-                <a:spcPts val="0"/>
-              </a:spcBef>
-              <a:buNone/>
-            </a:pPr>
-            <a:r>
-              <a:rPr lang="pt-BR" sz="7200" dirty="0"/>
-              <a:t>Nosso Amor Terminou </a:t>
-            </a:r>
-            <a:r>
-              <a:rPr lang="pt-BR" sz="7200" dirty="0">
-                <a:solidFill>
-                  <a:srgbClr val="FF0000"/>
-                </a:solidFill>
-              </a:rPr>
-              <a:t>Sol</a:t>
-            </a:r>
-            <a:br>
-              <a:rPr lang="pt-BR" sz="7200" dirty="0"/>
-            </a:br>
-            <a:r>
-              <a:rPr lang="pt-BR" sz="7200" dirty="0"/>
-              <a:t>Assino Com X </a:t>
-            </a:r>
-            <a:r>
-              <a:rPr lang="pt-BR" sz="7200" dirty="0">
-                <a:solidFill>
-                  <a:srgbClr val="FF0000"/>
-                </a:solidFill>
-              </a:rPr>
-              <a:t>La</a:t>
-            </a:r>
-            <a:endParaRPr lang="pt-BR" sz="8000" dirty="0">
-              <a:solidFill>
-                <a:srgbClr val="FF0000"/>
-              </a:solidFill>
-              <a:cs typeface="Arial" panose="020B0604020202020204" pitchFamily="34" charset="0"/>
-            </a:endParaRPr>
-          </a:p>
-        </p:txBody>
-      </p:sp>
-    </p:spTree>
-    <p:extLst>
-      <p:ext uri="{BB962C8B-B14F-4D97-AF65-F5344CB8AC3E}">
-        <p14:creationId xmlns:p14="http://schemas.microsoft.com/office/powerpoint/2010/main" val="1299608314"/>
+        <p14:creationId xmlns:p14="http://schemas.microsoft.com/office/powerpoint/2010/main" val="51799183"/>
       </p:ext>
     </p:extLst>
   </p:cSld>
@@ -17573,6 +17341,132 @@
         <p:cNvPr id="1" name="">
           <a:extLst>
             <a:ext uri="{FF2B5EF4-FFF2-40B4-BE49-F238E27FC236}">
+              <a16:creationId xmlns:a16="http://schemas.microsoft.com/office/drawing/2014/main" id="{B77F8FE7-F682-F272-86B7-05E04CD81CA5}"/>
+            </a:ext>
+          </a:extLst>
+        </p:cNvPr>
+        <p:cNvGrpSpPr/>
+        <p:nvPr/>
+      </p:nvGrpSpPr>
+      <p:grpSpPr>
+        <a:xfrm>
+          <a:off x="0" y="0"/>
+          <a:ext cx="0" cy="0"/>
+          <a:chOff x="0" y="0"/>
+          <a:chExt cx="0" cy="0"/>
+        </a:xfrm>
+      </p:grpSpPr>
+      <p:sp>
+        <p:nvSpPr>
+          <p:cNvPr id="3" name="Espaço Reservado para Conteúdo 2">
+            <a:extLst>
+              <a:ext uri="{FF2B5EF4-FFF2-40B4-BE49-F238E27FC236}">
+                <a16:creationId xmlns:a16="http://schemas.microsoft.com/office/drawing/2014/main" id="{2AC924BC-F62C-79CC-E31A-7623E1BCB835}"/>
+              </a:ext>
+            </a:extLst>
+          </p:cNvPr>
+          <p:cNvSpPr>
+            <a:spLocks noGrp="1"/>
+          </p:cNvSpPr>
+          <p:nvPr>
+            <p:ph idx="1"/>
+          </p:nvPr>
+        </p:nvSpPr>
+        <p:spPr>
+          <a:xfrm>
+            <a:off x="10509" y="-3937"/>
+            <a:ext cx="12181491" cy="6861937"/>
+          </a:xfrm>
+        </p:spPr>
+        <p:txBody>
+          <a:bodyPr>
+            <a:noAutofit/>
+          </a:bodyPr>
+          <a:lstStyle/>
+          <a:p>
+            <a:pPr algn="ctr">
+              <a:lnSpc>
+                <a:spcPct val="100000"/>
+              </a:lnSpc>
+              <a:buNone/>
+            </a:pPr>
+            <a:r>
+              <a:rPr lang="en-US" sz="8800" dirty="0">
+                <a:solidFill>
+                  <a:srgbClr val="FF0000"/>
+                </a:solidFill>
+                <a:cs typeface="Arial" panose="020B0604020202020204" pitchFamily="34" charset="0"/>
+              </a:rPr>
+              <a:t>VS BLOCO 16</a:t>
+            </a:r>
+          </a:p>
+          <a:p>
+            <a:pPr marL="36000" indent="-252000" algn="ctr">
+              <a:lnSpc>
+                <a:spcPct val="100000"/>
+              </a:lnSpc>
+              <a:spcBef>
+                <a:spcPts val="0"/>
+              </a:spcBef>
+              <a:buNone/>
+            </a:pPr>
+            <a:r>
+              <a:rPr lang="pt-BR" sz="7200" dirty="0"/>
+              <a:t>Nosso Amor Terminou </a:t>
+            </a:r>
+            <a:r>
+              <a:rPr lang="pt-BR" sz="7200" dirty="0">
+                <a:solidFill>
+                  <a:srgbClr val="FF0000"/>
+                </a:solidFill>
+              </a:rPr>
+              <a:t>Sol</a:t>
+            </a:r>
+            <a:br>
+              <a:rPr lang="pt-BR" sz="7200" dirty="0"/>
+            </a:br>
+            <a:r>
+              <a:rPr lang="pt-BR" sz="7200" dirty="0"/>
+              <a:t>Assino Com X </a:t>
+            </a:r>
+            <a:r>
+              <a:rPr lang="pt-BR" sz="7200" dirty="0">
+                <a:solidFill>
+                  <a:srgbClr val="FF0000"/>
+                </a:solidFill>
+              </a:rPr>
+              <a:t>La</a:t>
+            </a:r>
+            <a:endParaRPr lang="pt-BR" sz="8000" dirty="0">
+              <a:solidFill>
+                <a:srgbClr val="FF0000"/>
+              </a:solidFill>
+              <a:cs typeface="Arial" panose="020B0604020202020204" pitchFamily="34" charset="0"/>
+            </a:endParaRPr>
+          </a:p>
+        </p:txBody>
+      </p:sp>
+    </p:spTree>
+    <p:extLst>
+      <p:ext uri="{BB962C8B-B14F-4D97-AF65-F5344CB8AC3E}">
+        <p14:creationId xmlns:p14="http://schemas.microsoft.com/office/powerpoint/2010/main" val="348060073"/>
+      </p:ext>
+    </p:extLst>
+  </p:cSld>
+  <p:clrMapOvr>
+    <a:masterClrMapping/>
+  </p:clrMapOvr>
+</p:sld>
+</file>
+
+<file path=ppt/slides/slide81.xml><?xml version="1.0" encoding="utf-8"?>
+<p:sld xmlns:a="http://schemas.openxmlformats.org/drawingml/2006/main" xmlns:r="http://schemas.openxmlformats.org/officeDocument/2006/relationships" xmlns:p="http://schemas.openxmlformats.org/presentationml/2006/main">
+  <p:cSld>
+    <p:spTree>
+      <p:nvGrpSpPr>
+        <p:cNvPr id="1" name="">
+          <a:extLst>
+            <a:ext uri="{FF2B5EF4-FFF2-40B4-BE49-F238E27FC236}">
               <a16:creationId xmlns:a16="http://schemas.microsoft.com/office/drawing/2014/main" id="{70C65271-E891-BC86-E338-D59A2C58161B}"/>
             </a:ext>
           </a:extLst>
@@ -17759,7 +17653,7 @@
     </p:spTree>
     <p:extLst>
       <p:ext uri="{BB962C8B-B14F-4D97-AF65-F5344CB8AC3E}">
-        <p14:creationId xmlns:p14="http://schemas.microsoft.com/office/powerpoint/2010/main" val="4248360019"/>
+        <p14:creationId xmlns:p14="http://schemas.microsoft.com/office/powerpoint/2010/main" val="2344787189"/>
       </p:ext>
     </p:extLst>
   </p:cSld>
@@ -17769,7 +17663,7 @@
 </p:sld>
 </file>
 
-<file path=ppt/slides/slide81.xml><?xml version="1.0" encoding="utf-8"?>
+<file path=ppt/slides/slide82.xml><?xml version="1.0" encoding="utf-8"?>
 <p:sld xmlns:a="http://schemas.openxmlformats.org/drawingml/2006/main" xmlns:r="http://schemas.openxmlformats.org/officeDocument/2006/relationships" xmlns:p="http://schemas.openxmlformats.org/presentationml/2006/main">
   <p:cSld>
     <p:spTree>
@@ -17925,7 +17819,7 @@
     </p:spTree>
     <p:extLst>
       <p:ext uri="{BB962C8B-B14F-4D97-AF65-F5344CB8AC3E}">
-        <p14:creationId xmlns:p14="http://schemas.microsoft.com/office/powerpoint/2010/main" val="1960366677"/>
+        <p14:creationId xmlns:p14="http://schemas.microsoft.com/office/powerpoint/2010/main" val="1964108688"/>
       </p:ext>
     </p:extLst>
   </p:cSld>
@@ -17935,7 +17829,7 @@
 </p:sld>
 </file>
 
-<file path=ppt/slides/slide82.xml><?xml version="1.0" encoding="utf-8"?>
+<file path=ppt/slides/slide83.xml><?xml version="1.0" encoding="utf-8"?>
 <p:sld xmlns:a="http://schemas.openxmlformats.org/drawingml/2006/main" xmlns:r="http://schemas.openxmlformats.org/officeDocument/2006/relationships" xmlns:p="http://schemas.openxmlformats.org/presentationml/2006/main">
   <p:cSld>
     <p:spTree>
@@ -18066,7 +17960,7 @@
     </p:spTree>
     <p:extLst>
       <p:ext uri="{BB962C8B-B14F-4D97-AF65-F5344CB8AC3E}">
-        <p14:creationId xmlns:p14="http://schemas.microsoft.com/office/powerpoint/2010/main" val="2912743868"/>
+        <p14:creationId xmlns:p14="http://schemas.microsoft.com/office/powerpoint/2010/main" val="2403216192"/>
       </p:ext>
     </p:extLst>
   </p:cSld>
@@ -18076,7 +17970,7 @@
 </p:sld>
 </file>
 
-<file path=ppt/slides/slide83.xml><?xml version="1.0" encoding="utf-8"?>
+<file path=ppt/slides/slide84.xml><?xml version="1.0" encoding="utf-8"?>
 <p:sld xmlns:a="http://schemas.openxmlformats.org/drawingml/2006/main" xmlns:r="http://schemas.openxmlformats.org/officeDocument/2006/relationships" xmlns:p="http://schemas.openxmlformats.org/presentationml/2006/main">
   <p:cSld>
     <p:spTree>
@@ -18204,7 +18098,7 @@
     </p:spTree>
     <p:extLst>
       <p:ext uri="{BB962C8B-B14F-4D97-AF65-F5344CB8AC3E}">
-        <p14:creationId xmlns:p14="http://schemas.microsoft.com/office/powerpoint/2010/main" val="1228789558"/>
+        <p14:creationId xmlns:p14="http://schemas.microsoft.com/office/powerpoint/2010/main" val="1629742765"/>
       </p:ext>
     </p:extLst>
   </p:cSld>
@@ -18214,7 +18108,7 @@
 </p:sld>
 </file>
 
-<file path=ppt/slides/slide84.xml><?xml version="1.0" encoding="utf-8"?>
+<file path=ppt/slides/slide85.xml><?xml version="1.0" encoding="utf-8"?>
 <p:sld xmlns:a="http://schemas.openxmlformats.org/drawingml/2006/main" xmlns:r="http://schemas.openxmlformats.org/officeDocument/2006/relationships" xmlns:p="http://schemas.openxmlformats.org/presentationml/2006/main">
   <p:cSld>
     <p:spTree>
@@ -18345,7 +18239,7 @@
     </p:spTree>
     <p:extLst>
       <p:ext uri="{BB962C8B-B14F-4D97-AF65-F5344CB8AC3E}">
-        <p14:creationId xmlns:p14="http://schemas.microsoft.com/office/powerpoint/2010/main" val="4290407121"/>
+        <p14:creationId xmlns:p14="http://schemas.microsoft.com/office/powerpoint/2010/main" val="2219016206"/>
       </p:ext>
     </p:extLst>
   </p:cSld>
@@ -18355,7 +18249,7 @@
 </p:sld>
 </file>
 
-<file path=ppt/slides/slide85.xml><?xml version="1.0" encoding="utf-8"?>
+<file path=ppt/slides/slide86.xml><?xml version="1.0" encoding="utf-8"?>
 <p:sld xmlns:a="http://schemas.openxmlformats.org/drawingml/2006/main" xmlns:r="http://schemas.openxmlformats.org/officeDocument/2006/relationships" xmlns:p="http://schemas.openxmlformats.org/presentationml/2006/main">
   <p:cSld>
     <p:spTree>
@@ -18486,7 +18380,7 @@
     </p:spTree>
     <p:extLst>
       <p:ext uri="{BB962C8B-B14F-4D97-AF65-F5344CB8AC3E}">
-        <p14:creationId xmlns:p14="http://schemas.microsoft.com/office/powerpoint/2010/main" val="2964182992"/>
+        <p14:creationId xmlns:p14="http://schemas.microsoft.com/office/powerpoint/2010/main" val="4214511313"/>
       </p:ext>
     </p:extLst>
   </p:cSld>
@@ -18496,7 +18390,7 @@
 </p:sld>
 </file>
 
-<file path=ppt/slides/slide86.xml><?xml version="1.0" encoding="utf-8"?>
+<file path=ppt/slides/slide87.xml><?xml version="1.0" encoding="utf-8"?>
 <p:sld xmlns:a="http://schemas.openxmlformats.org/drawingml/2006/main" xmlns:r="http://schemas.openxmlformats.org/officeDocument/2006/relationships" xmlns:p="http://schemas.openxmlformats.org/presentationml/2006/main">
   <p:cSld>
     <p:spTree>
@@ -18635,166 +18529,7 @@
     </p:spTree>
     <p:extLst>
       <p:ext uri="{BB962C8B-B14F-4D97-AF65-F5344CB8AC3E}">
-        <p14:creationId xmlns:p14="http://schemas.microsoft.com/office/powerpoint/2010/main" val="1713249733"/>
-      </p:ext>
-    </p:extLst>
-  </p:cSld>
-  <p:clrMapOvr>
-    <a:masterClrMapping/>
-  </p:clrMapOvr>
-</p:sld>
-</file>
-
-<file path=ppt/slides/slide87.xml><?xml version="1.0" encoding="utf-8"?>
-<p:sld xmlns:a="http://schemas.openxmlformats.org/drawingml/2006/main" xmlns:r="http://schemas.openxmlformats.org/officeDocument/2006/relationships" xmlns:p="http://schemas.openxmlformats.org/presentationml/2006/main">
-  <p:cSld>
-    <p:spTree>
-      <p:nvGrpSpPr>
-        <p:cNvPr id="1" name=""/>
-        <p:cNvGrpSpPr/>
-        <p:nvPr/>
-      </p:nvGrpSpPr>
-      <p:grpSpPr>
-        <a:xfrm>
-          <a:off x="0" y="0"/>
-          <a:ext cx="0" cy="0"/>
-          <a:chOff x="0" y="0"/>
-          <a:chExt cx="0" cy="0"/>
-        </a:xfrm>
-      </p:grpSpPr>
-      <p:sp>
-        <p:nvSpPr>
-          <p:cNvPr id="3" name="Espaço Reservado para Conteúdo 2">
-            <a:extLst>
-              <a:ext uri="{FF2B5EF4-FFF2-40B4-BE49-F238E27FC236}">
-                <a16:creationId xmlns:a16="http://schemas.microsoft.com/office/drawing/2014/main" id="{7C70BAA2-54A1-BAA9-5EF9-9F93F22AE700}"/>
-              </a:ext>
-            </a:extLst>
-          </p:cNvPr>
-          <p:cNvSpPr>
-            <a:spLocks noGrp="1"/>
-          </p:cNvSpPr>
-          <p:nvPr>
-            <p:ph idx="1"/>
-          </p:nvPr>
-        </p:nvSpPr>
-        <p:spPr>
-          <a:xfrm>
-            <a:off x="10509" y="-3937"/>
-            <a:ext cx="12181491" cy="6861937"/>
-          </a:xfrm>
-        </p:spPr>
-        <p:txBody>
-          <a:bodyPr>
-            <a:noAutofit/>
-          </a:bodyPr>
-          <a:lstStyle/>
-          <a:p>
-            <a:pPr algn="ctr">
-              <a:lnSpc>
-                <a:spcPct val="100000"/>
-              </a:lnSpc>
-              <a:buNone/>
-            </a:pPr>
-            <a:r>
-              <a:rPr lang="en-US" sz="8800" dirty="0">
-                <a:solidFill>
-                  <a:srgbClr val="FF0000"/>
-                </a:solidFill>
-                <a:cs typeface="Arial" panose="020B0604020202020204" pitchFamily="34" charset="0"/>
-              </a:rPr>
-              <a:t>VS BLOCO 24</a:t>
-            </a:r>
-          </a:p>
-          <a:p>
-            <a:pPr marL="36000" indent="-252000" algn="ctr">
-              <a:lnSpc>
-                <a:spcPct val="100000"/>
-              </a:lnSpc>
-              <a:spcBef>
-                <a:spcPts val="0"/>
-              </a:spcBef>
-              <a:buNone/>
-            </a:pPr>
-            <a:r>
-              <a:rPr lang="pt-BR" sz="7200" dirty="0"/>
-              <a:t>Alô Galera </a:t>
-            </a:r>
-            <a:r>
-              <a:rPr lang="pt-BR" sz="7200" dirty="0">
-                <a:solidFill>
-                  <a:srgbClr val="FF0000"/>
-                </a:solidFill>
-              </a:rPr>
-              <a:t>??</a:t>
-            </a:r>
-            <a:br>
-              <a:rPr lang="pt-BR" sz="7200" dirty="0"/>
-            </a:br>
-            <a:r>
-              <a:rPr lang="pt-BR" sz="7200" dirty="0"/>
-              <a:t>Essa Cama Eu Não Vendo </a:t>
-            </a:r>
-            <a:r>
-              <a:rPr lang="pt-BR" sz="7200" dirty="0">
-                <a:solidFill>
-                  <a:srgbClr val="FF0000"/>
-                </a:solidFill>
-              </a:rPr>
-              <a:t>??</a:t>
-            </a:r>
-            <a:br>
-              <a:rPr lang="pt-BR" sz="7200" dirty="0"/>
-            </a:br>
-            <a:r>
-              <a:rPr lang="pt-BR" sz="7200" dirty="0"/>
-              <a:t>Pintou Uma Paixão </a:t>
-            </a:r>
-            <a:r>
-              <a:rPr lang="pt-BR" sz="7200" dirty="0">
-                <a:solidFill>
-                  <a:srgbClr val="FF0000"/>
-                </a:solidFill>
-              </a:rPr>
-              <a:t>??</a:t>
-            </a:r>
-            <a:br>
-              <a:rPr lang="pt-BR" sz="7200" dirty="0"/>
-            </a:br>
-            <a:r>
-              <a:rPr lang="pt-BR" sz="7200" dirty="0"/>
-              <a:t>Transgênica </a:t>
-            </a:r>
-            <a:r>
-              <a:rPr lang="pt-BR" sz="7200" dirty="0">
-                <a:solidFill>
-                  <a:srgbClr val="FF0000"/>
-                </a:solidFill>
-              </a:rPr>
-              <a:t>??</a:t>
-            </a:r>
-            <a:br>
-              <a:rPr lang="pt-BR" sz="7200" dirty="0"/>
-            </a:br>
-            <a:r>
-              <a:rPr lang="pt-BR" sz="7200" dirty="0"/>
-              <a:t>Algo Me Diz </a:t>
-            </a:r>
-            <a:r>
-              <a:rPr lang="pt-BR" sz="7200" dirty="0">
-                <a:solidFill>
-                  <a:srgbClr val="FF0000"/>
-                </a:solidFill>
-              </a:rPr>
-              <a:t>??</a:t>
-            </a:r>
-          </a:p>
-        </p:txBody>
-      </p:sp>
-    </p:spTree>
-    <p:extLst>
-      <p:ext uri="{BB962C8B-B14F-4D97-AF65-F5344CB8AC3E}">
-        <p14:creationId xmlns:p14="http://schemas.microsoft.com/office/powerpoint/2010/main" val="4187109604"/>
+        <p14:creationId xmlns:p14="http://schemas.microsoft.com/office/powerpoint/2010/main" val="132768071"/>
       </p:ext>
     </p:extLst>
   </p:cSld>
@@ -18862,7 +18597,7 @@
                 </a:solidFill>
                 <a:cs typeface="Arial" panose="020B0604020202020204" pitchFamily="34" charset="0"/>
               </a:rPr>
-              <a:t>VS BLOCO 25</a:t>
+              <a:t>VS BLOCO 24</a:t>
             </a:r>
           </a:p>
           <a:p>
@@ -18877,7 +18612,7 @@
             </a:pPr>
             <a:r>
               <a:rPr lang="pt-BR" sz="7200" dirty="0"/>
-              <a:t>Barril de Chopp </a:t>
+              <a:t>Alô Galera </a:t>
             </a:r>
             <a:r>
               <a:rPr lang="pt-BR" sz="7200" dirty="0">
@@ -18885,14 +18620,14 @@
                   <a:srgbClr val="FF0000"/>
                 </a:solidFill>
               </a:rPr>
-              <a:t>Sib-Mib</a:t>
+              <a:t>??</a:t>
             </a:r>
             <a:br>
               <a:rPr lang="pt-BR" sz="7200" dirty="0"/>
             </a:br>
             <a:r>
               <a:rPr lang="pt-BR" sz="7200" dirty="0"/>
-              <a:t>Ouro na Estrada </a:t>
+              <a:t>Essa Cama Eu Não Vendo </a:t>
             </a:r>
             <a:r>
               <a:rPr lang="pt-BR" sz="7200" dirty="0">
@@ -18907,7 +18642,37 @@
             </a:br>
             <a:r>
               <a:rPr lang="pt-BR" sz="7200" dirty="0"/>
-              <a:t>Bebidas de Amor </a:t>
+              <a:t>Pintou Uma Paixão </a:t>
+            </a:r>
+            <a:r>
+              <a:rPr lang="pt-BR" sz="7200" dirty="0">
+                <a:solidFill>
+                  <a:srgbClr val="FF0000"/>
+                </a:solidFill>
+              </a:rPr>
+              <a:t>??</a:t>
+            </a:r>
+            <a:br>
+              <a:rPr lang="pt-BR" sz="7200" dirty="0"/>
+            </a:br>
+            <a:r>
+              <a:rPr lang="pt-BR" sz="7200" dirty="0"/>
+              <a:t>Transgênica </a:t>
+            </a:r>
+            <a:r>
+              <a:rPr lang="pt-BR" sz="7200" dirty="0">
+                <a:solidFill>
+                  <a:srgbClr val="FF0000"/>
+                </a:solidFill>
+              </a:rPr>
+              <a:t>??</a:t>
+            </a:r>
+            <a:br>
+              <a:rPr lang="pt-BR" sz="7200" dirty="0"/>
+            </a:br>
+            <a:r>
+              <a:rPr lang="pt-BR" sz="7200" dirty="0"/>
+              <a:t>Algo Me Diz </a:t>
             </a:r>
             <a:r>
               <a:rPr lang="pt-BR" sz="7200" dirty="0">
@@ -18923,7 +18688,7 @@
     </p:spTree>
     <p:extLst>
       <p:ext uri="{BB962C8B-B14F-4D97-AF65-F5344CB8AC3E}">
-        <p14:creationId xmlns:p14="http://schemas.microsoft.com/office/powerpoint/2010/main" val="3127466589"/>
+        <p14:creationId xmlns:p14="http://schemas.microsoft.com/office/powerpoint/2010/main" val="2284215507"/>
       </p:ext>
     </p:extLst>
   </p:cSld>
@@ -18991,7 +18756,7 @@
                 </a:solidFill>
                 <a:cs typeface="Arial" panose="020B0604020202020204" pitchFamily="34" charset="0"/>
               </a:rPr>
-              <a:t>VS BLOCO 26</a:t>
+              <a:t>VS BLOCO 25</a:t>
             </a:r>
           </a:p>
           <a:p>
@@ -19006,7 +18771,7 @@
             </a:pPr>
             <a:r>
               <a:rPr lang="pt-BR" sz="7200" dirty="0"/>
-              <a:t>Beija Beija </a:t>
+              <a:t>Barril de Chopp </a:t>
             </a:r>
             <a:r>
               <a:rPr lang="pt-BR" sz="7200" dirty="0">
@@ -19014,14 +18779,14 @@
                   <a:srgbClr val="FF0000"/>
                 </a:solidFill>
               </a:rPr>
-              <a:t>??</a:t>
+              <a:t>Sib-Mib</a:t>
             </a:r>
             <a:br>
               <a:rPr lang="pt-BR" sz="7200" dirty="0"/>
             </a:br>
             <a:r>
               <a:rPr lang="pt-BR" sz="7200" dirty="0"/>
-              <a:t>Marreca </a:t>
+              <a:t>Ouro na Estrada </a:t>
             </a:r>
             <a:r>
               <a:rPr lang="pt-BR" sz="7200" dirty="0">
@@ -19036,7 +18801,7 @@
             </a:br>
             <a:r>
               <a:rPr lang="pt-BR" sz="7200" dirty="0"/>
-              <a:t>Kerbfest </a:t>
+              <a:t>Bebidas de Amor </a:t>
             </a:r>
             <a:r>
               <a:rPr lang="pt-BR" sz="7200" dirty="0">
@@ -19052,7 +18817,7 @@
     </p:spTree>
     <p:extLst>
       <p:ext uri="{BB962C8B-B14F-4D97-AF65-F5344CB8AC3E}">
-        <p14:creationId xmlns:p14="http://schemas.microsoft.com/office/powerpoint/2010/main" val="2376823465"/>
+        <p14:creationId xmlns:p14="http://schemas.microsoft.com/office/powerpoint/2010/main" val="1666658942"/>
       </p:ext>
     </p:extLst>
   </p:cSld>
@@ -19299,7 +19064,7 @@
                 </a:solidFill>
                 <a:cs typeface="Arial" panose="020B0604020202020204" pitchFamily="34" charset="0"/>
               </a:rPr>
-              <a:t>VS BLOCO 27</a:t>
+              <a:t>VS BLOCO 26</a:t>
             </a:r>
           </a:p>
           <a:p>
@@ -19314,7 +19079,7 @@
             </a:pPr>
             <a:r>
               <a:rPr lang="pt-BR" sz="7200" dirty="0"/>
-              <a:t>Camisa Manchada </a:t>
+              <a:t>Beija Beija </a:t>
             </a:r>
             <a:r>
               <a:rPr lang="pt-BR" sz="7200" dirty="0">
@@ -19322,14 +19087,14 @@
                   <a:srgbClr val="FF0000"/>
                 </a:solidFill>
               </a:rPr>
-              <a:t>Mi</a:t>
+              <a:t>??</a:t>
             </a:r>
             <a:br>
               <a:rPr lang="pt-BR" sz="7200" dirty="0"/>
             </a:br>
             <a:r>
               <a:rPr lang="pt-BR" sz="7200" dirty="0"/>
-              <a:t>&lt;falta o nome&gt; </a:t>
+              <a:t>Marreca </a:t>
             </a:r>
             <a:r>
               <a:rPr lang="pt-BR" sz="7200" dirty="0">
@@ -19344,7 +19109,7 @@
             </a:br>
             <a:r>
               <a:rPr lang="pt-BR" sz="7200" dirty="0"/>
-              <a:t>Estrada Da Vida </a:t>
+              <a:t>Kerbfest </a:t>
             </a:r>
             <a:r>
               <a:rPr lang="pt-BR" sz="7200" dirty="0">
@@ -19352,7 +19117,7 @@
                   <a:srgbClr val="FF0000"/>
                 </a:solidFill>
               </a:rPr>
-              <a:t>Sib</a:t>
+              <a:t>??</a:t>
             </a:r>
           </a:p>
         </p:txBody>
@@ -19360,7 +19125,7 @@
     </p:spTree>
     <p:extLst>
       <p:ext uri="{BB962C8B-B14F-4D97-AF65-F5344CB8AC3E}">
-        <p14:creationId xmlns:p14="http://schemas.microsoft.com/office/powerpoint/2010/main" val="1875749952"/>
+        <p14:creationId xmlns:p14="http://schemas.microsoft.com/office/powerpoint/2010/main" val="2287560427"/>
       </p:ext>
     </p:extLst>
   </p:cSld>
@@ -19428,7 +19193,7 @@
                 </a:solidFill>
                 <a:cs typeface="Arial" panose="020B0604020202020204" pitchFamily="34" charset="0"/>
               </a:rPr>
-              <a:t>VS BLOCO 28</a:t>
+              <a:t>VS BLOCO 27</a:t>
             </a:r>
           </a:p>
           <a:p>
@@ -19442,11 +19207,26 @@
               <a:buNone/>
             </a:pPr>
             <a:r>
-              <a:rPr lang="pt-BR" sz="5400" dirty="0"/>
-              <a:t>Coronel Boogey </a:t>
-            </a:r>
-            <a:r>
-              <a:rPr lang="pt-BR" sz="5400" dirty="0">
+              <a:rPr lang="pt-BR" sz="7200" dirty="0"/>
+              <a:t>Camisa Manchada </a:t>
+            </a:r>
+            <a:r>
+              <a:rPr lang="pt-BR" sz="7200" dirty="0">
+                <a:solidFill>
+                  <a:srgbClr val="FF0000"/>
+                </a:solidFill>
+              </a:rPr>
+              <a:t>Mi</a:t>
+            </a:r>
+            <a:br>
+              <a:rPr lang="pt-BR" sz="7200" dirty="0"/>
+            </a:br>
+            <a:r>
+              <a:rPr lang="pt-BR" sz="7200" dirty="0"/>
+              <a:t>&lt;falta o nome&gt; </a:t>
+            </a:r>
+            <a:r>
+              <a:rPr lang="pt-BR" sz="7200" dirty="0">
                 <a:solidFill>
                   <a:srgbClr val="FF0000"/>
                 </a:solidFill>
@@ -19454,19 +19234,19 @@
               <a:t>??</a:t>
             </a:r>
             <a:br>
-              <a:rPr lang="pt-BR" sz="5400" dirty="0"/>
+              <a:rPr lang="pt-BR" sz="7200" dirty="0"/>
             </a:br>
             <a:r>
-              <a:rPr lang="pt-BR" sz="5400" dirty="0"/>
-              <a:t>Marcha do Coelho </a:t>
-            </a:r>
-            <a:r>
-              <a:rPr lang="pt-BR" sz="5400" dirty="0">
-                <a:solidFill>
-                  <a:srgbClr val="FF0000"/>
-                </a:solidFill>
-              </a:rPr>
-              <a:t>??</a:t>
+              <a:rPr lang="pt-BR" sz="7200" dirty="0"/>
+              <a:t>Estrada Da Vida </a:t>
+            </a:r>
+            <a:r>
+              <a:rPr lang="pt-BR" sz="7200" dirty="0">
+                <a:solidFill>
+                  <a:srgbClr val="FF0000"/>
+                </a:solidFill>
+              </a:rPr>
+              <a:t>Sib</a:t>
             </a:r>
           </a:p>
         </p:txBody>
@@ -19474,7 +19254,7 @@
     </p:spTree>
     <p:extLst>
       <p:ext uri="{BB962C8B-B14F-4D97-AF65-F5344CB8AC3E}">
-        <p14:creationId xmlns:p14="http://schemas.microsoft.com/office/powerpoint/2010/main" val="3588785989"/>
+        <p14:creationId xmlns:p14="http://schemas.microsoft.com/office/powerpoint/2010/main" val="4023159127"/>
       </p:ext>
     </p:extLst>
   </p:cSld>
@@ -19542,7 +19322,7 @@
                 </a:solidFill>
                 <a:cs typeface="Arial" panose="020B0604020202020204" pitchFamily="34" charset="0"/>
               </a:rPr>
-              <a:t>VS BLOCO 29</a:t>
+              <a:t>VS BLOCO 28</a:t>
             </a:r>
           </a:p>
           <a:p>
@@ -19556,11 +19336,11 @@
               <a:buNone/>
             </a:pPr>
             <a:r>
-              <a:rPr lang="pt-BR" sz="7200" dirty="0"/>
-              <a:t>Dai Que Mioro </a:t>
-            </a:r>
-            <a:r>
-              <a:rPr lang="pt-BR" sz="7200" dirty="0">
+              <a:rPr lang="pt-BR" sz="5400" dirty="0"/>
+              <a:t>Coronel Boogey </a:t>
+            </a:r>
+            <a:r>
+              <a:rPr lang="pt-BR" sz="5400" dirty="0">
                 <a:solidFill>
                   <a:srgbClr val="FF0000"/>
                 </a:solidFill>
@@ -19568,64 +19348,19 @@
               <a:t>??</a:t>
             </a:r>
             <a:br>
-              <a:rPr lang="pt-BR" sz="7200" dirty="0"/>
+              <a:rPr lang="pt-BR" sz="5400" dirty="0"/>
             </a:br>
             <a:r>
-              <a:rPr lang="pt-BR" sz="7200" dirty="0"/>
-              <a:t>Senta no Colinho do Pai </a:t>
-            </a:r>
-            <a:r>
-              <a:rPr lang="pt-BR" sz="7200" dirty="0">
+              <a:rPr lang="pt-BR" sz="5400" dirty="0"/>
+              <a:t>Marcha do Coelho </a:t>
+            </a:r>
+            <a:r>
+              <a:rPr lang="pt-BR" sz="5400" dirty="0">
                 <a:solidFill>
                   <a:srgbClr val="FF0000"/>
                 </a:solidFill>
               </a:rPr>
               <a:t>??</a:t>
-            </a:r>
-            <a:br>
-              <a:rPr lang="pt-BR" sz="7200" dirty="0"/>
-            </a:br>
-            <a:r>
-              <a:rPr lang="pt-BR" sz="7200" dirty="0"/>
-              <a:t>Latinha na Goteira </a:t>
-            </a:r>
-            <a:r>
-              <a:rPr lang="pt-BR" sz="7200" dirty="0">
-                <a:solidFill>
-                  <a:srgbClr val="FF0000"/>
-                </a:solidFill>
-              </a:rPr>
-              <a:t>Sol</a:t>
-            </a:r>
-            <a:br>
-              <a:rPr lang="pt-BR" sz="7200" dirty="0"/>
-            </a:br>
-            <a:r>
-              <a:rPr lang="pt-BR" sz="7200" dirty="0"/>
-              <a:t>Morenaça </a:t>
-            </a:r>
-            <a:r>
-              <a:rPr lang="pt-BR" sz="7200" dirty="0">
-                <a:solidFill>
-                  <a:srgbClr val="FF0000"/>
-                </a:solidFill>
-              </a:rPr>
-              <a:t>Sol</a:t>
-            </a:r>
-            <a:br>
-              <a:rPr lang="pt-BR" sz="7200" dirty="0"/>
-            </a:br>
-            <a:r>
-              <a:rPr lang="pt-BR" sz="7200" dirty="0"/>
-              <a:t>Misturinha </a:t>
-            </a:r>
-            <a:r>
-              <a:rPr lang="pt-BR" sz="7200" dirty="0">
-                <a:solidFill>
-                  <a:srgbClr val="FF0000"/>
-                </a:solidFill>
-              </a:rPr>
-              <a:t>Fa</a:t>
             </a:r>
           </a:p>
         </p:txBody>
@@ -19633,7 +19368,7 @@
     </p:spTree>
     <p:extLst>
       <p:ext uri="{BB962C8B-B14F-4D97-AF65-F5344CB8AC3E}">
-        <p14:creationId xmlns:p14="http://schemas.microsoft.com/office/powerpoint/2010/main" val="3672496690"/>
+        <p14:creationId xmlns:p14="http://schemas.microsoft.com/office/powerpoint/2010/main" val="2592617258"/>
       </p:ext>
     </p:extLst>
   </p:cSld>
@@ -19701,7 +19436,7 @@
                 </a:solidFill>
                 <a:cs typeface="Arial" panose="020B0604020202020204" pitchFamily="34" charset="0"/>
               </a:rPr>
-              <a:t>VS BLOCO 30</a:t>
+              <a:t>VS BLOCO 29</a:t>
             </a:r>
           </a:p>
           <a:p>
@@ -19716,7 +19451,7 @@
             </a:pPr>
             <a:r>
               <a:rPr lang="pt-BR" sz="7200" dirty="0"/>
-              <a:t>Heyo Heyo </a:t>
+              <a:t>Dai Que Mioro </a:t>
             </a:r>
             <a:r>
               <a:rPr lang="pt-BR" sz="7200" dirty="0">
@@ -19724,14 +19459,14 @@
                   <a:srgbClr val="FF0000"/>
                 </a:solidFill>
               </a:rPr>
-              <a:t>Mib</a:t>
+              <a:t>??</a:t>
             </a:r>
             <a:br>
               <a:rPr lang="pt-BR" sz="7200" dirty="0"/>
             </a:br>
             <a:r>
               <a:rPr lang="pt-BR" sz="7200" dirty="0"/>
-              <a:t>Zic Zac </a:t>
+              <a:t>Senta no Colinho do Pai </a:t>
             </a:r>
             <a:r>
               <a:rPr lang="pt-BR" sz="7200" dirty="0">
@@ -19746,7 +19481,7 @@
             </a:br>
             <a:r>
               <a:rPr lang="pt-BR" sz="7200" dirty="0"/>
-              <a:t>Salada de Frutas </a:t>
+              <a:t>Latinha na Goteira </a:t>
             </a:r>
             <a:r>
               <a:rPr lang="pt-BR" sz="7200" dirty="0">
@@ -19754,7 +19489,37 @@
                   <a:srgbClr val="FF0000"/>
                 </a:solidFill>
               </a:rPr>
-              <a:t>Do</a:t>
+              <a:t>Sol</a:t>
+            </a:r>
+            <a:br>
+              <a:rPr lang="pt-BR" sz="7200" dirty="0"/>
+            </a:br>
+            <a:r>
+              <a:rPr lang="pt-BR" sz="7200" dirty="0"/>
+              <a:t>Morenaça </a:t>
+            </a:r>
+            <a:r>
+              <a:rPr lang="pt-BR" sz="7200" dirty="0">
+                <a:solidFill>
+                  <a:srgbClr val="FF0000"/>
+                </a:solidFill>
+              </a:rPr>
+              <a:t>Sol</a:t>
+            </a:r>
+            <a:br>
+              <a:rPr lang="pt-BR" sz="7200" dirty="0"/>
+            </a:br>
+            <a:r>
+              <a:rPr lang="pt-BR" sz="7200" dirty="0"/>
+              <a:t>Misturinha </a:t>
+            </a:r>
+            <a:r>
+              <a:rPr lang="pt-BR" sz="7200" dirty="0">
+                <a:solidFill>
+                  <a:srgbClr val="FF0000"/>
+                </a:solidFill>
+              </a:rPr>
+              <a:t>Fa</a:t>
             </a:r>
           </a:p>
         </p:txBody>
@@ -19762,7 +19527,7 @@
     </p:spTree>
     <p:extLst>
       <p:ext uri="{BB962C8B-B14F-4D97-AF65-F5344CB8AC3E}">
-        <p14:creationId xmlns:p14="http://schemas.microsoft.com/office/powerpoint/2010/main" val="3086042836"/>
+        <p14:creationId xmlns:p14="http://schemas.microsoft.com/office/powerpoint/2010/main" val="3011462309"/>
       </p:ext>
     </p:extLst>
   </p:cSld>
@@ -19830,7 +19595,7 @@
                 </a:solidFill>
                 <a:cs typeface="Arial" panose="020B0604020202020204" pitchFamily="34" charset="0"/>
               </a:rPr>
-              <a:t>VS BLOCO 31</a:t>
+              <a:t>VS BLOCO 30</a:t>
             </a:r>
           </a:p>
           <a:p>
@@ -19845,7 +19610,7 @@
             </a:pPr>
             <a:r>
               <a:rPr lang="pt-BR" sz="7200" dirty="0"/>
-              <a:t>Nova Iorque </a:t>
+              <a:t>Heyo Heyo </a:t>
             </a:r>
             <a:r>
               <a:rPr lang="pt-BR" sz="7200" dirty="0">
@@ -19853,14 +19618,14 @@
                   <a:srgbClr val="FF0000"/>
                 </a:solidFill>
               </a:rPr>
-              <a:t>??</a:t>
+              <a:t>Mib</a:t>
             </a:r>
             <a:br>
               <a:rPr lang="pt-BR" sz="7200" dirty="0"/>
             </a:br>
             <a:r>
               <a:rPr lang="pt-BR" sz="7200" dirty="0"/>
-              <a:t>Meu Ex Amor </a:t>
+              <a:t>Zic Zac </a:t>
             </a:r>
             <a:r>
               <a:rPr lang="pt-BR" sz="7200" dirty="0">
@@ -19875,7 +19640,7 @@
             </a:br>
             <a:r>
               <a:rPr lang="pt-BR" sz="7200" dirty="0"/>
-              <a:t>O Que Tiver Que Vir Virá </a:t>
+              <a:t>Salada de Frutas </a:t>
             </a:r>
             <a:r>
               <a:rPr lang="pt-BR" sz="7200" dirty="0">
@@ -19883,7 +19648,7 @@
                   <a:srgbClr val="FF0000"/>
                 </a:solidFill>
               </a:rPr>
-              <a:t>Ré</a:t>
+              <a:t>Do</a:t>
             </a:r>
           </a:p>
         </p:txBody>
@@ -19891,7 +19656,7 @@
     </p:spTree>
     <p:extLst>
       <p:ext uri="{BB962C8B-B14F-4D97-AF65-F5344CB8AC3E}">
-        <p14:creationId xmlns:p14="http://schemas.microsoft.com/office/powerpoint/2010/main" val="2158055679"/>
+        <p14:creationId xmlns:p14="http://schemas.microsoft.com/office/powerpoint/2010/main" val="962949835"/>
       </p:ext>
     </p:extLst>
   </p:cSld>
@@ -19959,7 +19724,7 @@
                 </a:solidFill>
                 <a:cs typeface="Arial" panose="020B0604020202020204" pitchFamily="34" charset="0"/>
               </a:rPr>
-              <a:t>VS BLOCO 32</a:t>
+              <a:t>VS BLOCO 31</a:t>
             </a:r>
           </a:p>
           <a:p>
@@ -19974,7 +19739,7 @@
             </a:pPr>
             <a:r>
               <a:rPr lang="pt-BR" sz="7200" dirty="0"/>
-              <a:t>Ponto Chick </a:t>
+              <a:t>Nova Iorque </a:t>
             </a:r>
             <a:r>
               <a:rPr lang="pt-BR" sz="7200" dirty="0">
@@ -19982,14 +19747,14 @@
                   <a:srgbClr val="FF0000"/>
                 </a:solidFill>
               </a:rPr>
-              <a:t>Sib-Mib</a:t>
+              <a:t>??</a:t>
             </a:r>
             <a:br>
               <a:rPr lang="pt-BR" sz="7200" dirty="0"/>
             </a:br>
             <a:r>
               <a:rPr lang="pt-BR" sz="7200" dirty="0"/>
-              <a:t>Rancho Grande </a:t>
+              <a:t>Meu Ex Amor </a:t>
             </a:r>
             <a:r>
               <a:rPr lang="pt-BR" sz="7200" dirty="0">
@@ -20004,7 +19769,7 @@
             </a:br>
             <a:r>
               <a:rPr lang="pt-BR" sz="7200" dirty="0"/>
-              <a:t>Feliz em Festa </a:t>
+              <a:t>O Que Tiver Que Vir Virá </a:t>
             </a:r>
             <a:r>
               <a:rPr lang="pt-BR" sz="7200" dirty="0">
@@ -20012,7 +19777,7 @@
                   <a:srgbClr val="FF0000"/>
                 </a:solidFill>
               </a:rPr>
-              <a:t>??</a:t>
+              <a:t>Ré</a:t>
             </a:r>
           </a:p>
         </p:txBody>
@@ -20020,7 +19785,7 @@
     </p:spTree>
     <p:extLst>
       <p:ext uri="{BB962C8B-B14F-4D97-AF65-F5344CB8AC3E}">
-        <p14:creationId xmlns:p14="http://schemas.microsoft.com/office/powerpoint/2010/main" val="4194378947"/>
+        <p14:creationId xmlns:p14="http://schemas.microsoft.com/office/powerpoint/2010/main" val="1425043211"/>
       </p:ext>
     </p:extLst>
   </p:cSld>
@@ -20088,7 +19853,7 @@
                 </a:solidFill>
                 <a:cs typeface="Arial" panose="020B0604020202020204" pitchFamily="34" charset="0"/>
               </a:rPr>
-              <a:t>VS BLOCO 33</a:t>
+              <a:t>VS BLOCO 32</a:t>
             </a:r>
           </a:p>
           <a:p>
@@ -20103,7 +19868,7 @@
             </a:pPr>
             <a:r>
               <a:rPr lang="pt-BR" sz="7200" dirty="0"/>
-              <a:t>A Festa É com Rota do Chopp </a:t>
+              <a:t>Ponto Chick </a:t>
             </a:r>
             <a:r>
               <a:rPr lang="pt-BR" sz="7200" dirty="0">
@@ -20111,7 +19876,37 @@
                   <a:srgbClr val="FF0000"/>
                 </a:solidFill>
               </a:rPr>
-              <a:t>Fa</a:t>
+              <a:t>Sib-Mib</a:t>
+            </a:r>
+            <a:br>
+              <a:rPr lang="pt-BR" sz="7200" dirty="0"/>
+            </a:br>
+            <a:r>
+              <a:rPr lang="pt-BR" sz="7200" dirty="0"/>
+              <a:t>Rancho Grande </a:t>
+            </a:r>
+            <a:r>
+              <a:rPr lang="pt-BR" sz="7200" dirty="0">
+                <a:solidFill>
+                  <a:srgbClr val="FF0000"/>
+                </a:solidFill>
+              </a:rPr>
+              <a:t>??</a:t>
+            </a:r>
+            <a:br>
+              <a:rPr lang="pt-BR" sz="7200" dirty="0"/>
+            </a:br>
+            <a:r>
+              <a:rPr lang="pt-BR" sz="7200" dirty="0"/>
+              <a:t>Feliz em Festa </a:t>
+            </a:r>
+            <a:r>
+              <a:rPr lang="pt-BR" sz="7200" dirty="0">
+                <a:solidFill>
+                  <a:srgbClr val="FF0000"/>
+                </a:solidFill>
+              </a:rPr>
+              <a:t>??</a:t>
             </a:r>
           </a:p>
         </p:txBody>
@@ -20119,7 +19914,7 @@
     </p:spTree>
     <p:extLst>
       <p:ext uri="{BB962C8B-B14F-4D97-AF65-F5344CB8AC3E}">
-        <p14:creationId xmlns:p14="http://schemas.microsoft.com/office/powerpoint/2010/main" val="1444003938"/>
+        <p14:creationId xmlns:p14="http://schemas.microsoft.com/office/powerpoint/2010/main" val="2605717146"/>
       </p:ext>
     </p:extLst>
   </p:cSld>
@@ -20187,7 +19982,7 @@
                 </a:solidFill>
                 <a:cs typeface="Arial" panose="020B0604020202020204" pitchFamily="34" charset="0"/>
               </a:rPr>
-              <a:t>VS BLOCO 34</a:t>
+              <a:t>VS BLOCO 33</a:t>
             </a:r>
           </a:p>
           <a:p>
@@ -20202,7 +19997,7 @@
             </a:pPr>
             <a:r>
               <a:rPr lang="pt-BR" sz="7200" dirty="0"/>
-              <a:t>Maratá </a:t>
+              <a:t>A Festa É com Rota do Chopp </a:t>
             </a:r>
             <a:r>
               <a:rPr lang="pt-BR" sz="7200" dirty="0">
@@ -20210,37 +20005,7 @@
                   <a:srgbClr val="FF0000"/>
                 </a:solidFill>
               </a:rPr>
-              <a:t>??</a:t>
-            </a:r>
-            <a:br>
-              <a:rPr lang="pt-BR" sz="7200" dirty="0"/>
-            </a:br>
-            <a:r>
-              <a:rPr lang="pt-BR" sz="7200" dirty="0"/>
-              <a:t>Levanta a Poeira </a:t>
-            </a:r>
-            <a:r>
-              <a:rPr lang="pt-BR" sz="7200" dirty="0">
-                <a:solidFill>
-                  <a:srgbClr val="FF0000"/>
-                </a:solidFill>
-              </a:rPr>
-              <a:t>Sib</a:t>
-            </a:r>
-            <a:br>
-              <a:rPr lang="pt-BR" sz="7200" dirty="0"/>
-            </a:br>
-            <a:r>
-              <a:rPr lang="pt-BR" sz="7200" dirty="0"/>
-              <a:t>Polka do Fritz </a:t>
-            </a:r>
-            <a:r>
-              <a:rPr lang="pt-BR" sz="7200" dirty="0">
-                <a:solidFill>
-                  <a:srgbClr val="FF0000"/>
-                </a:solidFill>
-              </a:rPr>
-              <a:t>??</a:t>
+              <a:t>Fa</a:t>
             </a:r>
           </a:p>
         </p:txBody>
@@ -20248,7 +20013,7 @@
     </p:spTree>
     <p:extLst>
       <p:ext uri="{BB962C8B-B14F-4D97-AF65-F5344CB8AC3E}">
-        <p14:creationId xmlns:p14="http://schemas.microsoft.com/office/powerpoint/2010/main" val="3833491578"/>
+        <p14:creationId xmlns:p14="http://schemas.microsoft.com/office/powerpoint/2010/main" val="2048236007"/>
       </p:ext>
     </p:extLst>
   </p:cSld>
@@ -20316,7 +20081,7 @@
                 </a:solidFill>
                 <a:cs typeface="Arial" panose="020B0604020202020204" pitchFamily="34" charset="0"/>
               </a:rPr>
-              <a:t>VS BLOCO 35</a:t>
+              <a:t>VS BLOCO 34</a:t>
             </a:r>
           </a:p>
           <a:p>
@@ -20331,7 +20096,7 @@
             </a:pPr>
             <a:r>
               <a:rPr lang="pt-BR" sz="7200" dirty="0"/>
-              <a:t>Na Hora de Amar </a:t>
+              <a:t>Maratá </a:t>
             </a:r>
             <a:r>
               <a:rPr lang="pt-BR" sz="7200" dirty="0">
@@ -20346,7 +20111,7 @@
             </a:br>
             <a:r>
               <a:rPr lang="pt-BR" sz="7200" dirty="0"/>
-              <a:t>Página de Amigos </a:t>
+              <a:t>Levanta a Poeira </a:t>
             </a:r>
             <a:r>
               <a:rPr lang="pt-BR" sz="7200" dirty="0">
@@ -20354,14 +20119,113 @@
                   <a:srgbClr val="FF0000"/>
                 </a:solidFill>
               </a:rPr>
-              <a:t>??</a:t>
+              <a:t>Sib</a:t>
             </a:r>
             <a:br>
               <a:rPr lang="pt-BR" sz="7200" dirty="0"/>
             </a:br>
             <a:r>
               <a:rPr lang="pt-BR" sz="7200" dirty="0"/>
-              <a:t>Dormi na Praça </a:t>
+              <a:t>Polka do Fritz </a:t>
+            </a:r>
+            <a:r>
+              <a:rPr lang="pt-BR" sz="7200" dirty="0">
+                <a:solidFill>
+                  <a:srgbClr val="FF0000"/>
+                </a:solidFill>
+              </a:rPr>
+              <a:t>??</a:t>
+            </a:r>
+          </a:p>
+        </p:txBody>
+      </p:sp>
+    </p:spTree>
+    <p:extLst>
+      <p:ext uri="{BB962C8B-B14F-4D97-AF65-F5344CB8AC3E}">
+        <p14:creationId xmlns:p14="http://schemas.microsoft.com/office/powerpoint/2010/main" val="2576813450"/>
+      </p:ext>
+    </p:extLst>
+  </p:cSld>
+  <p:clrMapOvr>
+    <a:masterClrMapping/>
+  </p:clrMapOvr>
+</p:sld>
+</file>
+
+<file path=ppt/slides/slide99.xml><?xml version="1.0" encoding="utf-8"?>
+<p:sld xmlns:a="http://schemas.openxmlformats.org/drawingml/2006/main" xmlns:r="http://schemas.openxmlformats.org/officeDocument/2006/relationships" xmlns:p="http://schemas.openxmlformats.org/presentationml/2006/main">
+  <p:cSld>
+    <p:spTree>
+      <p:nvGrpSpPr>
+        <p:cNvPr id="1" name=""/>
+        <p:cNvGrpSpPr/>
+        <p:nvPr/>
+      </p:nvGrpSpPr>
+      <p:grpSpPr>
+        <a:xfrm>
+          <a:off x="0" y="0"/>
+          <a:ext cx="0" cy="0"/>
+          <a:chOff x="0" y="0"/>
+          <a:chExt cx="0" cy="0"/>
+        </a:xfrm>
+      </p:grpSpPr>
+      <p:sp>
+        <p:nvSpPr>
+          <p:cNvPr id="3" name="Espaço Reservado para Conteúdo 2">
+            <a:extLst>
+              <a:ext uri="{FF2B5EF4-FFF2-40B4-BE49-F238E27FC236}">
+                <a16:creationId xmlns:a16="http://schemas.microsoft.com/office/drawing/2014/main" id="{7C70BAA2-54A1-BAA9-5EF9-9F93F22AE700}"/>
+              </a:ext>
+            </a:extLst>
+          </p:cNvPr>
+          <p:cNvSpPr>
+            <a:spLocks noGrp="1"/>
+          </p:cNvSpPr>
+          <p:nvPr>
+            <p:ph idx="1"/>
+          </p:nvPr>
+        </p:nvSpPr>
+        <p:spPr>
+          <a:xfrm>
+            <a:off x="10509" y="-3937"/>
+            <a:ext cx="12181491" cy="6861937"/>
+          </a:xfrm>
+        </p:spPr>
+        <p:txBody>
+          <a:bodyPr>
+            <a:noAutofit/>
+          </a:bodyPr>
+          <a:lstStyle/>
+          <a:p>
+            <a:pPr algn="ctr">
+              <a:lnSpc>
+                <a:spcPct val="100000"/>
+              </a:lnSpc>
+              <a:buNone/>
+            </a:pPr>
+            <a:r>
+              <a:rPr lang="en-US" sz="8800" dirty="0">
+                <a:solidFill>
+                  <a:srgbClr val="FF0000"/>
+                </a:solidFill>
+                <a:cs typeface="Arial" panose="020B0604020202020204" pitchFamily="34" charset="0"/>
+              </a:rPr>
+              <a:t>VS BLOCO 35</a:t>
+            </a:r>
+          </a:p>
+          <a:p>
+            <a:pPr marL="36000" indent="-252000" algn="ctr">
+              <a:lnSpc>
+                <a:spcPct val="100000"/>
+              </a:lnSpc>
+              <a:spcBef>
+                <a:spcPts val="0"/>
+              </a:spcBef>
+              <a:buNone/>
+            </a:pPr>
+            <a:r>
+              <a:rPr lang="pt-BR" sz="7200" dirty="0"/>
+              <a:t>Na Hora de Amar </a:t>
             </a:r>
             <a:r>
               <a:rPr lang="pt-BR" sz="7200" dirty="0">
@@ -20376,7 +20240,7 @@
             </a:br>
             <a:r>
               <a:rPr lang="pt-BR" sz="7200" dirty="0"/>
-              <a:t>Temporal de Amor </a:t>
+              <a:t>Página de Amigos </a:t>
             </a:r>
             <a:r>
               <a:rPr lang="pt-BR" sz="7200" dirty="0">
@@ -20391,6 +20255,36 @@
             </a:br>
             <a:r>
               <a:rPr lang="pt-BR" sz="7200" dirty="0"/>
+              <a:t>Dormi na Praça </a:t>
+            </a:r>
+            <a:r>
+              <a:rPr lang="pt-BR" sz="7200" dirty="0">
+                <a:solidFill>
+                  <a:srgbClr val="FF0000"/>
+                </a:solidFill>
+              </a:rPr>
+              <a:t>??</a:t>
+            </a:r>
+            <a:br>
+              <a:rPr lang="pt-BR" sz="7200" dirty="0"/>
+            </a:br>
+            <a:r>
+              <a:rPr lang="pt-BR" sz="7200" dirty="0"/>
+              <a:t>Temporal de Amor </a:t>
+            </a:r>
+            <a:r>
+              <a:rPr lang="pt-BR" sz="7200" dirty="0">
+                <a:solidFill>
+                  <a:srgbClr val="FF0000"/>
+                </a:solidFill>
+              </a:rPr>
+              <a:t>??</a:t>
+            </a:r>
+            <a:br>
+              <a:rPr lang="pt-BR" sz="7200" dirty="0"/>
+            </a:br>
+            <a:r>
+              <a:rPr lang="pt-BR" sz="7200" dirty="0"/>
               <a:t>Evidências </a:t>
             </a:r>
             <a:r>
@@ -20407,7 +20301,7 @@
     </p:spTree>
     <p:extLst>
       <p:ext uri="{BB962C8B-B14F-4D97-AF65-F5344CB8AC3E}">
-        <p14:creationId xmlns:p14="http://schemas.microsoft.com/office/powerpoint/2010/main" val="114692999"/>
+        <p14:creationId xmlns:p14="http://schemas.microsoft.com/office/powerpoint/2010/main" val="3575221592"/>
       </p:ext>
     </p:extLst>
   </p:cSld>

</xml_diff>

<commit_message>
Adiciona o bloco 36 (FUTURISTA), põe o BPM ao lado do nome no repertório e corrige Barquinha.
Co-authored-by: Cursor <cursoragent@cursor.com>
</commit_message>
<xml_diff>
--- a/REPERTÓRIO/Repertório Rota do Chopp - COMPLETO.pptx
+++ b/REPERTÓRIO/Repertório Rota do Chopp - COMPLETO.pptx
@@ -5,10 +5,10 @@
     <p:sldMasterId id="2147483804" r:id="rId1"/>
   </p:sldMasterIdLst>
   <p:handoutMasterIdLst>
-    <p:handoutMasterId r:id="rId101"/>
+    <p:handoutMasterId r:id="rId102"/>
   </p:handoutMasterIdLst>
   <p:sldIdLst>
-    <p:sldId id="484" r:id="rId2"/>
+    <p:sldId id="485" r:id="rId2"/>
     <p:sldId id="416" r:id="rId3"/>
     <p:sldId id="381" r:id="rId4"/>
     <p:sldId id="382" r:id="rId5"/>
@@ -107,6 +107,7 @@
     <p:sldId id="481" r:id="rId98"/>
     <p:sldId id="482" r:id="rId99"/>
     <p:sldId id="483" r:id="rId100"/>
+    <p:sldId id="484" r:id="rId101"/>
   </p:sldIdLst>
   <p:sldSz cx="12192000" cy="6858000"/>
   <p:notesSz cx="6858000" cy="9144000"/>
@@ -565,7 +566,7 @@
           <a:p>
             <a:fld id="{9F69E24D-9DBE-4DAB-A481-718B3C423892}" type="datetimeFigureOut">
               <a:rPr lang="pt-BR" smtClean="0"/>
-              <a:t>17/10/2026</a:t>
+              <a:t>24/10/2026</a:t>
             </a:fld>
             <a:endParaRPr lang="pt-BR"/>
           </a:p>
@@ -631,7 +632,7 @@
           <a:p>
             <a:fld id="{B00E33F2-1AEA-4A8F-89D6-776151CD4A14}" type="slidenum">
               <a:rPr lang="pt-BR" smtClean="0"/>
-              <a:t>‹nº›</a:t>
+              <a:t>‹#›</a:t>
             </a:fld>
             <a:endParaRPr lang="pt-BR"/>
           </a:p>
@@ -782,7 +783,7 @@
             <a:fld id="{BB0B304C-6D9A-40FB-A8B9-28880A8BB8D2}" type="datetimeFigureOut">
               <a:rPr lang="pt-BR" smtClean="0"/>
               <a:pPr/>
-              <a:t>17/10/2026</a:t>
+              <a:t>24/10/2026</a:t>
             </a:fld>
             <a:endParaRPr lang="pt-BR"/>
           </a:p>
@@ -825,7 +826,7 @@
             <a:fld id="{815917E5-2990-4847-B656-AC00D545A81B}" type="slidenum">
               <a:rPr lang="pt-BR" smtClean="0"/>
               <a:pPr/>
-              <a:t>‹nº›</a:t>
+              <a:t>‹#›</a:t>
             </a:fld>
             <a:endParaRPr lang="pt-BR"/>
           </a:p>
@@ -1071,7 +1072,7 @@
             <a:fld id="{BB0B304C-6D9A-40FB-A8B9-28880A8BB8D2}" type="datetimeFigureOut">
               <a:rPr lang="pt-BR" smtClean="0"/>
               <a:pPr/>
-              <a:t>17/10/2026</a:t>
+              <a:t>24/10/2026</a:t>
             </a:fld>
             <a:endParaRPr lang="pt-BR"/>
           </a:p>
@@ -1114,7 +1115,7 @@
             <a:fld id="{815917E5-2990-4847-B656-AC00D545A81B}" type="slidenum">
               <a:rPr lang="pt-BR" smtClean="0"/>
               <a:pPr/>
-              <a:t>‹nº›</a:t>
+              <a:t>‹#›</a:t>
             </a:fld>
             <a:endParaRPr lang="pt-BR"/>
           </a:p>
@@ -1265,7 +1266,7 @@
             <a:fld id="{BB0B304C-6D9A-40FB-A8B9-28880A8BB8D2}" type="datetimeFigureOut">
               <a:rPr lang="pt-BR" smtClean="0"/>
               <a:pPr/>
-              <a:t>17/10/2026</a:t>
+              <a:t>24/10/2026</a:t>
             </a:fld>
             <a:endParaRPr lang="pt-BR"/>
           </a:p>
@@ -1308,7 +1309,7 @@
             <a:fld id="{815917E5-2990-4847-B656-AC00D545A81B}" type="slidenum">
               <a:rPr lang="pt-BR" smtClean="0"/>
               <a:pPr/>
-              <a:t>‹nº›</a:t>
+              <a:t>‹#›</a:t>
             </a:fld>
             <a:endParaRPr lang="pt-BR"/>
           </a:p>
@@ -1528,7 +1529,7 @@
             <a:fld id="{BB0B304C-6D9A-40FB-A8B9-28880A8BB8D2}" type="datetimeFigureOut">
               <a:rPr lang="pt-BR" smtClean="0"/>
               <a:pPr/>
-              <a:t>17/10/2026</a:t>
+              <a:t>24/10/2026</a:t>
             </a:fld>
             <a:endParaRPr lang="pt-BR"/>
           </a:p>
@@ -1571,7 +1572,7 @@
             <a:fld id="{815917E5-2990-4847-B656-AC00D545A81B}" type="slidenum">
               <a:rPr lang="pt-BR" smtClean="0"/>
               <a:pPr/>
-              <a:t>‹nº›</a:t>
+              <a:t>‹#›</a:t>
             </a:fld>
             <a:endParaRPr lang="pt-BR"/>
           </a:p>
@@ -1954,7 +1955,7 @@
             <a:fld id="{BB0B304C-6D9A-40FB-A8B9-28880A8BB8D2}" type="datetimeFigureOut">
               <a:rPr lang="pt-BR" smtClean="0"/>
               <a:pPr/>
-              <a:t>17/10/2026</a:t>
+              <a:t>24/10/2026</a:t>
             </a:fld>
             <a:endParaRPr lang="pt-BR"/>
           </a:p>
@@ -1997,7 +1998,7 @@
             <a:fld id="{815917E5-2990-4847-B656-AC00D545A81B}" type="slidenum">
               <a:rPr lang="pt-BR" smtClean="0"/>
               <a:pPr/>
-              <a:t>‹nº›</a:t>
+              <a:t>‹#›</a:t>
             </a:fld>
             <a:endParaRPr lang="pt-BR"/>
           </a:p>
@@ -2502,7 +2503,7 @@
             <a:fld id="{BB0B304C-6D9A-40FB-A8B9-28880A8BB8D2}" type="datetimeFigureOut">
               <a:rPr lang="pt-BR" smtClean="0"/>
               <a:pPr/>
-              <a:t>17/10/2026</a:t>
+              <a:t>24/10/2026</a:t>
             </a:fld>
             <a:endParaRPr lang="pt-BR"/>
           </a:p>
@@ -2545,7 +2546,7 @@
             <a:fld id="{815917E5-2990-4847-B656-AC00D545A81B}" type="slidenum">
               <a:rPr lang="pt-BR" smtClean="0"/>
               <a:pPr/>
-              <a:t>‹nº›</a:t>
+              <a:t>‹#›</a:t>
             </a:fld>
             <a:endParaRPr lang="pt-BR"/>
           </a:p>
@@ -3344,7 +3345,7 @@
             <a:fld id="{BB0B304C-6D9A-40FB-A8B9-28880A8BB8D2}" type="datetimeFigureOut">
               <a:rPr lang="pt-BR" smtClean="0"/>
               <a:pPr/>
-              <a:t>17/10/2026</a:t>
+              <a:t>24/10/2026</a:t>
             </a:fld>
             <a:endParaRPr lang="pt-BR"/>
           </a:p>
@@ -3387,7 +3388,7 @@
             <a:fld id="{815917E5-2990-4847-B656-AC00D545A81B}" type="slidenum">
               <a:rPr lang="pt-BR" smtClean="0"/>
               <a:pPr/>
-              <a:t>‹nº›</a:t>
+              <a:t>‹#›</a:t>
             </a:fld>
             <a:endParaRPr lang="pt-BR"/>
           </a:p>
@@ -3516,7 +3517,7 @@
             <a:fld id="{BB0B304C-6D9A-40FB-A8B9-28880A8BB8D2}" type="datetimeFigureOut">
               <a:rPr lang="pt-BR" smtClean="0"/>
               <a:pPr/>
-              <a:t>17/10/2026</a:t>
+              <a:t>24/10/2026</a:t>
             </a:fld>
             <a:endParaRPr lang="pt-BR"/>
           </a:p>
@@ -3559,7 +3560,7 @@
             <a:fld id="{815917E5-2990-4847-B656-AC00D545A81B}" type="slidenum">
               <a:rPr lang="pt-BR" smtClean="0"/>
               <a:pPr/>
-              <a:t>‹nº›</a:t>
+              <a:t>‹#›</a:t>
             </a:fld>
             <a:endParaRPr lang="pt-BR"/>
           </a:p>
@@ -3702,7 +3703,7 @@
             <a:fld id="{BB0B304C-6D9A-40FB-A8B9-28880A8BB8D2}" type="datetimeFigureOut">
               <a:rPr lang="pt-BR" smtClean="0"/>
               <a:pPr/>
-              <a:t>17/10/2026</a:t>
+              <a:t>24/10/2026</a:t>
             </a:fld>
             <a:endParaRPr lang="pt-BR"/>
           </a:p>
@@ -3745,7 +3746,7 @@
             <a:fld id="{815917E5-2990-4847-B656-AC00D545A81B}" type="slidenum">
               <a:rPr lang="pt-BR" smtClean="0"/>
               <a:pPr/>
-              <a:t>‹nº›</a:t>
+              <a:t>‹#›</a:t>
             </a:fld>
             <a:endParaRPr lang="pt-BR"/>
           </a:p>
@@ -3874,7 +3875,7 @@
             <a:fld id="{BB0B304C-6D9A-40FB-A8B9-28880A8BB8D2}" type="datetimeFigureOut">
               <a:rPr lang="pt-BR" smtClean="0"/>
               <a:pPr/>
-              <a:t>17/10/2026</a:t>
+              <a:t>24/10/2026</a:t>
             </a:fld>
             <a:endParaRPr lang="pt-BR"/>
           </a:p>
@@ -3917,7 +3918,7 @@
             <a:fld id="{815917E5-2990-4847-B656-AC00D545A81B}" type="slidenum">
               <a:rPr lang="pt-BR" smtClean="0"/>
               <a:pPr/>
-              <a:t>‹nº›</a:t>
+              <a:t>‹#›</a:t>
             </a:fld>
             <a:endParaRPr lang="pt-BR"/>
           </a:p>
@@ -4124,7 +4125,7 @@
             <a:fld id="{BB0B304C-6D9A-40FB-A8B9-28880A8BB8D2}" type="datetimeFigureOut">
               <a:rPr lang="pt-BR" smtClean="0"/>
               <a:pPr/>
-              <a:t>17/10/2026</a:t>
+              <a:t>24/10/2026</a:t>
             </a:fld>
             <a:endParaRPr lang="pt-BR"/>
           </a:p>
@@ -4167,7 +4168,7 @@
             <a:fld id="{815917E5-2990-4847-B656-AC00D545A81B}" type="slidenum">
               <a:rPr lang="pt-BR" smtClean="0"/>
               <a:pPr/>
-              <a:t>‹nº›</a:t>
+              <a:t>‹#›</a:t>
             </a:fld>
             <a:endParaRPr lang="pt-BR"/>
           </a:p>
@@ -4363,7 +4364,7 @@
             <a:fld id="{BB0B304C-6D9A-40FB-A8B9-28880A8BB8D2}" type="datetimeFigureOut">
               <a:rPr lang="pt-BR" smtClean="0"/>
               <a:pPr/>
-              <a:t>17/10/2026</a:t>
+              <a:t>24/10/2026</a:t>
             </a:fld>
             <a:endParaRPr lang="pt-BR"/>
           </a:p>
@@ -4406,7 +4407,7 @@
             <a:fld id="{815917E5-2990-4847-B656-AC00D545A81B}" type="slidenum">
               <a:rPr lang="pt-BR" smtClean="0"/>
               <a:pPr/>
-              <a:t>‹nº›</a:t>
+              <a:t>‹#›</a:t>
             </a:fld>
             <a:endParaRPr lang="pt-BR"/>
           </a:p>
@@ -4738,7 +4739,7 @@
             <a:fld id="{BB0B304C-6D9A-40FB-A8B9-28880A8BB8D2}" type="datetimeFigureOut">
               <a:rPr lang="pt-BR" smtClean="0"/>
               <a:pPr/>
-              <a:t>17/10/2026</a:t>
+              <a:t>24/10/2026</a:t>
             </a:fld>
             <a:endParaRPr lang="pt-BR"/>
           </a:p>
@@ -4781,7 +4782,7 @@
             <a:fld id="{815917E5-2990-4847-B656-AC00D545A81B}" type="slidenum">
               <a:rPr lang="pt-BR" smtClean="0"/>
               <a:pPr/>
-              <a:t>‹nº›</a:t>
+              <a:t>‹#›</a:t>
             </a:fld>
             <a:endParaRPr lang="pt-BR"/>
           </a:p>
@@ -4858,7 +4859,7 @@
             <a:fld id="{BB0B304C-6D9A-40FB-A8B9-28880A8BB8D2}" type="datetimeFigureOut">
               <a:rPr lang="pt-BR" smtClean="0"/>
               <a:pPr/>
-              <a:t>17/10/2026</a:t>
+              <a:t>24/10/2026</a:t>
             </a:fld>
             <a:endParaRPr lang="pt-BR"/>
           </a:p>
@@ -4901,7 +4902,7 @@
             <a:fld id="{815917E5-2990-4847-B656-AC00D545A81B}" type="slidenum">
               <a:rPr lang="pt-BR" smtClean="0"/>
               <a:pPr/>
-              <a:t>‹nº›</a:t>
+              <a:t>‹#›</a:t>
             </a:fld>
             <a:endParaRPr lang="pt-BR"/>
           </a:p>
@@ -4955,7 +4956,7 @@
             <a:fld id="{BB0B304C-6D9A-40FB-A8B9-28880A8BB8D2}" type="datetimeFigureOut">
               <a:rPr lang="pt-BR" smtClean="0"/>
               <a:pPr/>
-              <a:t>17/10/2026</a:t>
+              <a:t>24/10/2026</a:t>
             </a:fld>
             <a:endParaRPr lang="pt-BR"/>
           </a:p>
@@ -4998,7 +4999,7 @@
             <a:fld id="{815917E5-2990-4847-B656-AC00D545A81B}" type="slidenum">
               <a:rPr lang="pt-BR" smtClean="0"/>
               <a:pPr/>
-              <a:t>‹nº›</a:t>
+              <a:t>‹#›</a:t>
             </a:fld>
             <a:endParaRPr lang="pt-BR"/>
           </a:p>
@@ -5208,7 +5209,7 @@
             <a:fld id="{BB0B304C-6D9A-40FB-A8B9-28880A8BB8D2}" type="datetimeFigureOut">
               <a:rPr lang="pt-BR" smtClean="0"/>
               <a:pPr/>
-              <a:t>17/10/2026</a:t>
+              <a:t>24/10/2026</a:t>
             </a:fld>
             <a:endParaRPr lang="pt-BR"/>
           </a:p>
@@ -5251,7 +5252,7 @@
             <a:fld id="{815917E5-2990-4847-B656-AC00D545A81B}" type="slidenum">
               <a:rPr lang="pt-BR" smtClean="0"/>
               <a:pPr/>
-              <a:t>‹nº›</a:t>
+              <a:t>‹#›</a:t>
             </a:fld>
             <a:endParaRPr lang="pt-BR"/>
           </a:p>
@@ -5497,7 +5498,7 @@
             <a:fld id="{BB0B304C-6D9A-40FB-A8B9-28880A8BB8D2}" type="datetimeFigureOut">
               <a:rPr lang="pt-BR" smtClean="0"/>
               <a:pPr/>
-              <a:t>17/10/2026</a:t>
+              <a:t>24/10/2026</a:t>
             </a:fld>
             <a:endParaRPr lang="pt-BR"/>
           </a:p>
@@ -5540,7 +5541,7 @@
             <a:fld id="{815917E5-2990-4847-B656-AC00D545A81B}" type="slidenum">
               <a:rPr lang="pt-BR" smtClean="0"/>
               <a:pPr/>
-              <a:t>‹nº›</a:t>
+              <a:t>‹#›</a:t>
             </a:fld>
             <a:endParaRPr lang="pt-BR"/>
           </a:p>
@@ -5712,7 +5713,7 @@
             <a:fld id="{BB0B304C-6D9A-40FB-A8B9-28880A8BB8D2}" type="datetimeFigureOut">
               <a:rPr lang="pt-BR" smtClean="0"/>
               <a:pPr/>
-              <a:t>17/10/2026</a:t>
+              <a:t>24/10/2026</a:t>
             </a:fld>
             <a:endParaRPr lang="pt-BR"/>
           </a:p>
@@ -5791,7 +5792,7 @@
             <a:fld id="{815917E5-2990-4847-B656-AC00D545A81B}" type="slidenum">
               <a:rPr lang="pt-BR" smtClean="0"/>
               <a:pPr/>
-              <a:t>‹nº›</a:t>
+              <a:t>‹#›</a:t>
             </a:fld>
             <a:endParaRPr lang="pt-BR"/>
           </a:p>
@@ -6196,10 +6197,10 @@
       </p:grpSpPr>
       <p:pic>
         <p:nvPicPr>
-          <p:cNvPr id="3" name="Imagem 2">
+          <p:cNvPr id="3" name="Picture 2">
             <a:extLst>
               <a:ext uri="{FF2B5EF4-FFF2-40B4-BE49-F238E27FC236}">
-                <a16:creationId xmlns:a16="http://schemas.microsoft.com/office/drawing/2014/main" id="{F429F386-107B-1B77-F7FD-6B74855304D9}"/>
+                <a16:creationId xmlns:a16="http://schemas.microsoft.com/office/drawing/2014/main" id="{65415F35-4A06-0FCC-ECB1-A5FC2ABFE813}"/>
               </a:ext>
             </a:extLst>
           </p:cNvPr>
@@ -6233,7 +6234,7 @@
     </p:spTree>
     <p:extLst>
       <p:ext uri="{BB962C8B-B14F-4D97-AF65-F5344CB8AC3E}">
-        <p14:creationId xmlns:p14="http://schemas.microsoft.com/office/powerpoint/2010/main" val="1857954803"/>
+        <p14:creationId xmlns:p14="http://schemas.microsoft.com/office/powerpoint/2010/main" val="397558887"/>
       </p:ext>
     </p:extLst>
   </p:cSld>
@@ -6375,6 +6376,118 @@
     <p:extLst>
       <p:ext uri="{BB962C8B-B14F-4D97-AF65-F5344CB8AC3E}">
         <p14:creationId xmlns:p14="http://schemas.microsoft.com/office/powerpoint/2010/main" val="1541091708"/>
+      </p:ext>
+    </p:extLst>
+  </p:cSld>
+  <p:clrMapOvr>
+    <a:masterClrMapping/>
+  </p:clrMapOvr>
+</p:sld>
+</file>
+
+<file path=ppt/slides/slide100.xml><?xml version="1.0" encoding="utf-8"?>
+<p:sld xmlns:a="http://schemas.openxmlformats.org/drawingml/2006/main" xmlns:r="http://schemas.openxmlformats.org/officeDocument/2006/relationships" xmlns:p="http://schemas.openxmlformats.org/presentationml/2006/main">
+  <p:cSld>
+    <p:spTree>
+      <p:nvGrpSpPr>
+        <p:cNvPr id="1" name=""/>
+        <p:cNvGrpSpPr/>
+        <p:nvPr/>
+      </p:nvGrpSpPr>
+      <p:grpSpPr>
+        <a:xfrm>
+          <a:off x="0" y="0"/>
+          <a:ext cx="0" cy="0"/>
+          <a:chOff x="0" y="0"/>
+          <a:chExt cx="0" cy="0"/>
+        </a:xfrm>
+      </p:grpSpPr>
+      <p:sp>
+        <p:nvSpPr>
+          <p:cNvPr id="3" name="Espaço Reservado para Conteúdo 2">
+            <a:extLst>
+              <a:ext uri="{FF2B5EF4-FFF2-40B4-BE49-F238E27FC236}">
+                <a16:creationId xmlns:a16="http://schemas.microsoft.com/office/drawing/2014/main" id="{7C70BAA2-54A1-BAA9-5EF9-9F93F22AE700}"/>
+              </a:ext>
+            </a:extLst>
+          </p:cNvPr>
+          <p:cNvSpPr>
+            <a:spLocks noGrp="1"/>
+          </p:cNvSpPr>
+          <p:nvPr>
+            <p:ph idx="1"/>
+          </p:nvPr>
+        </p:nvSpPr>
+        <p:spPr>
+          <a:xfrm>
+            <a:off x="10509" y="-3937"/>
+            <a:ext cx="12181491" cy="6861937"/>
+          </a:xfrm>
+        </p:spPr>
+        <p:txBody>
+          <a:bodyPr>
+            <a:noAutofit/>
+          </a:bodyPr>
+          <a:lstStyle/>
+          <a:p>
+            <a:pPr algn="ctr">
+              <a:lnSpc>
+                <a:spcPct val="100000"/>
+              </a:lnSpc>
+              <a:buNone/>
+            </a:pPr>
+            <a:r>
+              <a:rPr lang="en-US" sz="8800" dirty="0">
+                <a:solidFill>
+                  <a:srgbClr val="FF0000"/>
+                </a:solidFill>
+                <a:cs typeface="Arial" panose="020B0604020202020204" pitchFamily="34" charset="0"/>
+              </a:rPr>
+              <a:t>VS BLOCO 36</a:t>
+            </a:r>
+            <a:r>
+              <a:rPr lang="pt-BR" sz="4800" baseline="41667" dirty="0">
+                <a:solidFill>
+                  <a:srgbClr val="FFFFFF"/>
+                </a:solidFill>
+                <a:cs typeface="Arial" panose="020B0604020202020204" pitchFamily="34" charset="0"/>
+              </a:rPr>
+              <a:t>  135 BPM</a:t>
+            </a:r>
+          </a:p>
+          <a:p>
+            <a:pPr marL="36000" indent="-252000" algn="ctr">
+              <a:lnSpc>
+                <a:spcPct val="100000"/>
+              </a:lnSpc>
+              <a:spcBef>
+                <a:spcPts val="0"/>
+              </a:spcBef>
+              <a:buNone/>
+            </a:pPr>
+            <a:r>
+              <a:rPr lang="pt-BR" sz="7200" dirty="0">
+                <a:solidFill>
+                  <a:srgbClr val="FFFFFF"/>
+                </a:solidFill>
+              </a:rPr>
+              <a:t>Futurista </a:t>
+            </a:r>
+            <a:r>
+              <a:rPr lang="pt-BR" sz="7200" dirty="0">
+                <a:solidFill>
+                  <a:srgbClr val="FF0000"/>
+                </a:solidFill>
+              </a:rPr>
+              <a:t>??</a:t>
+            </a:r>
+          </a:p>
+        </p:txBody>
+      </p:sp>
+    </p:spTree>
+    <p:extLst>
+      <p:ext uri="{BB962C8B-B14F-4D97-AF65-F5344CB8AC3E}">
+        <p14:creationId xmlns:p14="http://schemas.microsoft.com/office/powerpoint/2010/main" val="2630754213"/>
       </p:ext>
     </p:extLst>
   </p:cSld>
@@ -14539,7 +14652,7 @@
     </p:spTree>
     <p:extLst>
       <p:ext uri="{BB962C8B-B14F-4D97-AF65-F5344CB8AC3E}">
-        <p14:creationId xmlns:p14="http://schemas.microsoft.com/office/powerpoint/2010/main" val="1701172766"/>
+        <p14:creationId xmlns:p14="http://schemas.microsoft.com/office/powerpoint/2010/main" val="276339301"/>
       </p:ext>
     </p:extLst>
   </p:cSld>
@@ -14615,6 +14728,15 @@
               </a:rPr>
               <a:t>VS BLOCO 1</a:t>
             </a:r>
+            <a:r>
+              <a:rPr lang="pt-BR" sz="4800" baseline="41667" dirty="0">
+                <a:solidFill>
+                  <a:srgbClr val="FFFFFF"/>
+                </a:solidFill>
+                <a:cs typeface="Arial" panose="020B0604020202020204" pitchFamily="34" charset="0"/>
+              </a:rPr>
+              <a:t>  140 BPM</a:t>
+            </a:r>
           </a:p>
           <a:p>
             <a:pPr marL="36000" indent="-252000" algn="ctr">
@@ -14628,12 +14750,18 @@
             </a:pPr>
             <a:r>
               <a:rPr lang="en-US" sz="7200" dirty="0" err="1">
+                <a:solidFill>
+                  <a:srgbClr val="FFFFFF"/>
+                </a:solidFill>
                 <a:cs typeface="Arial" panose="020B0604020202020204" pitchFamily="34" charset="0"/>
               </a:rPr>
               <a:t>Alambique</a:t>
             </a:r>
             <a:r>
               <a:rPr lang="en-US" sz="7200" dirty="0">
+                <a:solidFill>
+                  <a:srgbClr val="FFFFFF"/>
+                </a:solidFill>
                 <a:cs typeface="Arial" panose="020B0604020202020204" pitchFamily="34" charset="0"/>
               </a:rPr>
               <a:t> </a:t>
@@ -14660,18 +14788,27 @@
             </a:pPr>
             <a:r>
               <a:rPr lang="en-US" sz="7200" dirty="0">
+                <a:solidFill>
+                  <a:srgbClr val="FFFFFF"/>
+                </a:solidFill>
                 <a:cs typeface="Arial" panose="020B0604020202020204" pitchFamily="34" charset="0"/>
               </a:rPr>
               <a:t>Pode </a:t>
             </a:r>
             <a:r>
               <a:rPr lang="en-US" sz="7200" dirty="0" err="1">
+                <a:solidFill>
+                  <a:srgbClr val="FFFFFF"/>
+                </a:solidFill>
                 <a:cs typeface="Arial" panose="020B0604020202020204" pitchFamily="34" charset="0"/>
               </a:rPr>
               <a:t>Passar</a:t>
             </a:r>
             <a:r>
               <a:rPr lang="en-US" sz="7200" dirty="0">
+                <a:solidFill>
+                  <a:srgbClr val="FFFFFF"/>
+                </a:solidFill>
                 <a:cs typeface="Arial" panose="020B0604020202020204" pitchFamily="34" charset="0"/>
               </a:rPr>
               <a:t> o Rodo </a:t>
@@ -14698,12 +14835,18 @@
             </a:pPr>
             <a:r>
               <a:rPr lang="en-US" sz="7200" dirty="0" err="1">
+                <a:solidFill>
+                  <a:srgbClr val="FFFFFF"/>
+                </a:solidFill>
                 <a:cs typeface="Arial" panose="020B0604020202020204" pitchFamily="34" charset="0"/>
               </a:rPr>
               <a:t>Sofro</a:t>
             </a:r>
             <a:r>
               <a:rPr lang="en-US" sz="7200" dirty="0">
+                <a:solidFill>
+                  <a:srgbClr val="FFFFFF"/>
+                </a:solidFill>
                 <a:cs typeface="Arial" panose="020B0604020202020204" pitchFamily="34" charset="0"/>
               </a:rPr>
               <a:t> e Choro </a:t>
@@ -14743,7 +14886,7 @@
     </p:spTree>
     <p:extLst>
       <p:ext uri="{BB962C8B-B14F-4D97-AF65-F5344CB8AC3E}">
-        <p14:creationId xmlns:p14="http://schemas.microsoft.com/office/powerpoint/2010/main" val="3909828367"/>
+        <p14:creationId xmlns:p14="http://schemas.microsoft.com/office/powerpoint/2010/main" val="591764810"/>
       </p:ext>
     </p:extLst>
   </p:cSld>
@@ -14819,6 +14962,15 @@
               </a:rPr>
               <a:t>VS BLOCO 2</a:t>
             </a:r>
+            <a:r>
+              <a:rPr lang="pt-BR" sz="4800" baseline="41667" dirty="0">
+                <a:solidFill>
+                  <a:srgbClr val="FFFFFF"/>
+                </a:solidFill>
+                <a:cs typeface="Arial" panose="020B0604020202020204" pitchFamily="34" charset="0"/>
+              </a:rPr>
+              <a:t>  137 BPM</a:t>
+            </a:r>
           </a:p>
           <a:p>
             <a:pPr marL="36000" indent="-252000" algn="ctr">
@@ -14831,15 +14983,27 @@
               <a:buNone/>
             </a:pPr>
             <a:r>
-              <a:rPr lang="pt-BR" sz="7200" dirty="0"/>
+              <a:rPr lang="pt-BR" sz="7200" dirty="0">
+                <a:solidFill>
+                  <a:srgbClr val="FFFFFF"/>
+                </a:solidFill>
+              </a:rPr>
               <a:t>Amor </a:t>
             </a:r>
             <a:r>
-              <a:rPr lang="pt-BR" sz="7200" dirty="0" err="1"/>
+              <a:rPr lang="pt-BR" sz="7200" dirty="0" err="1">
+                <a:solidFill>
+                  <a:srgbClr val="FFFFFF"/>
+                </a:solidFill>
+              </a:rPr>
               <a:t>Carrapixo</a:t>
             </a:r>
             <a:r>
-              <a:rPr lang="pt-BR" sz="7200" dirty="0"/>
+              <a:rPr lang="pt-BR" sz="7200" dirty="0">
+                <a:solidFill>
+                  <a:srgbClr val="FFFFFF"/>
+                </a:solidFill>
+              </a:rPr>
               <a:t> </a:t>
             </a:r>
             <a:r>
@@ -14854,7 +15018,11 @@
               <a:rPr lang="pt-BR" sz="7200" dirty="0"/>
             </a:br>
             <a:r>
-              <a:rPr lang="pt-BR" sz="7200" dirty="0"/>
+              <a:rPr lang="pt-BR" sz="7200" dirty="0">
+                <a:solidFill>
+                  <a:srgbClr val="FFFFFF"/>
+                </a:solidFill>
+              </a:rPr>
               <a:t>Casa Cair </a:t>
             </a:r>
             <a:r>
@@ -14869,7 +15037,11 @@
               <a:rPr lang="pt-BR" sz="7200" dirty="0"/>
             </a:br>
             <a:r>
-              <a:rPr lang="pt-BR" sz="7200" dirty="0"/>
+              <a:rPr lang="pt-BR" sz="7200" dirty="0">
+                <a:solidFill>
+                  <a:srgbClr val="FFFFFF"/>
+                </a:solidFill>
+              </a:rPr>
               <a:t>Sola Da Bota </a:t>
             </a:r>
             <a:r>
@@ -14884,7 +15056,11 @@
               <a:rPr lang="pt-BR" sz="7200" dirty="0"/>
             </a:br>
             <a:r>
-              <a:rPr lang="pt-BR" sz="7200" dirty="0"/>
+              <a:rPr lang="pt-BR" sz="7200" dirty="0">
+                <a:solidFill>
+                  <a:srgbClr val="FFFFFF"/>
+                </a:solidFill>
+              </a:rPr>
               <a:t>Garagem Da Vizinha </a:t>
             </a:r>
             <a:r>
@@ -14907,7 +15083,7 @@
     </p:spTree>
     <p:extLst>
       <p:ext uri="{BB962C8B-B14F-4D97-AF65-F5344CB8AC3E}">
-        <p14:creationId xmlns:p14="http://schemas.microsoft.com/office/powerpoint/2010/main" val="78001677"/>
+        <p14:creationId xmlns:p14="http://schemas.microsoft.com/office/powerpoint/2010/main" val="1788294438"/>
       </p:ext>
     </p:extLst>
   </p:cSld>
@@ -14983,6 +15159,15 @@
               </a:rPr>
               <a:t>VS BLOCO 3</a:t>
             </a:r>
+            <a:r>
+              <a:rPr lang="pt-BR" sz="4800" baseline="41667" dirty="0">
+                <a:solidFill>
+                  <a:srgbClr val="FFFFFF"/>
+                </a:solidFill>
+                <a:cs typeface="Arial" panose="020B0604020202020204" pitchFamily="34" charset="0"/>
+              </a:rPr>
+              <a:t>  130 BPM</a:t>
+            </a:r>
           </a:p>
           <a:p>
             <a:pPr marL="36000" indent="-252000" algn="ctr">
@@ -14996,6 +15181,9 @@
             </a:pPr>
             <a:r>
               <a:rPr lang="en-US" sz="7200" dirty="0">
+                <a:solidFill>
+                  <a:srgbClr val="FFFFFF"/>
+                </a:solidFill>
                 <a:cs typeface="Arial" panose="020B0604020202020204" pitchFamily="34" charset="0"/>
               </a:rPr>
               <a:t>Barco do Amor </a:t>
@@ -15022,30 +15210,45 @@
             </a:pPr>
             <a:r>
               <a:rPr lang="en-US" sz="7200" dirty="0">
+                <a:solidFill>
+                  <a:srgbClr val="FFFFFF"/>
+                </a:solidFill>
                 <a:cs typeface="Arial" panose="020B0604020202020204" pitchFamily="34" charset="0"/>
               </a:rPr>
               <a:t>Sem Amor </a:t>
             </a:r>
             <a:r>
               <a:rPr lang="en-US" sz="7200" dirty="0" err="1">
+                <a:solidFill>
+                  <a:srgbClr val="FFFFFF"/>
+                </a:solidFill>
                 <a:cs typeface="Arial" panose="020B0604020202020204" pitchFamily="34" charset="0"/>
               </a:rPr>
               <a:t>Ningém</a:t>
             </a:r>
             <a:r>
               <a:rPr lang="en-US" sz="7200" dirty="0">
+                <a:solidFill>
+                  <a:srgbClr val="FFFFFF"/>
+                </a:solidFill>
                 <a:cs typeface="Arial" panose="020B0604020202020204" pitchFamily="34" charset="0"/>
               </a:rPr>
               <a:t> </a:t>
             </a:r>
             <a:r>
               <a:rPr lang="en-US" sz="7200" dirty="0" err="1">
+                <a:solidFill>
+                  <a:srgbClr val="FFFFFF"/>
+                </a:solidFill>
                 <a:cs typeface="Arial" panose="020B0604020202020204" pitchFamily="34" charset="0"/>
               </a:rPr>
               <a:t>Vive</a:t>
             </a:r>
             <a:r>
               <a:rPr lang="en-US" sz="7200" dirty="0">
+                <a:solidFill>
+                  <a:srgbClr val="FFFFFF"/>
+                </a:solidFill>
                 <a:cs typeface="Arial" panose="020B0604020202020204" pitchFamily="34" charset="0"/>
               </a:rPr>
               <a:t> </a:t>
@@ -15078,12 +15281,18 @@
             </a:pPr>
             <a:r>
               <a:rPr lang="en-US" sz="7200" dirty="0" err="1">
+                <a:solidFill>
+                  <a:srgbClr val="FFFFFF"/>
+                </a:solidFill>
                 <a:cs typeface="Arial" panose="020B0604020202020204" pitchFamily="34" charset="0"/>
               </a:rPr>
               <a:t>Rosto</a:t>
             </a:r>
             <a:r>
               <a:rPr lang="en-US" sz="7200" dirty="0">
+                <a:solidFill>
+                  <a:srgbClr val="FFFFFF"/>
+                </a:solidFill>
                 <a:cs typeface="Arial" panose="020B0604020202020204" pitchFamily="34" charset="0"/>
               </a:rPr>
               <a:t> Desmaquiado </a:t>
@@ -15110,6 +15319,9 @@
             </a:pPr>
             <a:r>
               <a:rPr lang="en-US" sz="7200" dirty="0">
+                <a:solidFill>
+                  <a:srgbClr val="FFFFFF"/>
+                </a:solidFill>
                 <a:cs typeface="Arial" panose="020B0604020202020204" pitchFamily="34" charset="0"/>
               </a:rPr>
               <a:t>Vida Cor de Rosa </a:t>
@@ -15149,7 +15361,7 @@
     </p:spTree>
     <p:extLst>
       <p:ext uri="{BB962C8B-B14F-4D97-AF65-F5344CB8AC3E}">
-        <p14:creationId xmlns:p14="http://schemas.microsoft.com/office/powerpoint/2010/main" val="833599022"/>
+        <p14:creationId xmlns:p14="http://schemas.microsoft.com/office/powerpoint/2010/main" val="726201620"/>
       </p:ext>
     </p:extLst>
   </p:cSld>
@@ -15225,6 +15437,15 @@
               </a:rPr>
               <a:t>VS BLOCO 4</a:t>
             </a:r>
+            <a:r>
+              <a:rPr lang="pt-BR" sz="4800" baseline="41667" dirty="0">
+                <a:solidFill>
+                  <a:srgbClr val="FFFFFF"/>
+                </a:solidFill>
+                <a:cs typeface="Arial" panose="020B0604020202020204" pitchFamily="34" charset="0"/>
+              </a:rPr>
+              <a:t>  188 BPM</a:t>
+            </a:r>
           </a:p>
           <a:p>
             <a:pPr marL="36000" indent="-252000" algn="ctr">
@@ -15237,12 +15458,12 @@
               <a:buNone/>
             </a:pPr>
             <a:r>
-              <a:rPr lang="pt-BR" sz="7200" dirty="0" err="1"/>
-              <a:t>Barquinnha</a:t>
-            </a:r>
-            <a:r>
-              <a:rPr lang="pt-BR" sz="7200" dirty="0"/>
-              <a:t> De Ouro </a:t>
+              <a:rPr lang="pt-BR" sz="7200" dirty="0" err="1">
+                <a:solidFill>
+                  <a:srgbClr val="FFFFFF"/>
+                </a:solidFill>
+              </a:rPr>
+              <a:t>Barquinha De Ouro </a:t>
             </a:r>
             <a:r>
               <a:rPr lang="pt-BR" sz="7200" dirty="0" err="1">
@@ -15264,19 +15485,35 @@
               <a:rPr lang="pt-BR" sz="7200" dirty="0"/>
             </a:br>
             <a:r>
-              <a:rPr lang="pt-BR" sz="7200" dirty="0" err="1"/>
+              <a:rPr lang="pt-BR" sz="7200" dirty="0" err="1">
+                <a:solidFill>
+                  <a:srgbClr val="FFFFFF"/>
+                </a:solidFill>
+              </a:rPr>
               <a:t>Voce</a:t>
             </a:r>
             <a:r>
-              <a:rPr lang="pt-BR" sz="7200" dirty="0"/>
+              <a:rPr lang="pt-BR" sz="7200" dirty="0">
+                <a:solidFill>
+                  <a:srgbClr val="FFFFFF"/>
+                </a:solidFill>
+              </a:rPr>
               <a:t> </a:t>
             </a:r>
             <a:r>
-              <a:rPr lang="pt-BR" sz="7200" dirty="0" err="1"/>
+              <a:rPr lang="pt-BR" sz="7200" dirty="0" err="1">
+                <a:solidFill>
+                  <a:srgbClr val="FFFFFF"/>
+                </a:solidFill>
+              </a:rPr>
               <a:t>Nao</a:t>
             </a:r>
             <a:r>
-              <a:rPr lang="pt-BR" sz="7200" dirty="0"/>
+              <a:rPr lang="pt-BR" sz="7200" dirty="0">
+                <a:solidFill>
+                  <a:srgbClr val="FFFFFF"/>
+                </a:solidFill>
+              </a:rPr>
               <a:t> Vale Nada </a:t>
             </a:r>
             <a:r>
@@ -15291,7 +15528,11 @@
               <a:rPr lang="pt-BR" sz="7200" dirty="0"/>
             </a:br>
             <a:r>
-              <a:rPr lang="pt-BR" sz="7200" dirty="0"/>
+              <a:rPr lang="pt-BR" sz="7200" dirty="0">
+                <a:solidFill>
+                  <a:srgbClr val="FFFFFF"/>
+                </a:solidFill>
+              </a:rPr>
               <a:t>Morango Do Nordeste </a:t>
             </a:r>
             <a:r>
@@ -15314,7 +15555,7 @@
     </p:spTree>
     <p:extLst>
       <p:ext uri="{BB962C8B-B14F-4D97-AF65-F5344CB8AC3E}">
-        <p14:creationId xmlns:p14="http://schemas.microsoft.com/office/powerpoint/2010/main" val="2434061000"/>
+        <p14:creationId xmlns:p14="http://schemas.microsoft.com/office/powerpoint/2010/main" val="284514789"/>
       </p:ext>
     </p:extLst>
   </p:cSld>
@@ -15390,6 +15631,15 @@
               </a:rPr>
               <a:t>VS BLOCO 5</a:t>
             </a:r>
+            <a:r>
+              <a:rPr lang="pt-BR" sz="4800" baseline="41667" dirty="0">
+                <a:solidFill>
+                  <a:srgbClr val="FFFFFF"/>
+                </a:solidFill>
+                <a:cs typeface="Arial" panose="020B0604020202020204" pitchFamily="34" charset="0"/>
+              </a:rPr>
+              <a:t>  168 BPM</a:t>
+            </a:r>
           </a:p>
           <a:p>
             <a:pPr marL="36000" indent="-252000" algn="ctr">
@@ -15403,18 +15653,27 @@
             </a:pPr>
             <a:r>
               <a:rPr lang="en-US" sz="6000" dirty="0">
+                <a:solidFill>
+                  <a:srgbClr val="FFFFFF"/>
+                </a:solidFill>
                 <a:cs typeface="Arial" panose="020B0604020202020204" pitchFamily="34" charset="0"/>
               </a:rPr>
               <a:t>Camisa </a:t>
             </a:r>
             <a:r>
               <a:rPr lang="en-US" sz="6000" dirty="0" err="1">
+                <a:solidFill>
+                  <a:srgbClr val="FFFFFF"/>
+                </a:solidFill>
                 <a:cs typeface="Arial" panose="020B0604020202020204" pitchFamily="34" charset="0"/>
               </a:rPr>
               <a:t>Manchada</a:t>
             </a:r>
             <a:r>
               <a:rPr lang="en-US" sz="6000" dirty="0">
+                <a:solidFill>
+                  <a:srgbClr val="FFFFFF"/>
+                </a:solidFill>
                 <a:cs typeface="Arial" panose="020B0604020202020204" pitchFamily="34" charset="0"/>
               </a:rPr>
               <a:t> </a:t>
@@ -15441,18 +15700,27 @@
             </a:pPr>
             <a:r>
               <a:rPr lang="en-US" sz="6000" dirty="0">
+                <a:solidFill>
+                  <a:srgbClr val="FFFFFF"/>
+                </a:solidFill>
                 <a:cs typeface="Arial" panose="020B0604020202020204" pitchFamily="34" charset="0"/>
               </a:rPr>
               <a:t>Esta Noite Como </a:t>
             </a:r>
             <a:r>
               <a:rPr lang="en-US" sz="6000" dirty="0" err="1">
+                <a:solidFill>
+                  <a:srgbClr val="FFFFFF"/>
+                </a:solidFill>
                 <a:cs typeface="Arial" panose="020B0604020202020204" pitchFamily="34" charset="0"/>
               </a:rPr>
               <a:t>Lembrança</a:t>
             </a:r>
             <a:r>
               <a:rPr lang="en-US" sz="6000" dirty="0">
+                <a:solidFill>
+                  <a:srgbClr val="FFFFFF"/>
+                </a:solidFill>
                 <a:cs typeface="Arial" panose="020B0604020202020204" pitchFamily="34" charset="0"/>
               </a:rPr>
               <a:t> </a:t>
@@ -15492,7 +15760,7 @@
     </p:spTree>
     <p:extLst>
       <p:ext uri="{BB962C8B-B14F-4D97-AF65-F5344CB8AC3E}">
-        <p14:creationId xmlns:p14="http://schemas.microsoft.com/office/powerpoint/2010/main" val="1742158037"/>
+        <p14:creationId xmlns:p14="http://schemas.microsoft.com/office/powerpoint/2010/main" val="4257389188"/>
       </p:ext>
     </p:extLst>
   </p:cSld>
@@ -15715,6 +15983,15 @@
               </a:rPr>
               <a:t>VS BLOCO 6</a:t>
             </a:r>
+            <a:r>
+              <a:rPr lang="pt-BR" sz="4800" baseline="41667" dirty="0">
+                <a:solidFill>
+                  <a:srgbClr val="FFFFFF"/>
+                </a:solidFill>
+                <a:cs typeface="Arial" panose="020B0604020202020204" pitchFamily="34" charset="0"/>
+              </a:rPr>
+              <a:t>  180 / 200 BPM</a:t>
+            </a:r>
           </a:p>
           <a:p>
             <a:pPr marL="36000" indent="-252000" algn="ctr">
@@ -15727,7 +16004,11 @@
               <a:buNone/>
             </a:pPr>
             <a:r>
-              <a:rPr lang="pt-BR" sz="7200" dirty="0"/>
+              <a:rPr lang="pt-BR" sz="7200" dirty="0">
+                <a:solidFill>
+                  <a:srgbClr val="FFFFFF"/>
+                </a:solidFill>
+              </a:rPr>
               <a:t>Catchaqueira </a:t>
             </a:r>
             <a:r>
@@ -15742,7 +16023,11 @@
               <a:rPr lang="pt-BR" sz="7200" dirty="0"/>
             </a:br>
             <a:r>
-              <a:rPr lang="pt-BR" sz="7200" dirty="0"/>
+              <a:rPr lang="pt-BR" sz="7200" dirty="0">
+                <a:solidFill>
+                  <a:srgbClr val="FFFFFF"/>
+                </a:solidFill>
+              </a:rPr>
               <a:t>Luz Da Minha Vida </a:t>
             </a:r>
             <a:r>
@@ -15765,7 +16050,7 @@
     </p:spTree>
     <p:extLst>
       <p:ext uri="{BB962C8B-B14F-4D97-AF65-F5344CB8AC3E}">
-        <p14:creationId xmlns:p14="http://schemas.microsoft.com/office/powerpoint/2010/main" val="1477774677"/>
+        <p14:creationId xmlns:p14="http://schemas.microsoft.com/office/powerpoint/2010/main" val="2813611595"/>
       </p:ext>
     </p:extLst>
   </p:cSld>
@@ -15841,6 +16126,15 @@
               </a:rPr>
               <a:t>VS BLOCO 7</a:t>
             </a:r>
+            <a:r>
+              <a:rPr lang="pt-BR" sz="4800" baseline="41667" dirty="0">
+                <a:solidFill>
+                  <a:srgbClr val="FFFFFF"/>
+                </a:solidFill>
+                <a:cs typeface="Arial" panose="020B0604020202020204" pitchFamily="34" charset="0"/>
+              </a:rPr>
+              <a:t>  142 BPM</a:t>
+            </a:r>
           </a:p>
           <a:p>
             <a:pPr marL="36000" indent="-252000" algn="ctr">
@@ -15853,7 +16147,11 @@
               <a:buNone/>
             </a:pPr>
             <a:r>
-              <a:rPr lang="pt-BR" sz="7200" dirty="0"/>
+              <a:rPr lang="pt-BR" sz="7200" dirty="0">
+                <a:solidFill>
+                  <a:srgbClr val="FFFFFF"/>
+                </a:solidFill>
+              </a:rPr>
               <a:t>Culpa é Sua </a:t>
             </a:r>
             <a:r>
@@ -15868,7 +16166,11 @@
               <a:rPr lang="pt-BR" sz="7200" dirty="0"/>
             </a:br>
             <a:r>
-              <a:rPr lang="pt-BR" sz="7200" dirty="0"/>
+              <a:rPr lang="pt-BR" sz="7200" dirty="0">
+                <a:solidFill>
+                  <a:srgbClr val="FFFFFF"/>
+                </a:solidFill>
+              </a:rPr>
               <a:t>Risca Faca </a:t>
             </a:r>
             <a:r>
@@ -15883,7 +16185,11 @@
               <a:rPr lang="pt-BR" sz="7200" dirty="0"/>
             </a:br>
             <a:r>
-              <a:rPr lang="pt-BR" sz="7200" dirty="0"/>
+              <a:rPr lang="pt-BR" sz="7200" dirty="0">
+                <a:solidFill>
+                  <a:srgbClr val="FFFFFF"/>
+                </a:solidFill>
+              </a:rPr>
               <a:t>Lua e a Noite </a:t>
             </a:r>
             <a:r>
@@ -15906,7 +16212,7 @@
     </p:spTree>
     <p:extLst>
       <p:ext uri="{BB962C8B-B14F-4D97-AF65-F5344CB8AC3E}">
-        <p14:creationId xmlns:p14="http://schemas.microsoft.com/office/powerpoint/2010/main" val="3340755008"/>
+        <p14:creationId xmlns:p14="http://schemas.microsoft.com/office/powerpoint/2010/main" val="4197087721"/>
       </p:ext>
     </p:extLst>
   </p:cSld>
@@ -15982,6 +16288,15 @@
               </a:rPr>
               <a:t>VS BLOCO 8</a:t>
             </a:r>
+            <a:r>
+              <a:rPr lang="pt-BR" sz="4800" baseline="41667" dirty="0">
+                <a:solidFill>
+                  <a:srgbClr val="FFFFFF"/>
+                </a:solidFill>
+                <a:cs typeface="Arial" panose="020B0604020202020204" pitchFamily="34" charset="0"/>
+              </a:rPr>
+              <a:t>  175 BPM</a:t>
+            </a:r>
           </a:p>
           <a:p>
             <a:pPr marL="36000" indent="-252000" algn="ctr">
@@ -15994,7 +16309,11 @@
               <a:buNone/>
             </a:pPr>
             <a:r>
-              <a:rPr lang="pt-BR" sz="6600" dirty="0"/>
+              <a:rPr lang="pt-BR" sz="6600" dirty="0">
+                <a:solidFill>
+                  <a:srgbClr val="FFFFFF"/>
+                </a:solidFill>
+              </a:rPr>
               <a:t>Do Outro Lado Da Cidade </a:t>
             </a:r>
             <a:r>
@@ -16009,7 +16328,11 @@
               <a:rPr lang="pt-BR" sz="6600" dirty="0"/>
             </a:br>
             <a:r>
-              <a:rPr lang="pt-BR" sz="6600" dirty="0"/>
+              <a:rPr lang="pt-BR" sz="6600" dirty="0">
+                <a:solidFill>
+                  <a:srgbClr val="FFFFFF"/>
+                </a:solidFill>
+              </a:rPr>
               <a:t>Estrada Da Vida </a:t>
             </a:r>
             <a:r>
@@ -16032,7 +16355,7 @@
     </p:spTree>
     <p:extLst>
       <p:ext uri="{BB962C8B-B14F-4D97-AF65-F5344CB8AC3E}">
-        <p14:creationId xmlns:p14="http://schemas.microsoft.com/office/powerpoint/2010/main" val="4078408356"/>
+        <p14:creationId xmlns:p14="http://schemas.microsoft.com/office/powerpoint/2010/main" val="1477584914"/>
       </p:ext>
     </p:extLst>
   </p:cSld>
@@ -16108,6 +16431,15 @@
               </a:rPr>
               <a:t>VS BLOCO 9</a:t>
             </a:r>
+            <a:r>
+              <a:rPr lang="pt-BR" sz="4800" baseline="41667" dirty="0">
+                <a:solidFill>
+                  <a:srgbClr val="FFFFFF"/>
+                </a:solidFill>
+                <a:cs typeface="Arial" panose="020B0604020202020204" pitchFamily="34" charset="0"/>
+              </a:rPr>
+              <a:t>  142 BPM</a:t>
+            </a:r>
           </a:p>
           <a:p>
             <a:pPr marL="36000" indent="-252000" algn="ctr">
@@ -16121,18 +16453,27 @@
             </a:pPr>
             <a:r>
               <a:rPr lang="en-US" sz="7200" dirty="0">
+                <a:solidFill>
+                  <a:srgbClr val="FFFFFF"/>
+                </a:solidFill>
                 <a:cs typeface="Arial" panose="020B0604020202020204" pitchFamily="34" charset="0"/>
               </a:rPr>
               <a:t>Ele </a:t>
             </a:r>
             <a:r>
               <a:rPr lang="en-US" sz="7200" dirty="0" err="1">
+                <a:solidFill>
+                  <a:srgbClr val="FFFFFF"/>
+                </a:solidFill>
                 <a:cs typeface="Arial" panose="020B0604020202020204" pitchFamily="34" charset="0"/>
               </a:rPr>
               <a:t>te</a:t>
             </a:r>
             <a:r>
               <a:rPr lang="en-US" sz="7200" dirty="0">
+                <a:solidFill>
+                  <a:srgbClr val="FFFFFF"/>
+                </a:solidFill>
                 <a:cs typeface="Arial" panose="020B0604020202020204" pitchFamily="34" charset="0"/>
               </a:rPr>
               <a:t> Trai </a:t>
@@ -16159,18 +16500,27 @@
             </a:pPr>
             <a:r>
               <a:rPr lang="en-US" sz="7200" dirty="0">
+                <a:solidFill>
+                  <a:srgbClr val="FFFFFF"/>
+                </a:solidFill>
                 <a:cs typeface="Arial" panose="020B0604020202020204" pitchFamily="34" charset="0"/>
               </a:rPr>
               <a:t>Cama </a:t>
             </a:r>
             <a:r>
               <a:rPr lang="en-US" sz="7200" dirty="0" err="1">
+                <a:solidFill>
+                  <a:srgbClr val="FFFFFF"/>
+                </a:solidFill>
                 <a:cs typeface="Arial" panose="020B0604020202020204" pitchFamily="34" charset="0"/>
               </a:rPr>
               <a:t>Vazia</a:t>
             </a:r>
             <a:r>
               <a:rPr lang="en-US" sz="7200" dirty="0">
+                <a:solidFill>
+                  <a:srgbClr val="FFFFFF"/>
+                </a:solidFill>
                 <a:cs typeface="Arial" panose="020B0604020202020204" pitchFamily="34" charset="0"/>
               </a:rPr>
               <a:t> </a:t>
@@ -16197,6 +16547,9 @@
             </a:pPr>
             <a:r>
               <a:rPr lang="en-US" sz="7200" dirty="0">
+                <a:solidFill>
+                  <a:srgbClr val="FFFFFF"/>
+                </a:solidFill>
                 <a:cs typeface="Arial" panose="020B0604020202020204" pitchFamily="34" charset="0"/>
               </a:rPr>
               <a:t>Meu Ex Amor </a:t>
@@ -16236,7 +16589,7 @@
     </p:spTree>
     <p:extLst>
       <p:ext uri="{BB962C8B-B14F-4D97-AF65-F5344CB8AC3E}">
-        <p14:creationId xmlns:p14="http://schemas.microsoft.com/office/powerpoint/2010/main" val="1733778688"/>
+        <p14:creationId xmlns:p14="http://schemas.microsoft.com/office/powerpoint/2010/main" val="2255003714"/>
       </p:ext>
     </p:extLst>
   </p:cSld>
@@ -16312,6 +16665,15 @@
               </a:rPr>
               <a:t>VS BLOCO 10</a:t>
             </a:r>
+            <a:r>
+              <a:rPr lang="pt-BR" sz="4800" baseline="41667" dirty="0">
+                <a:solidFill>
+                  <a:srgbClr val="FFFFFF"/>
+                </a:solidFill>
+                <a:cs typeface="Arial" panose="020B0604020202020204" pitchFamily="34" charset="0"/>
+              </a:rPr>
+              <a:t>  134 BPM</a:t>
+            </a:r>
           </a:p>
           <a:p>
             <a:pPr marL="36000" indent="-252000" algn="ctr">
@@ -16324,7 +16686,11 @@
               <a:buNone/>
             </a:pPr>
             <a:r>
-              <a:rPr lang="pt-BR" sz="7200" dirty="0"/>
+              <a:rPr lang="pt-BR" sz="7200" dirty="0">
+                <a:solidFill>
+                  <a:srgbClr val="FFFFFF"/>
+                </a:solidFill>
+              </a:rPr>
               <a:t>Fim De Semana </a:t>
             </a:r>
             <a:r>
@@ -16339,7 +16705,11 @@
               <a:rPr lang="pt-BR" sz="7200" dirty="0"/>
             </a:br>
             <a:r>
-              <a:rPr lang="pt-BR" sz="7200" dirty="0"/>
+              <a:rPr lang="pt-BR" sz="7200" dirty="0">
+                <a:solidFill>
+                  <a:srgbClr val="FFFFFF"/>
+                </a:solidFill>
+              </a:rPr>
               <a:t>Gosto Que Me Enrosco </a:t>
             </a:r>
             <a:r>
@@ -16354,7 +16724,11 @@
               <a:rPr lang="pt-BR" sz="7200" dirty="0"/>
             </a:br>
             <a:r>
-              <a:rPr lang="pt-BR" sz="7200" dirty="0"/>
+              <a:rPr lang="pt-BR" sz="7200" dirty="0">
+                <a:solidFill>
+                  <a:srgbClr val="FFFFFF"/>
+                </a:solidFill>
+              </a:rPr>
               <a:t>Novela Das 8 </a:t>
             </a:r>
             <a:r>
@@ -16377,7 +16751,7 @@
     </p:spTree>
     <p:extLst>
       <p:ext uri="{BB962C8B-B14F-4D97-AF65-F5344CB8AC3E}">
-        <p14:creationId xmlns:p14="http://schemas.microsoft.com/office/powerpoint/2010/main" val="115736051"/>
+        <p14:creationId xmlns:p14="http://schemas.microsoft.com/office/powerpoint/2010/main" val="2660966315"/>
       </p:ext>
     </p:extLst>
   </p:cSld>
@@ -16453,6 +16827,15 @@
               </a:rPr>
               <a:t>VS BLOCO 11</a:t>
             </a:r>
+            <a:r>
+              <a:rPr lang="pt-BR" sz="4800" baseline="41667" dirty="0">
+                <a:solidFill>
+                  <a:srgbClr val="FFFFFF"/>
+                </a:solidFill>
+                <a:cs typeface="Arial" panose="020B0604020202020204" pitchFamily="34" charset="0"/>
+              </a:rPr>
+              <a:t>  140 BPM</a:t>
+            </a:r>
           </a:p>
           <a:p>
             <a:pPr marL="36000" indent="-252000" algn="ctr">
@@ -16465,7 +16848,11 @@
               <a:buNone/>
             </a:pPr>
             <a:r>
-              <a:rPr lang="pt-BR" sz="5400" dirty="0"/>
+              <a:rPr lang="pt-BR" sz="5400" dirty="0">
+                <a:solidFill>
+                  <a:srgbClr val="FFFFFF"/>
+                </a:solidFill>
+              </a:rPr>
               <a:t>Garçom </a:t>
             </a:r>
             <a:r>
@@ -16480,7 +16867,11 @@
               <a:rPr lang="pt-BR" sz="5400" dirty="0"/>
             </a:br>
             <a:r>
-              <a:rPr lang="pt-BR" sz="5400" dirty="0"/>
+              <a:rPr lang="pt-BR" sz="5400" dirty="0">
+                <a:solidFill>
+                  <a:srgbClr val="FFFFFF"/>
+                </a:solidFill>
+              </a:rPr>
               <a:t>Ninguém Segura o Coração </a:t>
             </a:r>
             <a:r>
@@ -16495,7 +16886,11 @@
               <a:rPr lang="pt-BR" sz="5400" dirty="0"/>
             </a:br>
             <a:r>
-              <a:rPr lang="pt-BR" sz="5400" dirty="0"/>
+              <a:rPr lang="pt-BR" sz="5400" dirty="0">
+                <a:solidFill>
+                  <a:srgbClr val="FFFFFF"/>
+                </a:solidFill>
+              </a:rPr>
               <a:t>Misturinha </a:t>
             </a:r>
             <a:r>
@@ -16510,7 +16905,11 @@
               <a:rPr lang="pt-BR" sz="5400" dirty="0"/>
             </a:br>
             <a:r>
-              <a:rPr lang="pt-BR" sz="5400" dirty="0"/>
+              <a:rPr lang="pt-BR" sz="5400" dirty="0">
+                <a:solidFill>
+                  <a:srgbClr val="FFFFFF"/>
+                </a:solidFill>
+              </a:rPr>
               <a:t>Essa Cama Eu Não Vendo </a:t>
             </a:r>
             <a:r>
@@ -16525,7 +16924,11 @@
               <a:rPr lang="pt-BR" sz="5400" dirty="0"/>
             </a:br>
             <a:r>
-              <a:rPr lang="pt-BR" sz="5400" dirty="0"/>
+              <a:rPr lang="pt-BR" sz="5400" dirty="0">
+                <a:solidFill>
+                  <a:srgbClr val="FFFFFF"/>
+                </a:solidFill>
+              </a:rPr>
               <a:t>Preciso Te Falar </a:t>
             </a:r>
             <a:r>
@@ -16540,7 +16943,11 @@
               <a:rPr lang="pt-BR" sz="5400" dirty="0"/>
             </a:br>
             <a:r>
-              <a:rPr lang="pt-BR" sz="5400" dirty="0"/>
+              <a:rPr lang="pt-BR" sz="5400" dirty="0">
+                <a:solidFill>
+                  <a:srgbClr val="FFFFFF"/>
+                </a:solidFill>
+              </a:rPr>
               <a:t>Flashback </a:t>
             </a:r>
             <a:r>
@@ -16563,7 +16970,7 @@
     </p:spTree>
     <p:extLst>
       <p:ext uri="{BB962C8B-B14F-4D97-AF65-F5344CB8AC3E}">
-        <p14:creationId xmlns:p14="http://schemas.microsoft.com/office/powerpoint/2010/main" val="3399997052"/>
+        <p14:creationId xmlns:p14="http://schemas.microsoft.com/office/powerpoint/2010/main" val="2404092377"/>
       </p:ext>
     </p:extLst>
   </p:cSld>
@@ -16639,6 +17046,15 @@
               </a:rPr>
               <a:t>VS BLOCO 12</a:t>
             </a:r>
+            <a:r>
+              <a:rPr lang="pt-BR" sz="4800" baseline="41667" dirty="0">
+                <a:solidFill>
+                  <a:srgbClr val="FFFFFF"/>
+                </a:solidFill>
+                <a:cs typeface="Arial" panose="020B0604020202020204" pitchFamily="34" charset="0"/>
+              </a:rPr>
+              <a:t>  137 BPM</a:t>
+            </a:r>
           </a:p>
           <a:p>
             <a:pPr marL="36000" indent="-252000" algn="ctr">
@@ -16651,7 +17067,11 @@
               <a:buNone/>
             </a:pPr>
             <a:r>
-              <a:rPr lang="pt-BR" sz="7200" dirty="0"/>
+              <a:rPr lang="pt-BR" sz="7200" dirty="0">
+                <a:solidFill>
+                  <a:srgbClr val="FFFFFF"/>
+                </a:solidFill>
+              </a:rPr>
               <a:t>Guardanapo </a:t>
             </a:r>
             <a:r>
@@ -16679,7 +17099,11 @@
               <a:buNone/>
             </a:pPr>
             <a:r>
-              <a:rPr lang="pt-BR" sz="7200" dirty="0"/>
+              <a:rPr lang="pt-BR" sz="7200" dirty="0">
+                <a:solidFill>
+                  <a:srgbClr val="FFFFFF"/>
+                </a:solidFill>
+              </a:rPr>
               <a:t>Transgênica </a:t>
             </a:r>
             <a:r>
@@ -16694,7 +17118,11 @@
               <a:rPr lang="pt-BR" sz="7200" dirty="0"/>
             </a:br>
             <a:r>
-              <a:rPr lang="pt-BR" sz="7200" dirty="0"/>
+              <a:rPr lang="pt-BR" sz="7200" dirty="0">
+                <a:solidFill>
+                  <a:srgbClr val="FFFFFF"/>
+                </a:solidFill>
+              </a:rPr>
               <a:t>Caso Marcado </a:t>
             </a:r>
             <a:r>
@@ -16717,7 +17145,7 @@
     </p:spTree>
     <p:extLst>
       <p:ext uri="{BB962C8B-B14F-4D97-AF65-F5344CB8AC3E}">
-        <p14:creationId xmlns:p14="http://schemas.microsoft.com/office/powerpoint/2010/main" val="1493072947"/>
+        <p14:creationId xmlns:p14="http://schemas.microsoft.com/office/powerpoint/2010/main" val="2141575261"/>
       </p:ext>
     </p:extLst>
   </p:cSld>
@@ -16793,6 +17221,15 @@
               </a:rPr>
               <a:t>VS BLOCO 13</a:t>
             </a:r>
+            <a:r>
+              <a:rPr lang="pt-BR" sz="4800" baseline="41667" dirty="0">
+                <a:solidFill>
+                  <a:srgbClr val="FFFFFF"/>
+                </a:solidFill>
+                <a:cs typeface="Arial" panose="020B0604020202020204" pitchFamily="34" charset="0"/>
+              </a:rPr>
+              <a:t>  136 BPM</a:t>
+            </a:r>
           </a:p>
           <a:p>
             <a:pPr marL="36000" indent="-252000" algn="ctr">
@@ -16805,7 +17242,11 @@
               <a:buNone/>
             </a:pPr>
             <a:r>
-              <a:rPr lang="pt-BR" sz="7200" dirty="0"/>
+              <a:rPr lang="pt-BR" sz="7200" dirty="0">
+                <a:solidFill>
+                  <a:srgbClr val="FFFFFF"/>
+                </a:solidFill>
+              </a:rPr>
               <a:t>Lágrimas Sobre a Mesa </a:t>
             </a:r>
             <a:r>
@@ -16820,7 +17261,11 @@
               <a:rPr lang="pt-BR" sz="7200" dirty="0"/>
             </a:br>
             <a:r>
-              <a:rPr lang="pt-BR" sz="7200" dirty="0"/>
+              <a:rPr lang="pt-BR" sz="7200" dirty="0">
+                <a:solidFill>
+                  <a:srgbClr val="FFFFFF"/>
+                </a:solidFill>
+              </a:rPr>
               <a:t>Página Virada </a:t>
             </a:r>
             <a:r>
@@ -16835,7 +17280,11 @@
               <a:rPr lang="pt-BR" sz="7200" dirty="0"/>
             </a:br>
             <a:r>
-              <a:rPr lang="pt-BR" sz="7200" dirty="0"/>
+              <a:rPr lang="pt-BR" sz="7200" dirty="0">
+                <a:solidFill>
+                  <a:srgbClr val="FFFFFF"/>
+                </a:solidFill>
+              </a:rPr>
               <a:t>Fique </a:t>
             </a:r>
             <a:r>
@@ -16858,7 +17307,7 @@
     </p:spTree>
     <p:extLst>
       <p:ext uri="{BB962C8B-B14F-4D97-AF65-F5344CB8AC3E}">
-        <p14:creationId xmlns:p14="http://schemas.microsoft.com/office/powerpoint/2010/main" val="2639022366"/>
+        <p14:creationId xmlns:p14="http://schemas.microsoft.com/office/powerpoint/2010/main" val="1814431340"/>
       </p:ext>
     </p:extLst>
   </p:cSld>
@@ -16934,6 +17383,15 @@
               </a:rPr>
               <a:t>VS BLOCO 14</a:t>
             </a:r>
+            <a:r>
+              <a:rPr lang="pt-BR" sz="4800" baseline="41667" dirty="0">
+                <a:solidFill>
+                  <a:srgbClr val="FFFFFF"/>
+                </a:solidFill>
+                <a:cs typeface="Arial" panose="020B0604020202020204" pitchFamily="34" charset="0"/>
+              </a:rPr>
+              <a:t>  138 BPM</a:t>
+            </a:r>
           </a:p>
           <a:p>
             <a:pPr marL="36000" indent="-252000" algn="ctr">
@@ -16946,31 +17404,59 @@
               <a:buNone/>
             </a:pPr>
             <a:r>
-              <a:rPr lang="pt-BR" sz="7200" dirty="0"/>
+              <a:rPr lang="pt-BR" sz="7200" dirty="0">
+                <a:solidFill>
+                  <a:srgbClr val="FFFFFF"/>
+                </a:solidFill>
+              </a:rPr>
               <a:t>Maria </a:t>
             </a:r>
             <a:r>
-              <a:rPr lang="pt-BR" sz="7200" dirty="0" err="1"/>
+              <a:rPr lang="pt-BR" sz="7200" dirty="0" err="1">
+                <a:solidFill>
+                  <a:srgbClr val="FFFFFF"/>
+                </a:solidFill>
+              </a:rPr>
               <a:t>Tcha</a:t>
             </a:r>
             <a:r>
-              <a:rPr lang="pt-BR" sz="7200" dirty="0"/>
+              <a:rPr lang="pt-BR" sz="7200" dirty="0">
+                <a:solidFill>
+                  <a:srgbClr val="FFFFFF"/>
+                </a:solidFill>
+              </a:rPr>
               <a:t> </a:t>
             </a:r>
             <a:r>
-              <a:rPr lang="pt-BR" sz="7200" dirty="0" err="1"/>
+              <a:rPr lang="pt-BR" sz="7200" dirty="0" err="1">
+                <a:solidFill>
+                  <a:srgbClr val="FFFFFF"/>
+                </a:solidFill>
+              </a:rPr>
               <a:t>Tcha</a:t>
             </a:r>
             <a:r>
-              <a:rPr lang="pt-BR" sz="7200" dirty="0"/>
+              <a:rPr lang="pt-BR" sz="7200" dirty="0">
+                <a:solidFill>
+                  <a:srgbClr val="FFFFFF"/>
+                </a:solidFill>
+              </a:rPr>
               <a:t> </a:t>
             </a:r>
             <a:r>
-              <a:rPr lang="pt-BR" sz="7200" dirty="0" err="1"/>
+              <a:rPr lang="pt-BR" sz="7200" dirty="0" err="1">
+                <a:solidFill>
+                  <a:srgbClr val="FFFFFF"/>
+                </a:solidFill>
+              </a:rPr>
               <a:t>Tcha</a:t>
             </a:r>
             <a:r>
-              <a:rPr lang="pt-BR" sz="7200" dirty="0"/>
+              <a:rPr lang="pt-BR" sz="7200" dirty="0">
+                <a:solidFill>
+                  <a:srgbClr val="FFFFFF"/>
+                </a:solidFill>
+              </a:rPr>
               <a:t> </a:t>
             </a:r>
             <a:r>
@@ -16985,7 +17471,11 @@
               <a:rPr lang="pt-BR" sz="7200" dirty="0"/>
             </a:br>
             <a:r>
-              <a:rPr lang="pt-BR" sz="7200" dirty="0"/>
+              <a:rPr lang="pt-BR" sz="7200" dirty="0">
+                <a:solidFill>
+                  <a:srgbClr val="FFFFFF"/>
+                </a:solidFill>
+              </a:rPr>
               <a:t>Preciso Te Encontrar </a:t>
             </a:r>
             <a:r>
@@ -17000,7 +17490,11 @@
               <a:rPr lang="pt-BR" sz="7200" dirty="0"/>
             </a:br>
             <a:r>
-              <a:rPr lang="pt-BR" sz="7200" dirty="0"/>
+              <a:rPr lang="pt-BR" sz="7200" dirty="0">
+                <a:solidFill>
+                  <a:srgbClr val="FFFFFF"/>
+                </a:solidFill>
+              </a:rPr>
               <a:t>Você Vai Ver </a:t>
             </a:r>
             <a:r>
@@ -17023,7 +17517,7 @@
     </p:spTree>
     <p:extLst>
       <p:ext uri="{BB962C8B-B14F-4D97-AF65-F5344CB8AC3E}">
-        <p14:creationId xmlns:p14="http://schemas.microsoft.com/office/powerpoint/2010/main" val="1760658781"/>
+        <p14:creationId xmlns:p14="http://schemas.microsoft.com/office/powerpoint/2010/main" val="497065445"/>
       </p:ext>
     </p:extLst>
   </p:cSld>
@@ -17099,6 +17593,15 @@
               </a:rPr>
               <a:t>VS BLOCO 15</a:t>
             </a:r>
+            <a:r>
+              <a:rPr lang="pt-BR" sz="4800" baseline="41667" dirty="0">
+                <a:solidFill>
+                  <a:srgbClr val="FFFFFF"/>
+                </a:solidFill>
+                <a:cs typeface="Arial" panose="020B0604020202020204" pitchFamily="34" charset="0"/>
+              </a:rPr>
+              <a:t>  188 / 196 BPM</a:t>
+            </a:r>
           </a:p>
           <a:p>
             <a:pPr marL="36000" indent="-252000" algn="ctr">
@@ -17111,7 +17614,11 @@
               <a:buNone/>
             </a:pPr>
             <a:r>
-              <a:rPr lang="pt-BR" sz="7200" dirty="0"/>
+              <a:rPr lang="pt-BR" sz="7200" dirty="0">
+                <a:solidFill>
+                  <a:srgbClr val="FFFFFF"/>
+                </a:solidFill>
+              </a:rPr>
               <a:t>Mineirinho </a:t>
             </a:r>
             <a:r>
@@ -17126,7 +17633,11 @@
               <a:rPr lang="pt-BR" sz="7200" dirty="0"/>
             </a:br>
             <a:r>
-              <a:rPr lang="pt-BR" sz="7200" dirty="0"/>
+              <a:rPr lang="pt-BR" sz="7200" dirty="0">
+                <a:solidFill>
+                  <a:srgbClr val="FFFFFF"/>
+                </a:solidFill>
+              </a:rPr>
               <a:t>Cheia De Manias </a:t>
             </a:r>
             <a:r>
@@ -17141,7 +17652,11 @@
               <a:rPr lang="pt-BR" sz="7200" dirty="0"/>
             </a:br>
             <a:r>
-              <a:rPr lang="pt-BR" sz="7200" dirty="0"/>
+              <a:rPr lang="pt-BR" sz="7200" dirty="0">
+                <a:solidFill>
+                  <a:srgbClr val="FFFFFF"/>
+                </a:solidFill>
+              </a:rPr>
               <a:t>Deus Me Livre </a:t>
             </a:r>
             <a:r>
@@ -17164,7 +17679,7 @@
     </p:spTree>
     <p:extLst>
       <p:ext uri="{BB962C8B-B14F-4D97-AF65-F5344CB8AC3E}">
-        <p14:creationId xmlns:p14="http://schemas.microsoft.com/office/powerpoint/2010/main" val="51799183"/>
+        <p14:creationId xmlns:p14="http://schemas.microsoft.com/office/powerpoint/2010/main" val="3279386788"/>
       </p:ext>
     </p:extLst>
   </p:cSld>
@@ -17399,6 +17914,15 @@
               </a:rPr>
               <a:t>VS BLOCO 16</a:t>
             </a:r>
+            <a:r>
+              <a:rPr lang="pt-BR" sz="4800" baseline="41667" dirty="0">
+                <a:solidFill>
+                  <a:srgbClr val="FFFFFF"/>
+                </a:solidFill>
+                <a:cs typeface="Arial" panose="020B0604020202020204" pitchFamily="34" charset="0"/>
+              </a:rPr>
+              <a:t>  180 BPM</a:t>
+            </a:r>
           </a:p>
           <a:p>
             <a:pPr marL="36000" indent="-252000" algn="ctr">
@@ -17411,7 +17935,11 @@
               <a:buNone/>
             </a:pPr>
             <a:r>
-              <a:rPr lang="pt-BR" sz="7200" dirty="0"/>
+              <a:rPr lang="pt-BR" sz="7200" dirty="0">
+                <a:solidFill>
+                  <a:srgbClr val="FFFFFF"/>
+                </a:solidFill>
+              </a:rPr>
               <a:t>Nosso Amor Terminou </a:t>
             </a:r>
             <a:r>
@@ -17426,7 +17954,11 @@
               <a:rPr lang="pt-BR" sz="7200" dirty="0"/>
             </a:br>
             <a:r>
-              <a:rPr lang="pt-BR" sz="7200" dirty="0"/>
+              <a:rPr lang="pt-BR" sz="7200" dirty="0">
+                <a:solidFill>
+                  <a:srgbClr val="FFFFFF"/>
+                </a:solidFill>
+              </a:rPr>
               <a:t>Assino Com X </a:t>
             </a:r>
             <a:r>
@@ -17449,7 +17981,7 @@
     </p:spTree>
     <p:extLst>
       <p:ext uri="{BB962C8B-B14F-4D97-AF65-F5344CB8AC3E}">
-        <p14:creationId xmlns:p14="http://schemas.microsoft.com/office/powerpoint/2010/main" val="348060073"/>
+        <p14:creationId xmlns:p14="http://schemas.microsoft.com/office/powerpoint/2010/main" val="1878044634"/>
       </p:ext>
     </p:extLst>
   </p:cSld>
@@ -17525,6 +18057,15 @@
               </a:rPr>
               <a:t>VS BLOCO 17</a:t>
             </a:r>
+            <a:r>
+              <a:rPr lang="pt-BR" sz="4800" baseline="41667" dirty="0">
+                <a:solidFill>
+                  <a:srgbClr val="FFFFFF"/>
+                </a:solidFill>
+                <a:cs typeface="Arial" panose="020B0604020202020204" pitchFamily="34" charset="0"/>
+              </a:rPr>
+              <a:t>  136 BPM</a:t>
+            </a:r>
           </a:p>
           <a:p>
             <a:pPr marL="36000" indent="-252000" algn="ctr">
@@ -17538,6 +18079,9 @@
             </a:pPr>
             <a:r>
               <a:rPr lang="en-US" sz="7200" dirty="0">
+                <a:solidFill>
+                  <a:srgbClr val="FFFFFF"/>
+                </a:solidFill>
                 <a:cs typeface="Arial" panose="020B0604020202020204" pitchFamily="34" charset="0"/>
               </a:rPr>
               <a:t>Novela das 8 </a:t>
@@ -17564,12 +18108,18 @@
             </a:pPr>
             <a:r>
               <a:rPr lang="en-US" sz="7200" dirty="0" err="1">
+                <a:solidFill>
+                  <a:srgbClr val="FFFFFF"/>
+                </a:solidFill>
                 <a:cs typeface="Arial" panose="020B0604020202020204" pitchFamily="34" charset="0"/>
               </a:rPr>
               <a:t>Melô</a:t>
             </a:r>
             <a:r>
               <a:rPr lang="en-US" sz="7200" dirty="0">
+                <a:solidFill>
+                  <a:srgbClr val="FFFFFF"/>
+                </a:solidFill>
                 <a:cs typeface="Arial" panose="020B0604020202020204" pitchFamily="34" charset="0"/>
               </a:rPr>
               <a:t> do Rolo </a:t>
@@ -17596,24 +18146,36 @@
             </a:pPr>
             <a:r>
               <a:rPr lang="en-US" sz="7200" dirty="0" err="1">
+                <a:solidFill>
+                  <a:srgbClr val="FFFFFF"/>
+                </a:solidFill>
                 <a:cs typeface="Arial" panose="020B0604020202020204" pitchFamily="34" charset="0"/>
               </a:rPr>
               <a:t>Heyo</a:t>
             </a:r>
             <a:r>
               <a:rPr lang="en-US" sz="7200" dirty="0">
+                <a:solidFill>
+                  <a:srgbClr val="FFFFFF"/>
+                </a:solidFill>
                 <a:cs typeface="Arial" panose="020B0604020202020204" pitchFamily="34" charset="0"/>
               </a:rPr>
               <a:t> </a:t>
             </a:r>
             <a:r>
               <a:rPr lang="en-US" sz="7200" dirty="0" err="1">
+                <a:solidFill>
+                  <a:srgbClr val="FFFFFF"/>
+                </a:solidFill>
                 <a:cs typeface="Arial" panose="020B0604020202020204" pitchFamily="34" charset="0"/>
               </a:rPr>
               <a:t>Heyo</a:t>
             </a:r>
             <a:r>
               <a:rPr lang="en-US" sz="7200" dirty="0">
+                <a:solidFill>
+                  <a:srgbClr val="FFFFFF"/>
+                </a:solidFill>
                 <a:cs typeface="Arial" panose="020B0604020202020204" pitchFamily="34" charset="0"/>
               </a:rPr>
               <a:t> </a:t>
@@ -17653,7 +18215,7 @@
     </p:spTree>
     <p:extLst>
       <p:ext uri="{BB962C8B-B14F-4D97-AF65-F5344CB8AC3E}">
-        <p14:creationId xmlns:p14="http://schemas.microsoft.com/office/powerpoint/2010/main" val="2344787189"/>
+        <p14:creationId xmlns:p14="http://schemas.microsoft.com/office/powerpoint/2010/main" val="4046938534"/>
       </p:ext>
     </p:extLst>
   </p:cSld>
@@ -17729,6 +18291,15 @@
               </a:rPr>
               <a:t>VS BLOCO 18</a:t>
             </a:r>
+            <a:r>
+              <a:rPr lang="pt-BR" sz="4800" baseline="41667" dirty="0">
+                <a:solidFill>
+                  <a:srgbClr val="FFFFFF"/>
+                </a:solidFill>
+                <a:cs typeface="Arial" panose="020B0604020202020204" pitchFamily="34" charset="0"/>
+              </a:rPr>
+              <a:t>  192 / 200 BPM</a:t>
+            </a:r>
           </a:p>
           <a:p>
             <a:pPr marL="36000" indent="-252000" algn="ctr">
@@ -17742,12 +18313,18 @@
             </a:pPr>
             <a:r>
               <a:rPr lang="en-US" sz="7200" dirty="0" err="1">
+                <a:solidFill>
+                  <a:srgbClr val="FFFFFF"/>
+                </a:solidFill>
                 <a:cs typeface="Arial" panose="020B0604020202020204" pitchFamily="34" charset="0"/>
               </a:rPr>
               <a:t>Olhos</a:t>
             </a:r>
             <a:r>
               <a:rPr lang="en-US" sz="7200" dirty="0">
+                <a:solidFill>
+                  <a:srgbClr val="FFFFFF"/>
+                </a:solidFill>
                 <a:cs typeface="Arial" panose="020B0604020202020204" pitchFamily="34" charset="0"/>
               </a:rPr>
               <a:t> Negros </a:t>
@@ -17774,12 +18351,18 @@
             </a:pPr>
             <a:r>
               <a:rPr lang="en-US" sz="7200" dirty="0" err="1">
+                <a:solidFill>
+                  <a:srgbClr val="FFFFFF"/>
+                </a:solidFill>
                 <a:cs typeface="Arial" panose="020B0604020202020204" pitchFamily="34" charset="0"/>
               </a:rPr>
               <a:t>Alô</a:t>
             </a:r>
             <a:r>
               <a:rPr lang="en-US" sz="7200" dirty="0">
+                <a:solidFill>
+                  <a:srgbClr val="FFFFFF"/>
+                </a:solidFill>
                 <a:cs typeface="Arial" panose="020B0604020202020204" pitchFamily="34" charset="0"/>
               </a:rPr>
               <a:t> meu Amor </a:t>
@@ -17819,7 +18402,7 @@
     </p:spTree>
     <p:extLst>
       <p:ext uri="{BB962C8B-B14F-4D97-AF65-F5344CB8AC3E}">
-        <p14:creationId xmlns:p14="http://schemas.microsoft.com/office/powerpoint/2010/main" val="1964108688"/>
+        <p14:creationId xmlns:p14="http://schemas.microsoft.com/office/powerpoint/2010/main" val="3066135460"/>
       </p:ext>
     </p:extLst>
   </p:cSld>
@@ -17895,6 +18478,15 @@
               </a:rPr>
               <a:t>VS BLOCO 19</a:t>
             </a:r>
+            <a:r>
+              <a:rPr lang="pt-BR" sz="4800" baseline="41667" dirty="0">
+                <a:solidFill>
+                  <a:srgbClr val="FFFFFF"/>
+                </a:solidFill>
+                <a:cs typeface="Arial" panose="020B0604020202020204" pitchFamily="34" charset="0"/>
+              </a:rPr>
+              <a:t>  137 BPM</a:t>
+            </a:r>
           </a:p>
           <a:p>
             <a:pPr marL="36000" indent="-252000" algn="ctr">
@@ -17907,7 +18499,11 @@
               <a:buNone/>
             </a:pPr>
             <a:r>
-              <a:rPr lang="pt-BR" sz="6600" dirty="0"/>
+              <a:rPr lang="pt-BR" sz="6600" dirty="0">
+                <a:solidFill>
+                  <a:srgbClr val="FFFFFF"/>
+                </a:solidFill>
+              </a:rPr>
               <a:t>Pegando Ônibus </a:t>
             </a:r>
             <a:r>
@@ -17922,7 +18518,11 @@
               <a:rPr lang="pt-BR" sz="6600" dirty="0"/>
             </a:br>
             <a:r>
-              <a:rPr lang="pt-BR" sz="6600" dirty="0"/>
+              <a:rPr lang="pt-BR" sz="6600" dirty="0">
+                <a:solidFill>
+                  <a:srgbClr val="FFFFFF"/>
+                </a:solidFill>
+              </a:rPr>
               <a:t>Bandido Do Amor </a:t>
             </a:r>
             <a:r>
@@ -17937,7 +18537,11 @@
               <a:rPr lang="pt-BR" sz="6600" dirty="0"/>
             </a:br>
             <a:r>
-              <a:rPr lang="pt-BR" sz="6600" dirty="0"/>
+              <a:rPr lang="pt-BR" sz="6600" dirty="0">
+                <a:solidFill>
+                  <a:srgbClr val="FFFFFF"/>
+                </a:solidFill>
+              </a:rPr>
               <a:t>O Que Tiver Que Vir Virá </a:t>
             </a:r>
             <a:r>
@@ -17960,7 +18564,7 @@
     </p:spTree>
     <p:extLst>
       <p:ext uri="{BB962C8B-B14F-4D97-AF65-F5344CB8AC3E}">
-        <p14:creationId xmlns:p14="http://schemas.microsoft.com/office/powerpoint/2010/main" val="2403216192"/>
+        <p14:creationId xmlns:p14="http://schemas.microsoft.com/office/powerpoint/2010/main" val="3947110089"/>
       </p:ext>
     </p:extLst>
   </p:cSld>
@@ -18036,6 +18640,15 @@
               </a:rPr>
               <a:t>VS BLOCO 20</a:t>
             </a:r>
+            <a:r>
+              <a:rPr lang="pt-BR" sz="4800" baseline="41667" dirty="0">
+                <a:solidFill>
+                  <a:srgbClr val="FFFFFF"/>
+                </a:solidFill>
+                <a:cs typeface="Arial" panose="020B0604020202020204" pitchFamily="34" charset="0"/>
+              </a:rPr>
+              <a:t>  190 BPM</a:t>
+            </a:r>
           </a:p>
           <a:p>
             <a:pPr marL="36000" indent="-252000" algn="ctr">
@@ -18048,7 +18661,11 @@
               <a:buNone/>
             </a:pPr>
             <a:r>
-              <a:rPr lang="pt-BR" sz="7200" dirty="0"/>
+              <a:rPr lang="pt-BR" sz="7200" dirty="0">
+                <a:solidFill>
+                  <a:srgbClr val="FFFFFF"/>
+                </a:solidFill>
+              </a:rPr>
               <a:t>Perigosa e Linda </a:t>
             </a:r>
             <a:r>
@@ -18063,19 +18680,35 @@
               <a:rPr lang="pt-BR" sz="7200" dirty="0"/>
             </a:br>
             <a:r>
-              <a:rPr lang="pt-BR" sz="7200" dirty="0" err="1"/>
+              <a:rPr lang="pt-BR" sz="7200" dirty="0" err="1">
+                <a:solidFill>
+                  <a:srgbClr val="FFFFFF"/>
+                </a:solidFill>
+              </a:rPr>
               <a:t>Cumpadi</a:t>
             </a:r>
             <a:r>
-              <a:rPr lang="pt-BR" sz="7200" dirty="0"/>
+              <a:rPr lang="pt-BR" sz="7200" dirty="0">
+                <a:solidFill>
+                  <a:srgbClr val="FFFFFF"/>
+                </a:solidFill>
+              </a:rPr>
               <a:t> e </a:t>
             </a:r>
             <a:r>
-              <a:rPr lang="pt-BR" sz="7200" dirty="0" err="1"/>
+              <a:rPr lang="pt-BR" sz="7200" dirty="0" err="1">
+                <a:solidFill>
+                  <a:srgbClr val="FFFFFF"/>
+                </a:solidFill>
+              </a:rPr>
               <a:t>Cumadi</a:t>
             </a:r>
             <a:r>
-              <a:rPr lang="pt-BR" sz="7200" dirty="0"/>
+              <a:rPr lang="pt-BR" sz="7200" dirty="0">
+                <a:solidFill>
+                  <a:srgbClr val="FFFFFF"/>
+                </a:solidFill>
+              </a:rPr>
               <a:t> </a:t>
             </a:r>
             <a:r>
@@ -18098,7 +18731,7 @@
     </p:spTree>
     <p:extLst>
       <p:ext uri="{BB962C8B-B14F-4D97-AF65-F5344CB8AC3E}">
-        <p14:creationId xmlns:p14="http://schemas.microsoft.com/office/powerpoint/2010/main" val="1629742765"/>
+        <p14:creationId xmlns:p14="http://schemas.microsoft.com/office/powerpoint/2010/main" val="1100565757"/>
       </p:ext>
     </p:extLst>
   </p:cSld>
@@ -18174,6 +18807,15 @@
               </a:rPr>
               <a:t>VS BLOCO 21</a:t>
             </a:r>
+            <a:r>
+              <a:rPr lang="pt-BR" sz="4800" baseline="41667" dirty="0">
+                <a:solidFill>
+                  <a:srgbClr val="FFFFFF"/>
+                </a:solidFill>
+                <a:cs typeface="Arial" panose="020B0604020202020204" pitchFamily="34" charset="0"/>
+              </a:rPr>
+              <a:t>  140 BPM</a:t>
+            </a:r>
           </a:p>
           <a:p>
             <a:pPr marL="36000" indent="-252000" algn="ctr">
@@ -18186,7 +18828,11 @@
               <a:buNone/>
             </a:pPr>
             <a:r>
-              <a:rPr lang="pt-BR" sz="7200" dirty="0"/>
+              <a:rPr lang="pt-BR" sz="7200" dirty="0">
+                <a:solidFill>
+                  <a:srgbClr val="FFFFFF"/>
+                </a:solidFill>
+              </a:rPr>
               <a:t>Reprises De Amor </a:t>
             </a:r>
             <a:r>
@@ -18201,7 +18847,11 @@
               <a:rPr lang="pt-BR" sz="7200" dirty="0"/>
             </a:br>
             <a:r>
-              <a:rPr lang="pt-BR" sz="7200" dirty="0"/>
+              <a:rPr lang="pt-BR" sz="7200" dirty="0">
+                <a:solidFill>
+                  <a:srgbClr val="FFFFFF"/>
+                </a:solidFill>
+              </a:rPr>
               <a:t>Eu O Copo e a Solidão </a:t>
             </a:r>
             <a:r>
@@ -18216,7 +18866,11 @@
               <a:rPr lang="pt-BR" sz="7200" dirty="0"/>
             </a:br>
             <a:r>
-              <a:rPr lang="pt-BR" sz="7200" dirty="0"/>
+              <a:rPr lang="pt-BR" sz="7200" dirty="0">
+                <a:solidFill>
+                  <a:srgbClr val="FFFFFF"/>
+                </a:solidFill>
+              </a:rPr>
               <a:t>Você Me Tira Do Ar </a:t>
             </a:r>
             <a:r>
@@ -18239,7 +18893,7 @@
     </p:spTree>
     <p:extLst>
       <p:ext uri="{BB962C8B-B14F-4D97-AF65-F5344CB8AC3E}">
-        <p14:creationId xmlns:p14="http://schemas.microsoft.com/office/powerpoint/2010/main" val="2219016206"/>
+        <p14:creationId xmlns:p14="http://schemas.microsoft.com/office/powerpoint/2010/main" val="2378623589"/>
       </p:ext>
     </p:extLst>
   </p:cSld>
@@ -18315,6 +18969,15 @@
               </a:rPr>
               <a:t>VS BLOCO 22</a:t>
             </a:r>
+            <a:r>
+              <a:rPr lang="pt-BR" sz="4800" baseline="41667" dirty="0">
+                <a:solidFill>
+                  <a:srgbClr val="FFFFFF"/>
+                </a:solidFill>
+                <a:cs typeface="Arial" panose="020B0604020202020204" pitchFamily="34" charset="0"/>
+              </a:rPr>
+              <a:t>  140 BPM</a:t>
+            </a:r>
           </a:p>
           <a:p>
             <a:pPr marL="36000" indent="-252000" algn="ctr">
@@ -18327,7 +18990,11 @@
               <a:buNone/>
             </a:pPr>
             <a:r>
-              <a:rPr lang="pt-BR" sz="7200" dirty="0"/>
+              <a:rPr lang="pt-BR" sz="7200" dirty="0">
+                <a:solidFill>
+                  <a:srgbClr val="FFFFFF"/>
+                </a:solidFill>
+              </a:rPr>
               <a:t>Santa Catarina </a:t>
             </a:r>
             <a:r>
@@ -18342,7 +19009,11 @@
               <a:rPr lang="pt-BR" sz="7200" dirty="0"/>
             </a:br>
             <a:r>
-              <a:rPr lang="pt-BR" sz="7200" dirty="0"/>
+              <a:rPr lang="pt-BR" sz="7200" dirty="0">
+                <a:solidFill>
+                  <a:srgbClr val="FFFFFF"/>
+                </a:solidFill>
+              </a:rPr>
               <a:t>Baile Bom </a:t>
             </a:r>
             <a:r>
@@ -18357,7 +19028,11 @@
               <a:rPr lang="pt-BR" sz="7200" dirty="0"/>
             </a:br>
             <a:r>
-              <a:rPr lang="pt-BR" sz="7200" dirty="0"/>
+              <a:rPr lang="pt-BR" sz="7200" dirty="0">
+                <a:solidFill>
+                  <a:srgbClr val="FFFFFF"/>
+                </a:solidFill>
+              </a:rPr>
               <a:t>Diga Locutor </a:t>
             </a:r>
             <a:r>
@@ -18380,7 +19055,7 @@
     </p:spTree>
     <p:extLst>
       <p:ext uri="{BB962C8B-B14F-4D97-AF65-F5344CB8AC3E}">
-        <p14:creationId xmlns:p14="http://schemas.microsoft.com/office/powerpoint/2010/main" val="4214511313"/>
+        <p14:creationId xmlns:p14="http://schemas.microsoft.com/office/powerpoint/2010/main" val="3034252705"/>
       </p:ext>
     </p:extLst>
   </p:cSld>
@@ -18456,6 +19131,15 @@
               </a:rPr>
               <a:t>VS BLOCO 23</a:t>
             </a:r>
+            <a:r>
+              <a:rPr lang="pt-BR" sz="4800" baseline="41667" dirty="0">
+                <a:solidFill>
+                  <a:srgbClr val="FFFFFF"/>
+                </a:solidFill>
+                <a:cs typeface="Arial" panose="020B0604020202020204" pitchFamily="34" charset="0"/>
+              </a:rPr>
+              <a:t>  188 BPM</a:t>
+            </a:r>
           </a:p>
           <a:p>
             <a:pPr marL="36000" indent="-252000" algn="ctr">
@@ -18468,7 +19152,11 @@
               <a:buNone/>
             </a:pPr>
             <a:r>
-              <a:rPr lang="pt-BR" sz="7200" dirty="0"/>
+              <a:rPr lang="pt-BR" sz="7200" dirty="0">
+                <a:solidFill>
+                  <a:srgbClr val="FFFFFF"/>
+                </a:solidFill>
+              </a:rPr>
               <a:t>Vagabundo </a:t>
             </a:r>
             <a:r>
@@ -18483,15 +19171,27 @@
               <a:rPr lang="pt-BR" sz="7200" dirty="0"/>
             </a:br>
             <a:r>
-              <a:rPr lang="pt-BR" sz="7200" dirty="0"/>
+              <a:rPr lang="pt-BR" sz="7200" dirty="0">
+                <a:solidFill>
+                  <a:srgbClr val="FFFFFF"/>
+                </a:solidFill>
+              </a:rPr>
               <a:t>Agarra </a:t>
             </a:r>
             <a:r>
-              <a:rPr lang="pt-BR" sz="7200" dirty="0" err="1"/>
+              <a:rPr lang="pt-BR" sz="7200" dirty="0" err="1">
+                <a:solidFill>
+                  <a:srgbClr val="FFFFFF"/>
+                </a:solidFill>
+              </a:rPr>
               <a:t>Agara</a:t>
             </a:r>
             <a:r>
-              <a:rPr lang="pt-BR" sz="7200" dirty="0"/>
+              <a:rPr lang="pt-BR" sz="7200" dirty="0">
+                <a:solidFill>
+                  <a:srgbClr val="FFFFFF"/>
+                </a:solidFill>
+              </a:rPr>
               <a:t> </a:t>
             </a:r>
             <a:r>
@@ -18506,7 +19206,11 @@
               <a:rPr lang="pt-BR" sz="7200" dirty="0"/>
             </a:br>
             <a:r>
-              <a:rPr lang="pt-BR" sz="7200" dirty="0"/>
+              <a:rPr lang="pt-BR" sz="7200" dirty="0">
+                <a:solidFill>
+                  <a:srgbClr val="FFFFFF"/>
+                </a:solidFill>
+              </a:rPr>
               <a:t>Vira e Mexe </a:t>
             </a:r>
             <a:r>
@@ -18529,7 +19233,7 @@
     </p:spTree>
     <p:extLst>
       <p:ext uri="{BB962C8B-B14F-4D97-AF65-F5344CB8AC3E}">
-        <p14:creationId xmlns:p14="http://schemas.microsoft.com/office/powerpoint/2010/main" val="132768071"/>
+        <p14:creationId xmlns:p14="http://schemas.microsoft.com/office/powerpoint/2010/main" val="1936083096"/>
       </p:ext>
     </p:extLst>
   </p:cSld>
@@ -18599,6 +19303,15 @@
               </a:rPr>
               <a:t>VS BLOCO 24</a:t>
             </a:r>
+            <a:r>
+              <a:rPr lang="pt-BR" sz="4800" baseline="41667" dirty="0">
+                <a:solidFill>
+                  <a:srgbClr val="FFFFFF"/>
+                </a:solidFill>
+                <a:cs typeface="Arial" panose="020B0604020202020204" pitchFamily="34" charset="0"/>
+              </a:rPr>
+              <a:t>  138 BPM</a:t>
+            </a:r>
           </a:p>
           <a:p>
             <a:pPr marL="36000" indent="-252000" algn="ctr">
@@ -18611,7 +19324,11 @@
               <a:buNone/>
             </a:pPr>
             <a:r>
-              <a:rPr lang="pt-BR" sz="7200" dirty="0"/>
+              <a:rPr lang="pt-BR" sz="7200" dirty="0">
+                <a:solidFill>
+                  <a:srgbClr val="FFFFFF"/>
+                </a:solidFill>
+              </a:rPr>
               <a:t>Alô Galera </a:t>
             </a:r>
             <a:r>
@@ -18626,7 +19343,11 @@
               <a:rPr lang="pt-BR" sz="7200" dirty="0"/>
             </a:br>
             <a:r>
-              <a:rPr lang="pt-BR" sz="7200" dirty="0"/>
+              <a:rPr lang="pt-BR" sz="7200" dirty="0">
+                <a:solidFill>
+                  <a:srgbClr val="FFFFFF"/>
+                </a:solidFill>
+              </a:rPr>
               <a:t>Essa Cama Eu Não Vendo </a:t>
             </a:r>
             <a:r>
@@ -18641,7 +19362,11 @@
               <a:rPr lang="pt-BR" sz="7200" dirty="0"/>
             </a:br>
             <a:r>
-              <a:rPr lang="pt-BR" sz="7200" dirty="0"/>
+              <a:rPr lang="pt-BR" sz="7200" dirty="0">
+                <a:solidFill>
+                  <a:srgbClr val="FFFFFF"/>
+                </a:solidFill>
+              </a:rPr>
               <a:t>Pintou Uma Paixão </a:t>
             </a:r>
             <a:r>
@@ -18656,7 +19381,11 @@
               <a:rPr lang="pt-BR" sz="7200" dirty="0"/>
             </a:br>
             <a:r>
-              <a:rPr lang="pt-BR" sz="7200" dirty="0"/>
+              <a:rPr lang="pt-BR" sz="7200" dirty="0">
+                <a:solidFill>
+                  <a:srgbClr val="FFFFFF"/>
+                </a:solidFill>
+              </a:rPr>
               <a:t>Transgênica </a:t>
             </a:r>
             <a:r>
@@ -18671,7 +19400,11 @@
               <a:rPr lang="pt-BR" sz="7200" dirty="0"/>
             </a:br>
             <a:r>
-              <a:rPr lang="pt-BR" sz="7200" dirty="0"/>
+              <a:rPr lang="pt-BR" sz="7200" dirty="0">
+                <a:solidFill>
+                  <a:srgbClr val="FFFFFF"/>
+                </a:solidFill>
+              </a:rPr>
               <a:t>Algo Me Diz </a:t>
             </a:r>
             <a:r>
@@ -18688,7 +19421,7 @@
     </p:spTree>
     <p:extLst>
       <p:ext uri="{BB962C8B-B14F-4D97-AF65-F5344CB8AC3E}">
-        <p14:creationId xmlns:p14="http://schemas.microsoft.com/office/powerpoint/2010/main" val="2284215507"/>
+        <p14:creationId xmlns:p14="http://schemas.microsoft.com/office/powerpoint/2010/main" val="1895795543"/>
       </p:ext>
     </p:extLst>
   </p:cSld>
@@ -18758,6 +19491,15 @@
               </a:rPr>
               <a:t>VS BLOCO 25</a:t>
             </a:r>
+            <a:r>
+              <a:rPr lang="pt-BR" sz="4800" baseline="41667" dirty="0">
+                <a:solidFill>
+                  <a:srgbClr val="FFFFFF"/>
+                </a:solidFill>
+                <a:cs typeface="Arial" panose="020B0604020202020204" pitchFamily="34" charset="0"/>
+              </a:rPr>
+              <a:t>  136 BPM</a:t>
+            </a:r>
           </a:p>
           <a:p>
             <a:pPr marL="36000" indent="-252000" algn="ctr">
@@ -18770,7 +19512,11 @@
               <a:buNone/>
             </a:pPr>
             <a:r>
-              <a:rPr lang="pt-BR" sz="7200" dirty="0"/>
+              <a:rPr lang="pt-BR" sz="7200" dirty="0">
+                <a:solidFill>
+                  <a:srgbClr val="FFFFFF"/>
+                </a:solidFill>
+              </a:rPr>
               <a:t>Barril de Chopp </a:t>
             </a:r>
             <a:r>
@@ -18785,7 +19531,11 @@
               <a:rPr lang="pt-BR" sz="7200" dirty="0"/>
             </a:br>
             <a:r>
-              <a:rPr lang="pt-BR" sz="7200" dirty="0"/>
+              <a:rPr lang="pt-BR" sz="7200" dirty="0">
+                <a:solidFill>
+                  <a:srgbClr val="FFFFFF"/>
+                </a:solidFill>
+              </a:rPr>
               <a:t>Ouro na Estrada </a:t>
             </a:r>
             <a:r>
@@ -18800,7 +19550,11 @@
               <a:rPr lang="pt-BR" sz="7200" dirty="0"/>
             </a:br>
             <a:r>
-              <a:rPr lang="pt-BR" sz="7200" dirty="0"/>
+              <a:rPr lang="pt-BR" sz="7200" dirty="0">
+                <a:solidFill>
+                  <a:srgbClr val="FFFFFF"/>
+                </a:solidFill>
+              </a:rPr>
               <a:t>Bebidas de Amor </a:t>
             </a:r>
             <a:r>
@@ -18817,7 +19571,7 @@
     </p:spTree>
     <p:extLst>
       <p:ext uri="{BB962C8B-B14F-4D97-AF65-F5344CB8AC3E}">
-        <p14:creationId xmlns:p14="http://schemas.microsoft.com/office/powerpoint/2010/main" val="1666658942"/>
+        <p14:creationId xmlns:p14="http://schemas.microsoft.com/office/powerpoint/2010/main" val="758399868"/>
       </p:ext>
     </p:extLst>
   </p:cSld>
@@ -19066,6 +19820,15 @@
               </a:rPr>
               <a:t>VS BLOCO 26</a:t>
             </a:r>
+            <a:r>
+              <a:rPr lang="pt-BR" sz="4800" baseline="41667" dirty="0">
+                <a:solidFill>
+                  <a:srgbClr val="FFFFFF"/>
+                </a:solidFill>
+                <a:cs typeface="Arial" panose="020B0604020202020204" pitchFamily="34" charset="0"/>
+              </a:rPr>
+              <a:t>  138 BPM</a:t>
+            </a:r>
           </a:p>
           <a:p>
             <a:pPr marL="36000" indent="-252000" algn="ctr">
@@ -19078,7 +19841,11 @@
               <a:buNone/>
             </a:pPr>
             <a:r>
-              <a:rPr lang="pt-BR" sz="7200" dirty="0"/>
+              <a:rPr lang="pt-BR" sz="7200" dirty="0">
+                <a:solidFill>
+                  <a:srgbClr val="FFFFFF"/>
+                </a:solidFill>
+              </a:rPr>
               <a:t>Beija Beija </a:t>
             </a:r>
             <a:r>
@@ -19093,7 +19860,11 @@
               <a:rPr lang="pt-BR" sz="7200" dirty="0"/>
             </a:br>
             <a:r>
-              <a:rPr lang="pt-BR" sz="7200" dirty="0"/>
+              <a:rPr lang="pt-BR" sz="7200" dirty="0">
+                <a:solidFill>
+                  <a:srgbClr val="FFFFFF"/>
+                </a:solidFill>
+              </a:rPr>
               <a:t>Marreca </a:t>
             </a:r>
             <a:r>
@@ -19108,7 +19879,11 @@
               <a:rPr lang="pt-BR" sz="7200" dirty="0"/>
             </a:br>
             <a:r>
-              <a:rPr lang="pt-BR" sz="7200" dirty="0"/>
+              <a:rPr lang="pt-BR" sz="7200" dirty="0">
+                <a:solidFill>
+                  <a:srgbClr val="FFFFFF"/>
+                </a:solidFill>
+              </a:rPr>
               <a:t>Kerbfest </a:t>
             </a:r>
             <a:r>
@@ -19125,7 +19900,7 @@
     </p:spTree>
     <p:extLst>
       <p:ext uri="{BB962C8B-B14F-4D97-AF65-F5344CB8AC3E}">
-        <p14:creationId xmlns:p14="http://schemas.microsoft.com/office/powerpoint/2010/main" val="2287560427"/>
+        <p14:creationId xmlns:p14="http://schemas.microsoft.com/office/powerpoint/2010/main" val="2273785495"/>
       </p:ext>
     </p:extLst>
   </p:cSld>
@@ -19195,6 +19970,15 @@
               </a:rPr>
               <a:t>VS BLOCO 27</a:t>
             </a:r>
+            <a:r>
+              <a:rPr lang="pt-BR" sz="4800" baseline="41667" dirty="0">
+                <a:solidFill>
+                  <a:srgbClr val="FFFFFF"/>
+                </a:solidFill>
+                <a:cs typeface="Arial" panose="020B0604020202020204" pitchFamily="34" charset="0"/>
+              </a:rPr>
+              <a:t>  168 BPM</a:t>
+            </a:r>
           </a:p>
           <a:p>
             <a:pPr marL="36000" indent="-252000" algn="ctr">
@@ -19207,7 +19991,11 @@
               <a:buNone/>
             </a:pPr>
             <a:r>
-              <a:rPr lang="pt-BR" sz="7200" dirty="0"/>
+              <a:rPr lang="pt-BR" sz="7200" dirty="0">
+                <a:solidFill>
+                  <a:srgbClr val="FFFFFF"/>
+                </a:solidFill>
+              </a:rPr>
               <a:t>Camisa Manchada </a:t>
             </a:r>
             <a:r>
@@ -19222,7 +20010,11 @@
               <a:rPr lang="pt-BR" sz="7200" dirty="0"/>
             </a:br>
             <a:r>
-              <a:rPr lang="pt-BR" sz="7200" dirty="0"/>
+              <a:rPr lang="pt-BR" sz="7200" dirty="0">
+                <a:solidFill>
+                  <a:srgbClr val="FFFFFF"/>
+                </a:solidFill>
+              </a:rPr>
               <a:t>&lt;falta o nome&gt; </a:t>
             </a:r>
             <a:r>
@@ -19237,7 +20029,11 @@
               <a:rPr lang="pt-BR" sz="7200" dirty="0"/>
             </a:br>
             <a:r>
-              <a:rPr lang="pt-BR" sz="7200" dirty="0"/>
+              <a:rPr lang="pt-BR" sz="7200" dirty="0">
+                <a:solidFill>
+                  <a:srgbClr val="FFFFFF"/>
+                </a:solidFill>
+              </a:rPr>
               <a:t>Estrada Da Vida </a:t>
             </a:r>
             <a:r>
@@ -19254,7 +20050,7 @@
     </p:spTree>
     <p:extLst>
       <p:ext uri="{BB962C8B-B14F-4D97-AF65-F5344CB8AC3E}">
-        <p14:creationId xmlns:p14="http://schemas.microsoft.com/office/powerpoint/2010/main" val="4023159127"/>
+        <p14:creationId xmlns:p14="http://schemas.microsoft.com/office/powerpoint/2010/main" val="2971652731"/>
       </p:ext>
     </p:extLst>
   </p:cSld>
@@ -19324,6 +20120,15 @@
               </a:rPr>
               <a:t>VS BLOCO 28</a:t>
             </a:r>
+            <a:r>
+              <a:rPr lang="pt-BR" sz="4800" baseline="41667" dirty="0">
+                <a:solidFill>
+                  <a:srgbClr val="FFFFFF"/>
+                </a:solidFill>
+                <a:cs typeface="Arial" panose="020B0604020202020204" pitchFamily="34" charset="0"/>
+              </a:rPr>
+              <a:t>  130 BPM</a:t>
+            </a:r>
           </a:p>
           <a:p>
             <a:pPr marL="36000" indent="-252000" algn="ctr">
@@ -19336,7 +20141,11 @@
               <a:buNone/>
             </a:pPr>
             <a:r>
-              <a:rPr lang="pt-BR" sz="5400" dirty="0"/>
+              <a:rPr lang="pt-BR" sz="5400" dirty="0">
+                <a:solidFill>
+                  <a:srgbClr val="FFFFFF"/>
+                </a:solidFill>
+              </a:rPr>
               <a:t>Coronel Boogey </a:t>
             </a:r>
             <a:r>
@@ -19351,7 +20160,11 @@
               <a:rPr lang="pt-BR" sz="5400" dirty="0"/>
             </a:br>
             <a:r>
-              <a:rPr lang="pt-BR" sz="5400" dirty="0"/>
+              <a:rPr lang="pt-BR" sz="5400" dirty="0">
+                <a:solidFill>
+                  <a:srgbClr val="FFFFFF"/>
+                </a:solidFill>
+              </a:rPr>
               <a:t>Marcha do Coelho </a:t>
             </a:r>
             <a:r>
@@ -19368,7 +20181,7 @@
     </p:spTree>
     <p:extLst>
       <p:ext uri="{BB962C8B-B14F-4D97-AF65-F5344CB8AC3E}">
-        <p14:creationId xmlns:p14="http://schemas.microsoft.com/office/powerpoint/2010/main" val="2592617258"/>
+        <p14:creationId xmlns:p14="http://schemas.microsoft.com/office/powerpoint/2010/main" val="3862167691"/>
       </p:ext>
     </p:extLst>
   </p:cSld>
@@ -19438,6 +20251,15 @@
               </a:rPr>
               <a:t>VS BLOCO 29</a:t>
             </a:r>
+            <a:r>
+              <a:rPr lang="pt-BR" sz="4800" baseline="41667" dirty="0">
+                <a:solidFill>
+                  <a:srgbClr val="FFFFFF"/>
+                </a:solidFill>
+                <a:cs typeface="Arial" panose="020B0604020202020204" pitchFamily="34" charset="0"/>
+              </a:rPr>
+              <a:t>  138 BPM</a:t>
+            </a:r>
           </a:p>
           <a:p>
             <a:pPr marL="36000" indent="-252000" algn="ctr">
@@ -19450,7 +20272,11 @@
               <a:buNone/>
             </a:pPr>
             <a:r>
-              <a:rPr lang="pt-BR" sz="7200" dirty="0"/>
+              <a:rPr lang="pt-BR" sz="7200" dirty="0">
+                <a:solidFill>
+                  <a:srgbClr val="FFFFFF"/>
+                </a:solidFill>
+              </a:rPr>
               <a:t>Dai Que Mioro </a:t>
             </a:r>
             <a:r>
@@ -19465,7 +20291,11 @@
               <a:rPr lang="pt-BR" sz="7200" dirty="0"/>
             </a:br>
             <a:r>
-              <a:rPr lang="pt-BR" sz="7200" dirty="0"/>
+              <a:rPr lang="pt-BR" sz="7200" dirty="0">
+                <a:solidFill>
+                  <a:srgbClr val="FFFFFF"/>
+                </a:solidFill>
+              </a:rPr>
               <a:t>Senta no Colinho do Pai </a:t>
             </a:r>
             <a:r>
@@ -19480,7 +20310,11 @@
               <a:rPr lang="pt-BR" sz="7200" dirty="0"/>
             </a:br>
             <a:r>
-              <a:rPr lang="pt-BR" sz="7200" dirty="0"/>
+              <a:rPr lang="pt-BR" sz="7200" dirty="0">
+                <a:solidFill>
+                  <a:srgbClr val="FFFFFF"/>
+                </a:solidFill>
+              </a:rPr>
               <a:t>Latinha na Goteira </a:t>
             </a:r>
             <a:r>
@@ -19495,7 +20329,11 @@
               <a:rPr lang="pt-BR" sz="7200" dirty="0"/>
             </a:br>
             <a:r>
-              <a:rPr lang="pt-BR" sz="7200" dirty="0"/>
+              <a:rPr lang="pt-BR" sz="7200" dirty="0">
+                <a:solidFill>
+                  <a:srgbClr val="FFFFFF"/>
+                </a:solidFill>
+              </a:rPr>
               <a:t>Morenaça </a:t>
             </a:r>
             <a:r>
@@ -19510,7 +20348,11 @@
               <a:rPr lang="pt-BR" sz="7200" dirty="0"/>
             </a:br>
             <a:r>
-              <a:rPr lang="pt-BR" sz="7200" dirty="0"/>
+              <a:rPr lang="pt-BR" sz="7200" dirty="0">
+                <a:solidFill>
+                  <a:srgbClr val="FFFFFF"/>
+                </a:solidFill>
+              </a:rPr>
               <a:t>Misturinha </a:t>
             </a:r>
             <a:r>
@@ -19527,7 +20369,7 @@
     </p:spTree>
     <p:extLst>
       <p:ext uri="{BB962C8B-B14F-4D97-AF65-F5344CB8AC3E}">
-        <p14:creationId xmlns:p14="http://schemas.microsoft.com/office/powerpoint/2010/main" val="3011462309"/>
+        <p14:creationId xmlns:p14="http://schemas.microsoft.com/office/powerpoint/2010/main" val="3282265368"/>
       </p:ext>
     </p:extLst>
   </p:cSld>
@@ -19597,6 +20439,15 @@
               </a:rPr>
               <a:t>VS BLOCO 30</a:t>
             </a:r>
+            <a:r>
+              <a:rPr lang="pt-BR" sz="4800" baseline="41667" dirty="0">
+                <a:solidFill>
+                  <a:srgbClr val="FFFFFF"/>
+                </a:solidFill>
+                <a:cs typeface="Arial" panose="020B0604020202020204" pitchFamily="34" charset="0"/>
+              </a:rPr>
+              <a:t>  135 BPM</a:t>
+            </a:r>
           </a:p>
           <a:p>
             <a:pPr marL="36000" indent="-252000" algn="ctr">
@@ -19609,7 +20460,11 @@
               <a:buNone/>
             </a:pPr>
             <a:r>
-              <a:rPr lang="pt-BR" sz="7200" dirty="0"/>
+              <a:rPr lang="pt-BR" sz="7200" dirty="0">
+                <a:solidFill>
+                  <a:srgbClr val="FFFFFF"/>
+                </a:solidFill>
+              </a:rPr>
               <a:t>Heyo Heyo </a:t>
             </a:r>
             <a:r>
@@ -19624,7 +20479,11 @@
               <a:rPr lang="pt-BR" sz="7200" dirty="0"/>
             </a:br>
             <a:r>
-              <a:rPr lang="pt-BR" sz="7200" dirty="0"/>
+              <a:rPr lang="pt-BR" sz="7200" dirty="0">
+                <a:solidFill>
+                  <a:srgbClr val="FFFFFF"/>
+                </a:solidFill>
+              </a:rPr>
               <a:t>Zic Zac </a:t>
             </a:r>
             <a:r>
@@ -19639,7 +20498,11 @@
               <a:rPr lang="pt-BR" sz="7200" dirty="0"/>
             </a:br>
             <a:r>
-              <a:rPr lang="pt-BR" sz="7200" dirty="0"/>
+              <a:rPr lang="pt-BR" sz="7200" dirty="0">
+                <a:solidFill>
+                  <a:srgbClr val="FFFFFF"/>
+                </a:solidFill>
+              </a:rPr>
               <a:t>Salada de Frutas </a:t>
             </a:r>
             <a:r>
@@ -19656,7 +20519,7 @@
     </p:spTree>
     <p:extLst>
       <p:ext uri="{BB962C8B-B14F-4D97-AF65-F5344CB8AC3E}">
-        <p14:creationId xmlns:p14="http://schemas.microsoft.com/office/powerpoint/2010/main" val="962949835"/>
+        <p14:creationId xmlns:p14="http://schemas.microsoft.com/office/powerpoint/2010/main" val="1795630249"/>
       </p:ext>
     </p:extLst>
   </p:cSld>
@@ -19726,6 +20589,15 @@
               </a:rPr>
               <a:t>VS BLOCO 31</a:t>
             </a:r>
+            <a:r>
+              <a:rPr lang="pt-BR" sz="4800" baseline="41667" dirty="0">
+                <a:solidFill>
+                  <a:srgbClr val="FFFFFF"/>
+                </a:solidFill>
+                <a:cs typeface="Arial" panose="020B0604020202020204" pitchFamily="34" charset="0"/>
+              </a:rPr>
+              <a:t>  138 BPM</a:t>
+            </a:r>
           </a:p>
           <a:p>
             <a:pPr marL="36000" indent="-252000" algn="ctr">
@@ -19738,7 +20610,11 @@
               <a:buNone/>
             </a:pPr>
             <a:r>
-              <a:rPr lang="pt-BR" sz="7200" dirty="0"/>
+              <a:rPr lang="pt-BR" sz="7200" dirty="0">
+                <a:solidFill>
+                  <a:srgbClr val="FFFFFF"/>
+                </a:solidFill>
+              </a:rPr>
               <a:t>Nova Iorque </a:t>
             </a:r>
             <a:r>
@@ -19753,7 +20629,11 @@
               <a:rPr lang="pt-BR" sz="7200" dirty="0"/>
             </a:br>
             <a:r>
-              <a:rPr lang="pt-BR" sz="7200" dirty="0"/>
+              <a:rPr lang="pt-BR" sz="7200" dirty="0">
+                <a:solidFill>
+                  <a:srgbClr val="FFFFFF"/>
+                </a:solidFill>
+              </a:rPr>
               <a:t>Meu Ex Amor </a:t>
             </a:r>
             <a:r>
@@ -19768,7 +20648,11 @@
               <a:rPr lang="pt-BR" sz="7200" dirty="0"/>
             </a:br>
             <a:r>
-              <a:rPr lang="pt-BR" sz="7200" dirty="0"/>
+              <a:rPr lang="pt-BR" sz="7200" dirty="0">
+                <a:solidFill>
+                  <a:srgbClr val="FFFFFF"/>
+                </a:solidFill>
+              </a:rPr>
               <a:t>O Que Tiver Que Vir Virá </a:t>
             </a:r>
             <a:r>
@@ -19785,7 +20669,7 @@
     </p:spTree>
     <p:extLst>
       <p:ext uri="{BB962C8B-B14F-4D97-AF65-F5344CB8AC3E}">
-        <p14:creationId xmlns:p14="http://schemas.microsoft.com/office/powerpoint/2010/main" val="1425043211"/>
+        <p14:creationId xmlns:p14="http://schemas.microsoft.com/office/powerpoint/2010/main" val="2630618978"/>
       </p:ext>
     </p:extLst>
   </p:cSld>
@@ -19855,6 +20739,15 @@
               </a:rPr>
               <a:t>VS BLOCO 32</a:t>
             </a:r>
+            <a:r>
+              <a:rPr lang="pt-BR" sz="4800" baseline="41667" dirty="0">
+                <a:solidFill>
+                  <a:srgbClr val="FFFFFF"/>
+                </a:solidFill>
+                <a:cs typeface="Arial" panose="020B0604020202020204" pitchFamily="34" charset="0"/>
+              </a:rPr>
+              <a:t>  138 BPM</a:t>
+            </a:r>
           </a:p>
           <a:p>
             <a:pPr marL="36000" indent="-252000" algn="ctr">
@@ -19867,7 +20760,11 @@
               <a:buNone/>
             </a:pPr>
             <a:r>
-              <a:rPr lang="pt-BR" sz="7200" dirty="0"/>
+              <a:rPr lang="pt-BR" sz="7200" dirty="0">
+                <a:solidFill>
+                  <a:srgbClr val="FFFFFF"/>
+                </a:solidFill>
+              </a:rPr>
               <a:t>Ponto Chick </a:t>
             </a:r>
             <a:r>
@@ -19882,7 +20779,11 @@
               <a:rPr lang="pt-BR" sz="7200" dirty="0"/>
             </a:br>
             <a:r>
-              <a:rPr lang="pt-BR" sz="7200" dirty="0"/>
+              <a:rPr lang="pt-BR" sz="7200" dirty="0">
+                <a:solidFill>
+                  <a:srgbClr val="FFFFFF"/>
+                </a:solidFill>
+              </a:rPr>
               <a:t>Rancho Grande </a:t>
             </a:r>
             <a:r>
@@ -19897,7 +20798,11 @@
               <a:rPr lang="pt-BR" sz="7200" dirty="0"/>
             </a:br>
             <a:r>
-              <a:rPr lang="pt-BR" sz="7200" dirty="0"/>
+              <a:rPr lang="pt-BR" sz="7200" dirty="0">
+                <a:solidFill>
+                  <a:srgbClr val="FFFFFF"/>
+                </a:solidFill>
+              </a:rPr>
               <a:t>Feliz em Festa </a:t>
             </a:r>
             <a:r>
@@ -19914,7 +20819,7 @@
     </p:spTree>
     <p:extLst>
       <p:ext uri="{BB962C8B-B14F-4D97-AF65-F5344CB8AC3E}">
-        <p14:creationId xmlns:p14="http://schemas.microsoft.com/office/powerpoint/2010/main" val="2605717146"/>
+        <p14:creationId xmlns:p14="http://schemas.microsoft.com/office/powerpoint/2010/main" val="2764430638"/>
       </p:ext>
     </p:extLst>
   </p:cSld>
@@ -19984,6 +20889,15 @@
               </a:rPr>
               <a:t>VS BLOCO 33</a:t>
             </a:r>
+            <a:r>
+              <a:rPr lang="pt-BR" sz="4800" baseline="41667" dirty="0">
+                <a:solidFill>
+                  <a:srgbClr val="FFFFFF"/>
+                </a:solidFill>
+                <a:cs typeface="Arial" panose="020B0604020202020204" pitchFamily="34" charset="0"/>
+              </a:rPr>
+              <a:t>  142 BPM</a:t>
+            </a:r>
           </a:p>
           <a:p>
             <a:pPr marL="36000" indent="-252000" algn="ctr">
@@ -19996,7 +20910,11 @@
               <a:buNone/>
             </a:pPr>
             <a:r>
-              <a:rPr lang="pt-BR" sz="7200" dirty="0"/>
+              <a:rPr lang="pt-BR" sz="7200" dirty="0">
+                <a:solidFill>
+                  <a:srgbClr val="FFFFFF"/>
+                </a:solidFill>
+              </a:rPr>
               <a:t>A Festa É com Rota do Chopp </a:t>
             </a:r>
             <a:r>
@@ -20013,7 +20931,7 @@
     </p:spTree>
     <p:extLst>
       <p:ext uri="{BB962C8B-B14F-4D97-AF65-F5344CB8AC3E}">
-        <p14:creationId xmlns:p14="http://schemas.microsoft.com/office/powerpoint/2010/main" val="2048236007"/>
+        <p14:creationId xmlns:p14="http://schemas.microsoft.com/office/powerpoint/2010/main" val="426179831"/>
       </p:ext>
     </p:extLst>
   </p:cSld>
@@ -20083,6 +21001,15 @@
               </a:rPr>
               <a:t>VS BLOCO 34</a:t>
             </a:r>
+            <a:r>
+              <a:rPr lang="pt-BR" sz="4800" baseline="41667" dirty="0">
+                <a:solidFill>
+                  <a:srgbClr val="FFFFFF"/>
+                </a:solidFill>
+                <a:cs typeface="Arial" panose="020B0604020202020204" pitchFamily="34" charset="0"/>
+              </a:rPr>
+              <a:t>  137 BPM</a:t>
+            </a:r>
           </a:p>
           <a:p>
             <a:pPr marL="36000" indent="-252000" algn="ctr">
@@ -20095,7 +21022,11 @@
               <a:buNone/>
             </a:pPr>
             <a:r>
-              <a:rPr lang="pt-BR" sz="7200" dirty="0"/>
+              <a:rPr lang="pt-BR" sz="7200" dirty="0">
+                <a:solidFill>
+                  <a:srgbClr val="FFFFFF"/>
+                </a:solidFill>
+              </a:rPr>
               <a:t>Maratá </a:t>
             </a:r>
             <a:r>
@@ -20110,7 +21041,11 @@
               <a:rPr lang="pt-BR" sz="7200" dirty="0"/>
             </a:br>
             <a:r>
-              <a:rPr lang="pt-BR" sz="7200" dirty="0"/>
+              <a:rPr lang="pt-BR" sz="7200" dirty="0">
+                <a:solidFill>
+                  <a:srgbClr val="FFFFFF"/>
+                </a:solidFill>
+              </a:rPr>
               <a:t>Levanta a Poeira </a:t>
             </a:r>
             <a:r>
@@ -20125,7 +21060,11 @@
               <a:rPr lang="pt-BR" sz="7200" dirty="0"/>
             </a:br>
             <a:r>
-              <a:rPr lang="pt-BR" sz="7200" dirty="0"/>
+              <a:rPr lang="pt-BR" sz="7200" dirty="0">
+                <a:solidFill>
+                  <a:srgbClr val="FFFFFF"/>
+                </a:solidFill>
+              </a:rPr>
               <a:t>Polka do Fritz </a:t>
             </a:r>
             <a:r>
@@ -20142,7 +21081,7 @@
     </p:spTree>
     <p:extLst>
       <p:ext uri="{BB962C8B-B14F-4D97-AF65-F5344CB8AC3E}">
-        <p14:creationId xmlns:p14="http://schemas.microsoft.com/office/powerpoint/2010/main" val="2576813450"/>
+        <p14:creationId xmlns:p14="http://schemas.microsoft.com/office/powerpoint/2010/main" val="2623680955"/>
       </p:ext>
     </p:extLst>
   </p:cSld>
@@ -20212,6 +21151,15 @@
               </a:rPr>
               <a:t>VS BLOCO 35</a:t>
             </a:r>
+            <a:r>
+              <a:rPr lang="pt-BR" sz="4800" baseline="41667" dirty="0">
+                <a:solidFill>
+                  <a:srgbClr val="FFFFFF"/>
+                </a:solidFill>
+                <a:cs typeface="Arial" panose="020B0604020202020204" pitchFamily="34" charset="0"/>
+              </a:rPr>
+              <a:t>  176-190 BPM</a:t>
+            </a:r>
           </a:p>
           <a:p>
             <a:pPr marL="36000" indent="-252000" algn="ctr">
@@ -20224,7 +21172,11 @@
               <a:buNone/>
             </a:pPr>
             <a:r>
-              <a:rPr lang="pt-BR" sz="7200" dirty="0"/>
+              <a:rPr lang="pt-BR" sz="7200" dirty="0">
+                <a:solidFill>
+                  <a:srgbClr val="FFFFFF"/>
+                </a:solidFill>
+              </a:rPr>
               <a:t>Na Hora de Amar </a:t>
             </a:r>
             <a:r>
@@ -20239,7 +21191,11 @@
               <a:rPr lang="pt-BR" sz="7200" dirty="0"/>
             </a:br>
             <a:r>
-              <a:rPr lang="pt-BR" sz="7200" dirty="0"/>
+              <a:rPr lang="pt-BR" sz="7200" dirty="0">
+                <a:solidFill>
+                  <a:srgbClr val="FFFFFF"/>
+                </a:solidFill>
+              </a:rPr>
               <a:t>Página de Amigos </a:t>
             </a:r>
             <a:r>
@@ -20254,7 +21210,11 @@
               <a:rPr lang="pt-BR" sz="7200" dirty="0"/>
             </a:br>
             <a:r>
-              <a:rPr lang="pt-BR" sz="7200" dirty="0"/>
+              <a:rPr lang="pt-BR" sz="7200" dirty="0">
+                <a:solidFill>
+                  <a:srgbClr val="FFFFFF"/>
+                </a:solidFill>
+              </a:rPr>
               <a:t>Dormi na Praça </a:t>
             </a:r>
             <a:r>
@@ -20269,7 +21229,11 @@
               <a:rPr lang="pt-BR" sz="7200" dirty="0"/>
             </a:br>
             <a:r>
-              <a:rPr lang="pt-BR" sz="7200" dirty="0"/>
+              <a:rPr lang="pt-BR" sz="7200" dirty="0">
+                <a:solidFill>
+                  <a:srgbClr val="FFFFFF"/>
+                </a:solidFill>
+              </a:rPr>
               <a:t>Temporal de Amor </a:t>
             </a:r>
             <a:r>
@@ -20284,7 +21248,11 @@
               <a:rPr lang="pt-BR" sz="7200" dirty="0"/>
             </a:br>
             <a:r>
-              <a:rPr lang="pt-BR" sz="7200" dirty="0"/>
+              <a:rPr lang="pt-BR" sz="7200" dirty="0">
+                <a:solidFill>
+                  <a:srgbClr val="FFFFFF"/>
+                </a:solidFill>
+              </a:rPr>
               <a:t>Evidências </a:t>
             </a:r>
             <a:r>
@@ -20301,7 +21269,7 @@
     </p:spTree>
     <p:extLst>
       <p:ext uri="{BB962C8B-B14F-4D97-AF65-F5344CB8AC3E}">
-        <p14:creationId xmlns:p14="http://schemas.microsoft.com/office/powerpoint/2010/main" val="3575221592"/>
+        <p14:creationId xmlns:p14="http://schemas.microsoft.com/office/powerpoint/2010/main" val="1005451256"/>
       </p:ext>
     </p:extLst>
   </p:cSld>

</xml_diff>